<commit_message>
Place the Photo Korea preview photos in the ILCEC 2027 flyer
Seven KOGL type-1 photos from Photo Korea (Seoul skyline, Myeongdong,
Seoullo 7017, Geunjeongjeon, Banpo Bridge, Bukchon, Gyeonghoeru) now
fill the hero and photo slots in both the HTML/PDF flyer and the PPTX,
with photographer credits in the footer. The files are low-resolution
watermarked previews; the README explains how to swap in the originals
before printing.

Co-Authored-By: Claude Fable 5.1 <noreply@anthropic.com>
Claude-Session: https://claude.ai/code/session_0176bT1uqbE7ABLdKoQNCaUr
</commit_message>
<xml_diff>
--- a/ilcec2027/ILCEC_2027_First_Announcement_DRAFT.pptx
+++ b/ilcec2027/ILCEC_2027_First_Announcement_DRAFT.pptx
@@ -504,7 +504,7 @@
             <a:r>
               <a:rPr lang="en-US" dirty="0"/>
               <a:t>ILCEC 2027 First Announcement – FRONT page (draft).
-Replace every red [bracketed] item. Click the empty picture icons to insert photos (Photo Korea, phoko.visitkorea.or.kr, KOGL type 1, credit required). Right-click the top illustration → Change Picture to swap in a Seoul panorama. Delete the red DRAFT tag before release.</a:t>
+Replace every red [bracketed] item. Photos are Photo Korea preview files (low resolution, watermarked): right-click each photo → Change Picture and pick the original download before printing. Credits are in the footer. Delete the red DRAFT tag before release.</a:t>
             </a:r>
             <a:endParaRPr lang="en-US" dirty="0"/>
           </a:p>
@@ -941,7 +941,42 @@
         <p:spPr>
           <a:xfrm>
             <a:off x="429768" y="7818120"/>
-            <a:ext cx="3218688" cy="1280160"/>
+            <a:ext cx="1563624" cy="1280160"/>
+          </a:xfrm>
+          <a:prstGeom prst="rect">
+            <a:avLst/>
+          </a:prstGeom>
+          <a:noFill/>
+          <a:ln/>
+        </p:spPr>
+        <p:txBody>
+          <a:bodyPr wrap="square" rtlCol="0"/>
+          <a:lstStyle>
+            <a:lvl1pPr indent="0" marL="0">
+              <a:buNone/>
+              <a:defRPr lang="en-US" dirty="0"/>
+            </a:lvl1pPr>
+          </a:lstStyle>
+          <a:p>
+            <a:pPr indent="0" marL="0">
+              <a:buNone/>
+            </a:pPr>
+            <a:endParaRPr lang="en-US" dirty="0"/>
+          </a:p>
+        </p:txBody>
+      </p:sp>
+      <p:sp>
+        <p:nvSpPr>
+          <p:cNvPr id="4" name="Text 0"/>
+          <p:cNvSpPr/>
+          <p:nvPr>
+            <p:ph type="pic" idx="102" hasCustomPrompt="1"/>
+          </p:nvPr>
+        </p:nvSpPr>
+        <p:spPr>
+          <a:xfrm>
+            <a:off x="2084832" y="7818120"/>
+            <a:ext cx="1563624" cy="1280160"/>
           </a:xfrm>
           <a:prstGeom prst="rect">
             <a:avLst/>
@@ -1271,7 +1306,7 @@
       </p:grpSpPr>
       <p:pic>
         <p:nvPicPr>
-          <p:cNvPr id="2" name="Image 0" descr="/home/user/spel-website/ilcec2027/flyer/pptx/hero.png">    </p:cNvPr>
+          <p:cNvPr id="2" name="Image 0" descr="/home/user/spel-website/ilcec2027/flyer/pptx/photos/hero-front.jpg">    </p:cNvPr>
           <p:cNvPicPr>
             <a:picLocks noChangeAspect="1"/>
           </p:cNvPicPr>
@@ -2344,305 +2379,61 @@
           </a:p>
         </p:txBody>
       </p:sp>
-      <p:sp>
-        <p:nvSpPr>
-          <p:cNvPr id="23" name="Shape 18"/>
-          <p:cNvSpPr/>
-          <p:nvPr/>
-        </p:nvSpPr>
+      <p:pic>
+        <p:nvPicPr>
+          <p:cNvPr id="23" name="Image 3" descr="/home/user/spel-website/ilcec2027/flyer/pptx/photos/p-myeongdong.jpg">    </p:cNvPr>
+          <p:cNvPicPr>
+            <a:picLocks noChangeAspect="1"/>
+          </p:cNvPicPr>
+          <p:nvPr>
+            <p:ph type="pic" idx="101" hasCustomPrompt="1"/>
+          </p:nvPr>
+        </p:nvPicPr>
+        <p:blipFill>
+          <a:blip r:embed="rId4"/>
+          <a:stretch>
+            <a:fillRect/>
+          </a:stretch>
+        </p:blipFill>
         <p:spPr>
           <a:xfrm>
             <a:off x="429768" y="6967728"/>
             <a:ext cx="3218688" cy="1170432"/>
           </a:xfrm>
-          <a:prstGeom prst="roundRect">
-            <a:avLst>
-              <a:gd name="adj" fmla="val 4688"/>
-            </a:avLst>
-          </a:prstGeom>
-          <a:solidFill>
-            <a:srgbClr val="E3E6F4"/>
-          </a:solidFill>
-          <a:ln w="6350">
-            <a:solidFill>
-              <a:srgbClr val="CFD4EA"/>
-            </a:solidFill>
-            <a:prstDash val="dash"/>
-          </a:ln>
-        </p:spPr>
-      </p:sp>
-      <p:sp>
-        <p:nvSpPr>
-          <p:cNvPr id="24" name="Text 19"/>
-          <p:cNvSpPr txBox="1"/>
-          <p:nvPr/>
-        </p:nvSpPr>
-        <p:spPr>
-          <a:xfrm>
-            <a:off x="502920" y="6967728"/>
-            <a:ext cx="3072384" cy="1170432"/>
-          </a:xfrm>
-          <a:prstGeom prst="rect">
-            <a:avLst/>
-          </a:prstGeom>
-          <a:noFill/>
-          <a:ln/>
-        </p:spPr>
-        <p:txBody>
-          <a:bodyPr wrap="square" lIns="0" tIns="0" rIns="0" bIns="0" rtlCol="0" anchor="b"/>
-          <a:lstStyle/>
-          <a:p>
-            <a:pPr indent="0" marL="0">
-              <a:spcAft>
-                <a:spcPts val="100"/>
-              </a:spcAft>
-              <a:buNone/>
-            </a:pPr>
-            <a:r>
-              <a:rPr lang="en-US" sz="760" b="1" dirty="0">
-                <a:solidFill>
-                  <a:srgbClr val="1B2450"/>
-                </a:solidFill>
-                <a:latin typeface="Arial" pitchFamily="34" charset="0"/>
-                <a:ea typeface="Arial" pitchFamily="34" charset="-122"/>
-                <a:cs typeface="Arial" pitchFamily="34" charset="-120"/>
-              </a:rPr>
-              <a:t>Myeongdong at night</a:t>
-            </a:r>
-            <a:endParaRPr lang="en-US" sz="760" dirty="0"/>
-          </a:p>
-          <a:p>
-            <a:pPr indent="0" marL="0">
-              <a:spcAft>
-                <a:spcPts val="100"/>
-              </a:spcAft>
-              <a:buNone/>
-            </a:pPr>
-            <a:r>
-              <a:rPr lang="en-US" sz="640" dirty="0">
-                <a:solidFill>
-                  <a:srgbClr val="5B6079"/>
-                </a:solidFill>
-                <a:latin typeface="Arial" pitchFamily="34" charset="0"/>
-                <a:ea typeface="Arial" pitchFamily="34" charset="-122"/>
-                <a:cs typeface="Arial" pitchFamily="34" charset="-120"/>
-              </a:rPr>
-              <a:t>Street-level view of the Myeongdong shopping district, a short walk from the venue.</a:t>
-            </a:r>
-            <a:endParaRPr lang="en-US" sz="760" dirty="0"/>
-          </a:p>
-          <a:p>
-            <a:pPr indent="0" marL="0">
-              <a:spcAft>
-                <a:spcPts val="100"/>
-              </a:spcAft>
-              <a:buNone/>
-            </a:pPr>
-            <a:r>
-              <a:rPr lang="en-US" sz="620" b="1" dirty="0">
-                <a:solidFill>
-                  <a:srgbClr val="D8432F"/>
-                </a:solidFill>
-                <a:latin typeface="Arial" pitchFamily="34" charset="0"/>
-                <a:ea typeface="Arial" pitchFamily="34" charset="-122"/>
-                <a:cs typeface="Arial" pitchFamily="34" charset="-120"/>
-              </a:rPr>
-              <a:t>Photo Korea search: 명동 야경</a:t>
-            </a:r>
-            <a:endParaRPr lang="en-US" sz="760" dirty="0"/>
-          </a:p>
-        </p:txBody>
-      </p:sp>
-      <p:sp>
-        <p:nvSpPr>
-          <p:cNvPr id="25" name="Text 20"/>
-          <p:cNvSpPr txBox="1"/>
-          <p:nvPr/>
-        </p:nvSpPr>
-        <p:spPr>
-          <a:xfrm>
-            <a:off x="502920" y="7013448"/>
-            <a:ext cx="3072384" cy="164592"/>
-          </a:xfrm>
-          <a:prstGeom prst="rect">
-            <a:avLst/>
-          </a:prstGeom>
-          <a:noFill/>
-          <a:ln/>
-        </p:spPr>
-        <p:txBody>
-          <a:bodyPr wrap="square" lIns="0" tIns="0" rIns="0" bIns="0" rtlCol="0" anchor="t"/>
-          <a:lstStyle/>
-          <a:p>
-            <a:pPr indent="0" marL="0">
-              <a:buNone/>
-            </a:pPr>
-            <a:r>
-              <a:rPr lang="en-US" sz="600" i="1" dirty="0">
-                <a:solidFill>
-                  <a:srgbClr val="5B6079"/>
-                </a:solidFill>
-                <a:latin typeface="Arial" pitchFamily="34" charset="0"/>
-                <a:ea typeface="Arial" pitchFamily="34" charset="-122"/>
-                <a:cs typeface="Arial" pitchFamily="34" charset="-120"/>
-              </a:rPr>
-              <a:t>Click the picture icon to insert a photo</a:t>
-            </a:r>
-            <a:endParaRPr lang="en-US" sz="600" dirty="0"/>
-          </a:p>
-        </p:txBody>
-      </p:sp>
-      <p:sp>
-        <p:nvSpPr>
-          <p:cNvPr id="26" name="Shape 21"/>
-          <p:cNvSpPr/>
-          <p:nvPr/>
-        </p:nvSpPr>
+          <a:prstGeom prst="rect">
+            <a:avLst/>
+          </a:prstGeom>
+        </p:spPr>
+      </p:pic>
+      <p:pic>
+        <p:nvPicPr>
+          <p:cNvPr id="24" name="Image 4" descr="/home/user/spel-website/ilcec2027/flyer/pptx/photos/p-seoullo.jpg">    </p:cNvPr>
+          <p:cNvPicPr>
+            <a:picLocks noChangeAspect="1"/>
+          </p:cNvPicPr>
+          <p:nvPr>
+            <p:ph type="pic" idx="102" hasCustomPrompt="1"/>
+          </p:nvPr>
+        </p:nvPicPr>
+        <p:blipFill>
+          <a:blip r:embed="rId5"/>
+          <a:stretch>
+            <a:fillRect/>
+          </a:stretch>
+        </p:blipFill>
         <p:spPr>
           <a:xfrm>
             <a:off x="429768" y="8211312"/>
             <a:ext cx="3218688" cy="877824"/>
           </a:xfrm>
-          <a:prstGeom prst="roundRect">
-            <a:avLst>
-              <a:gd name="adj" fmla="val 6250"/>
-            </a:avLst>
-          </a:prstGeom>
-          <a:solidFill>
-            <a:srgbClr val="E3E6F4"/>
-          </a:solidFill>
-          <a:ln w="6350">
-            <a:solidFill>
-              <a:srgbClr val="CFD4EA"/>
-            </a:solidFill>
-            <a:prstDash val="dash"/>
-          </a:ln>
-        </p:spPr>
-      </p:sp>
-      <p:sp>
-        <p:nvSpPr>
-          <p:cNvPr id="27" name="Text 22"/>
-          <p:cNvSpPr txBox="1"/>
-          <p:nvPr/>
-        </p:nvSpPr>
-        <p:spPr>
-          <a:xfrm>
-            <a:off x="502920" y="8211312"/>
-            <a:ext cx="3072384" cy="877824"/>
-          </a:xfrm>
-          <a:prstGeom prst="rect">
-            <a:avLst/>
-          </a:prstGeom>
-          <a:noFill/>
-          <a:ln/>
-        </p:spPr>
-        <p:txBody>
-          <a:bodyPr wrap="square" lIns="0" tIns="0" rIns="0" bIns="0" rtlCol="0" anchor="b"/>
-          <a:lstStyle/>
-          <a:p>
-            <a:pPr indent="0" marL="0">
-              <a:spcAft>
-                <a:spcPts val="100"/>
-              </a:spcAft>
-              <a:buNone/>
-            </a:pPr>
-            <a:r>
-              <a:rPr lang="en-US" sz="760" b="1" dirty="0">
-                <a:solidFill>
-                  <a:srgbClr val="1B2450"/>
-                </a:solidFill>
-                <a:latin typeface="Arial" pitchFamily="34" charset="0"/>
-                <a:ea typeface="Arial" pitchFamily="34" charset="-122"/>
-                <a:cs typeface="Arial" pitchFamily="34" charset="-120"/>
-              </a:rPr>
-              <a:t>Namsan &amp; N Seoul Tower</a:t>
-            </a:r>
-            <a:endParaRPr lang="en-US" sz="760" dirty="0"/>
-          </a:p>
-          <a:p>
-            <a:pPr indent="0" marL="0">
-              <a:spcAft>
-                <a:spcPts val="100"/>
-              </a:spcAft>
-              <a:buNone/>
-            </a:pPr>
-            <a:r>
-              <a:rPr lang="en-US" sz="640" dirty="0">
-                <a:solidFill>
-                  <a:srgbClr val="5B6079"/>
-                </a:solidFill>
-                <a:latin typeface="Arial" pitchFamily="34" charset="0"/>
-                <a:ea typeface="Arial" pitchFamily="34" charset="-122"/>
-                <a:cs typeface="Arial" pitchFamily="34" charset="-120"/>
-              </a:rPr>
-              <a:t>City view from Namsan, 20 min on foot or by cable car from Myeongdong.</a:t>
-            </a:r>
-            <a:endParaRPr lang="en-US" sz="760" dirty="0"/>
-          </a:p>
-          <a:p>
-            <a:pPr indent="0" marL="0">
-              <a:spcAft>
-                <a:spcPts val="100"/>
-              </a:spcAft>
-              <a:buNone/>
-            </a:pPr>
-            <a:r>
-              <a:rPr lang="en-US" sz="620" b="1" dirty="0">
-                <a:solidFill>
-                  <a:srgbClr val="D8432F"/>
-                </a:solidFill>
-                <a:latin typeface="Arial" pitchFamily="34" charset="0"/>
-                <a:ea typeface="Arial" pitchFamily="34" charset="-122"/>
-                <a:cs typeface="Arial" pitchFamily="34" charset="-120"/>
-              </a:rPr>
-              <a:t>Search: 남산 서울타워 야경</a:t>
-            </a:r>
-            <a:endParaRPr lang="en-US" sz="760" dirty="0"/>
-          </a:p>
-        </p:txBody>
-      </p:sp>
-      <p:sp>
-        <p:nvSpPr>
-          <p:cNvPr id="28" name="Text 23"/>
-          <p:cNvSpPr txBox="1"/>
-          <p:nvPr/>
-        </p:nvSpPr>
-        <p:spPr>
-          <a:xfrm>
-            <a:off x="502920" y="8257032"/>
-            <a:ext cx="3072384" cy="164592"/>
-          </a:xfrm>
-          <a:prstGeom prst="rect">
-            <a:avLst/>
-          </a:prstGeom>
-          <a:noFill/>
-          <a:ln/>
-        </p:spPr>
-        <p:txBody>
-          <a:bodyPr wrap="square" lIns="0" tIns="0" rIns="0" bIns="0" rtlCol="0" anchor="t"/>
-          <a:lstStyle/>
-          <a:p>
-            <a:pPr indent="0" marL="0">
-              <a:buNone/>
-            </a:pPr>
-            <a:r>
-              <a:rPr lang="en-US" sz="600" i="1" dirty="0">
-                <a:solidFill>
-                  <a:srgbClr val="5B6079"/>
-                </a:solidFill>
-                <a:latin typeface="Arial" pitchFamily="34" charset="0"/>
-                <a:ea typeface="Arial" pitchFamily="34" charset="-122"/>
-                <a:cs typeface="Arial" pitchFamily="34" charset="-120"/>
-              </a:rPr>
-              <a:t>Click the picture icon to insert a photo</a:t>
-            </a:r>
-            <a:endParaRPr lang="en-US" sz="600" dirty="0"/>
-          </a:p>
-        </p:txBody>
-      </p:sp>
-      <p:sp>
-        <p:nvSpPr>
-          <p:cNvPr id="29" name="Text 24"/>
+          <a:prstGeom prst="rect">
+            <a:avLst/>
+          </a:prstGeom>
+        </p:spPr>
+      </p:pic>
+      <p:sp>
+        <p:nvSpPr>
+          <p:cNvPr id="25" name="Text 18"/>
           <p:cNvSpPr txBox="1"/>
           <p:nvPr/>
         </p:nvSpPr>
@@ -2681,7 +2472,7 @@
       </p:sp>
       <p:sp>
         <p:nvSpPr>
-          <p:cNvPr id="30" name="Text 25"/>
+          <p:cNvPr id="26" name="Text 19"/>
           <p:cNvSpPr txBox="1"/>
           <p:nvPr/>
         </p:nvSpPr>
@@ -2757,7 +2548,7 @@
       </p:sp>
       <p:sp>
         <p:nvSpPr>
-          <p:cNvPr id="31" name="Text 26"/>
+          <p:cNvPr id="27" name="Text 20"/>
           <p:cNvSpPr txBox="1"/>
           <p:nvPr/>
         </p:nvSpPr>
@@ -2796,7 +2587,7 @@
       </p:sp>
       <p:sp>
         <p:nvSpPr>
-          <p:cNvPr id="32" name="Text 27"/>
+          <p:cNvPr id="28" name="Text 21"/>
           <p:cNvSpPr txBox="1"/>
           <p:nvPr/>
         </p:nvSpPr>
@@ -2838,7 +2629,7 @@
       </p:sp>
       <p:sp>
         <p:nvSpPr>
-          <p:cNvPr id="33" name="Text 28"/>
+          <p:cNvPr id="29" name="Text 22"/>
           <p:cNvSpPr txBox="1"/>
           <p:nvPr/>
         </p:nvSpPr>
@@ -2877,7 +2668,7 @@
       </p:sp>
       <p:sp>
         <p:nvSpPr>
-          <p:cNvPr id="34" name="Text 29"/>
+          <p:cNvPr id="30" name="Text 23"/>
           <p:cNvSpPr txBox="1"/>
           <p:nvPr/>
         </p:nvSpPr>
@@ -2919,7 +2710,7 @@
       </p:sp>
       <p:sp>
         <p:nvSpPr>
-          <p:cNvPr id="35" name="Text 30"/>
+          <p:cNvPr id="31" name="Text 24"/>
           <p:cNvSpPr txBox="1"/>
           <p:nvPr/>
         </p:nvSpPr>
@@ -2972,7 +2763,7 @@
       </p:sp>
       <p:sp>
         <p:nvSpPr>
-          <p:cNvPr id="36" name="Text 31"/>
+          <p:cNvPr id="32" name="Text 25"/>
           <p:cNvSpPr txBox="1"/>
           <p:nvPr/>
         </p:nvSpPr>
@@ -3232,305 +3023,61 @@
           </a:p>
         </p:txBody>
       </p:sp>
-      <p:sp>
-        <p:nvSpPr>
-          <p:cNvPr id="37" name="Shape 32"/>
-          <p:cNvSpPr/>
-          <p:nvPr/>
-        </p:nvSpPr>
+      <p:pic>
+        <p:nvPicPr>
+          <p:cNvPr id="33" name="Image 5" descr="/home/user/spel-website/ilcec2027/flyer/pptx/photos/p-gyeongbokgung.jpg">    </p:cNvPr>
+          <p:cNvPicPr>
+            <a:picLocks noChangeAspect="1"/>
+          </p:cNvPicPr>
+          <p:nvPr>
+            <p:ph type="pic" idx="103" hasCustomPrompt="1"/>
+          </p:nvPr>
+        </p:nvPicPr>
+        <p:blipFill>
+          <a:blip r:embed="rId6"/>
+          <a:stretch>
+            <a:fillRect/>
+          </a:stretch>
+        </p:blipFill>
         <p:spPr>
           <a:xfrm>
             <a:off x="3913632" y="8394192"/>
             <a:ext cx="1563624" cy="694944"/>
           </a:xfrm>
-          <a:prstGeom prst="roundRect">
-            <a:avLst>
-              <a:gd name="adj" fmla="val 7895"/>
-            </a:avLst>
-          </a:prstGeom>
-          <a:solidFill>
-            <a:srgbClr val="E3E6F4"/>
-          </a:solidFill>
-          <a:ln w="6350">
-            <a:solidFill>
-              <a:srgbClr val="CFD4EA"/>
-            </a:solidFill>
-            <a:prstDash val="dash"/>
-          </a:ln>
-        </p:spPr>
-      </p:sp>
-      <p:sp>
-        <p:nvSpPr>
-          <p:cNvPr id="38" name="Text 33"/>
-          <p:cNvSpPr txBox="1"/>
-          <p:nvPr/>
-        </p:nvSpPr>
-        <p:spPr>
-          <a:xfrm>
-            <a:off x="3986784" y="8394192"/>
-            <a:ext cx="1417320" cy="694944"/>
-          </a:xfrm>
-          <a:prstGeom prst="rect">
-            <a:avLst/>
-          </a:prstGeom>
-          <a:noFill/>
-          <a:ln/>
-        </p:spPr>
-        <p:txBody>
-          <a:bodyPr wrap="square" lIns="0" tIns="0" rIns="0" bIns="0" rtlCol="0" anchor="b"/>
-          <a:lstStyle/>
-          <a:p>
-            <a:pPr indent="0" marL="0">
-              <a:spcAft>
-                <a:spcPts val="100"/>
-              </a:spcAft>
-              <a:buNone/>
-            </a:pPr>
-            <a:r>
-              <a:rPr lang="en-US" sz="760" b="1" dirty="0">
-                <a:solidFill>
-                  <a:srgbClr val="1B2450"/>
-                </a:solidFill>
-                <a:latin typeface="Arial" pitchFamily="34" charset="0"/>
-                <a:ea typeface="Arial" pitchFamily="34" charset="-122"/>
-                <a:cs typeface="Arial" pitchFamily="34" charset="-120"/>
-              </a:rPr>
-              <a:t>Gyeongbokgung Palace</a:t>
-            </a:r>
-            <a:endParaRPr lang="en-US" sz="760" dirty="0"/>
-          </a:p>
-          <a:p>
-            <a:pPr indent="0" marL="0">
-              <a:spcAft>
-                <a:spcPts val="100"/>
-              </a:spcAft>
-              <a:buNone/>
-            </a:pPr>
-            <a:r>
-              <a:rPr lang="en-US" sz="640" dirty="0">
-                <a:solidFill>
-                  <a:srgbClr val="5B6079"/>
-                </a:solidFill>
-                <a:latin typeface="Arial" pitchFamily="34" charset="0"/>
-                <a:ea typeface="Arial" pitchFamily="34" charset="-122"/>
-                <a:cs typeface="Arial" pitchFamily="34" charset="-120"/>
-              </a:rPr>
-              <a:t>Royal palace, 15 min from Myeongdong.</a:t>
-            </a:r>
-            <a:endParaRPr lang="en-US" sz="760" dirty="0"/>
-          </a:p>
-          <a:p>
-            <a:pPr indent="0" marL="0">
-              <a:spcAft>
-                <a:spcPts val="100"/>
-              </a:spcAft>
-              <a:buNone/>
-            </a:pPr>
-            <a:r>
-              <a:rPr lang="en-US" sz="620" b="1" dirty="0">
-                <a:solidFill>
-                  <a:srgbClr val="D8432F"/>
-                </a:solidFill>
-                <a:latin typeface="Arial" pitchFamily="34" charset="0"/>
-                <a:ea typeface="Arial" pitchFamily="34" charset="-122"/>
-                <a:cs typeface="Arial" pitchFamily="34" charset="-120"/>
-              </a:rPr>
-              <a:t>Search: 경복궁 근정전</a:t>
-            </a:r>
-            <a:endParaRPr lang="en-US" sz="760" dirty="0"/>
-          </a:p>
-        </p:txBody>
-      </p:sp>
-      <p:sp>
-        <p:nvSpPr>
-          <p:cNvPr id="39" name="Text 34"/>
-          <p:cNvSpPr txBox="1"/>
-          <p:nvPr/>
-        </p:nvSpPr>
-        <p:spPr>
-          <a:xfrm>
-            <a:off x="3986784" y="8439912"/>
-            <a:ext cx="1417320" cy="164592"/>
-          </a:xfrm>
-          <a:prstGeom prst="rect">
-            <a:avLst/>
-          </a:prstGeom>
-          <a:noFill/>
-          <a:ln/>
-        </p:spPr>
-        <p:txBody>
-          <a:bodyPr wrap="square" lIns="0" tIns="0" rIns="0" bIns="0" rtlCol="0" anchor="t"/>
-          <a:lstStyle/>
-          <a:p>
-            <a:pPr indent="0" marL="0">
-              <a:buNone/>
-            </a:pPr>
-            <a:r>
-              <a:rPr lang="en-US" sz="600" i="1" dirty="0">
-                <a:solidFill>
-                  <a:srgbClr val="5B6079"/>
-                </a:solidFill>
-                <a:latin typeface="Arial" pitchFamily="34" charset="0"/>
-                <a:ea typeface="Arial" pitchFamily="34" charset="-122"/>
-                <a:cs typeface="Arial" pitchFamily="34" charset="-120"/>
-              </a:rPr>
-              <a:t>Click the picture icon to insert a photo</a:t>
-            </a:r>
-            <a:endParaRPr lang="en-US" sz="600" dirty="0"/>
-          </a:p>
-        </p:txBody>
-      </p:sp>
-      <p:sp>
-        <p:nvSpPr>
-          <p:cNvPr id="40" name="Shape 35"/>
-          <p:cNvSpPr/>
-          <p:nvPr/>
-        </p:nvSpPr>
+          <a:prstGeom prst="rect">
+            <a:avLst/>
+          </a:prstGeom>
+        </p:spPr>
+      </p:pic>
+      <p:pic>
+        <p:nvPicPr>
+          <p:cNvPr id="34" name="Image 6" descr="/home/user/spel-website/ilcec2027/flyer/pptx/photos/p-hangang.jpg">    </p:cNvPr>
+          <p:cNvPicPr>
+            <a:picLocks noChangeAspect="1"/>
+          </p:cNvPicPr>
+          <p:nvPr>
+            <p:ph idx="104" hasCustomPrompt="1"/>
+          </p:nvPr>
+        </p:nvPicPr>
+        <p:blipFill>
+          <a:blip r:embed="rId7"/>
+          <a:stretch>
+            <a:fillRect/>
+          </a:stretch>
+        </p:blipFill>
         <p:spPr>
           <a:xfrm>
             <a:off x="5568696" y="8394192"/>
             <a:ext cx="1563624" cy="694944"/>
           </a:xfrm>
-          <a:prstGeom prst="roundRect">
-            <a:avLst>
-              <a:gd name="adj" fmla="val 7895"/>
-            </a:avLst>
-          </a:prstGeom>
-          <a:solidFill>
-            <a:srgbClr val="E3E6F4"/>
-          </a:solidFill>
-          <a:ln w="6350">
-            <a:solidFill>
-              <a:srgbClr val="CFD4EA"/>
-            </a:solidFill>
-            <a:prstDash val="dash"/>
-          </a:ln>
-        </p:spPr>
-      </p:sp>
-      <p:sp>
-        <p:nvSpPr>
-          <p:cNvPr id="41" name="Text 36"/>
-          <p:cNvSpPr txBox="1"/>
-          <p:nvPr/>
-        </p:nvSpPr>
-        <p:spPr>
-          <a:xfrm>
-            <a:off x="5641848" y="8394192"/>
-            <a:ext cx="1417320" cy="694944"/>
-          </a:xfrm>
-          <a:prstGeom prst="rect">
-            <a:avLst/>
-          </a:prstGeom>
-          <a:noFill/>
-          <a:ln/>
-        </p:spPr>
-        <p:txBody>
-          <a:bodyPr wrap="square" lIns="0" tIns="0" rIns="0" bIns="0" rtlCol="0" anchor="b"/>
-          <a:lstStyle/>
-          <a:p>
-            <a:pPr indent="0" marL="0">
-              <a:spcAft>
-                <a:spcPts val="100"/>
-              </a:spcAft>
-              <a:buNone/>
-            </a:pPr>
-            <a:r>
-              <a:rPr lang="en-US" sz="760" b="1" dirty="0">
-                <a:solidFill>
-                  <a:srgbClr val="1B2450"/>
-                </a:solidFill>
-                <a:latin typeface="Arial" pitchFamily="34" charset="0"/>
-                <a:ea typeface="Arial" pitchFamily="34" charset="-122"/>
-                <a:cs typeface="Arial" pitchFamily="34" charset="-120"/>
-              </a:rPr>
-              <a:t>Han River at dusk</a:t>
-            </a:r>
-            <a:endParaRPr lang="en-US" sz="760" dirty="0"/>
-          </a:p>
-          <a:p>
-            <a:pPr indent="0" marL="0">
-              <a:spcAft>
-                <a:spcPts val="100"/>
-              </a:spcAft>
-              <a:buNone/>
-            </a:pPr>
-            <a:r>
-              <a:rPr lang="en-US" sz="640" dirty="0">
-                <a:solidFill>
-                  <a:srgbClr val="5B6079"/>
-                </a:solidFill>
-                <a:latin typeface="Arial" pitchFamily="34" charset="0"/>
-                <a:ea typeface="Arial" pitchFamily="34" charset="-122"/>
-                <a:cs typeface="Arial" pitchFamily="34" charset="-120"/>
-              </a:rPr>
-              <a:t>Banpo Bridge fountain / river cruise.</a:t>
-            </a:r>
-            <a:endParaRPr lang="en-US" sz="760" dirty="0"/>
-          </a:p>
-          <a:p>
-            <a:pPr indent="0" marL="0">
-              <a:spcAft>
-                <a:spcPts val="100"/>
-              </a:spcAft>
-              <a:buNone/>
-            </a:pPr>
-            <a:r>
-              <a:rPr lang="en-US" sz="620" b="1" dirty="0">
-                <a:solidFill>
-                  <a:srgbClr val="D8432F"/>
-                </a:solidFill>
-                <a:latin typeface="Arial" pitchFamily="34" charset="0"/>
-                <a:ea typeface="Arial" pitchFamily="34" charset="-122"/>
-                <a:cs typeface="Arial" pitchFamily="34" charset="-120"/>
-              </a:rPr>
-              <a:t>Search: 한강 반포대교 야경</a:t>
-            </a:r>
-            <a:endParaRPr lang="en-US" sz="760" dirty="0"/>
-          </a:p>
-        </p:txBody>
-      </p:sp>
-      <p:sp>
-        <p:nvSpPr>
-          <p:cNvPr id="42" name="Text 37"/>
-          <p:cNvSpPr txBox="1"/>
-          <p:nvPr/>
-        </p:nvSpPr>
-        <p:spPr>
-          <a:xfrm>
-            <a:off x="5641848" y="8439912"/>
-            <a:ext cx="1417320" cy="164592"/>
-          </a:xfrm>
-          <a:prstGeom prst="rect">
-            <a:avLst/>
-          </a:prstGeom>
-          <a:noFill/>
-          <a:ln/>
-        </p:spPr>
-        <p:txBody>
-          <a:bodyPr wrap="square" lIns="0" tIns="0" rIns="0" bIns="0" rtlCol="0" anchor="t"/>
-          <a:lstStyle/>
-          <a:p>
-            <a:pPr indent="0" marL="0">
-              <a:buNone/>
-            </a:pPr>
-            <a:r>
-              <a:rPr lang="en-US" sz="600" i="1" dirty="0">
-                <a:solidFill>
-                  <a:srgbClr val="5B6079"/>
-                </a:solidFill>
-                <a:latin typeface="Arial" pitchFamily="34" charset="0"/>
-                <a:ea typeface="Arial" pitchFamily="34" charset="-122"/>
-                <a:cs typeface="Arial" pitchFamily="34" charset="-120"/>
-              </a:rPr>
-              <a:t>Click the picture icon to insert a photo</a:t>
-            </a:r>
-            <a:endParaRPr lang="en-US" sz="600" dirty="0"/>
-          </a:p>
-        </p:txBody>
-      </p:sp>
-      <p:sp>
-        <p:nvSpPr>
-          <p:cNvPr id="43" name="Shape 38"/>
+          <a:prstGeom prst="rect">
+            <a:avLst/>
+          </a:prstGeom>
+        </p:spPr>
+      </p:pic>
+      <p:sp>
+        <p:nvSpPr>
+          <p:cNvPr id="35" name="Shape 26"/>
           <p:cNvSpPr/>
           <p:nvPr/>
         </p:nvSpPr>
@@ -3553,7 +3100,7 @@
       </p:sp>
       <p:sp>
         <p:nvSpPr>
-          <p:cNvPr id="44" name="Shape 39"/>
+          <p:cNvPr id="36" name="Shape 27"/>
           <p:cNvSpPr/>
           <p:nvPr/>
         </p:nvSpPr>
@@ -3580,7 +3127,7 @@
       </p:sp>
       <p:sp>
         <p:nvSpPr>
-          <p:cNvPr id="45" name="Text 40"/>
+          <p:cNvPr id="37" name="Text 28"/>
           <p:cNvSpPr txBox="1"/>
           <p:nvPr/>
         </p:nvSpPr>
@@ -3619,7 +3166,7 @@
       </p:sp>
       <p:sp>
         <p:nvSpPr>
-          <p:cNvPr id="46" name="Shape 41"/>
+          <p:cNvPr id="38" name="Shape 29"/>
           <p:cNvSpPr/>
           <p:nvPr/>
         </p:nvSpPr>
@@ -3646,7 +3193,7 @@
       </p:sp>
       <p:sp>
         <p:nvSpPr>
-          <p:cNvPr id="47" name="Text 42"/>
+          <p:cNvPr id="39" name="Text 30"/>
           <p:cNvSpPr txBox="1"/>
           <p:nvPr/>
         </p:nvSpPr>
@@ -3685,7 +3232,7 @@
       </p:sp>
       <p:sp>
         <p:nvSpPr>
-          <p:cNvPr id="48" name="Shape 43"/>
+          <p:cNvPr id="40" name="Shape 31"/>
           <p:cNvSpPr/>
           <p:nvPr/>
         </p:nvSpPr>
@@ -3712,7 +3259,7 @@
       </p:sp>
       <p:sp>
         <p:nvSpPr>
-          <p:cNvPr id="49" name="Text 44"/>
+          <p:cNvPr id="41" name="Text 32"/>
           <p:cNvSpPr txBox="1"/>
           <p:nvPr/>
         </p:nvSpPr>
@@ -3751,7 +3298,7 @@
       </p:sp>
       <p:sp>
         <p:nvSpPr>
-          <p:cNvPr id="50" name="Text 45"/>
+          <p:cNvPr id="42" name="Text 33"/>
           <p:cNvSpPr txBox="1"/>
           <p:nvPr/>
         </p:nvSpPr>
@@ -3782,7 +3329,7 @@
                 <a:ea typeface="Arial" pitchFamily="34" charset="-122"/>
                 <a:cs typeface="Arial" pitchFamily="34" charset="-120"/>
               </a:rPr>
-              <a:t>Photo credits: </a:t>
+              <a:t>Photos: </a:t>
             </a:r>
             <a:pPr algn="r" indent="0" marL="0">
               <a:buNone/>
@@ -3796,7 +3343,7 @@
                 <a:ea typeface="Arial" pitchFamily="34" charset="-122"/>
                 <a:cs typeface="Arial" pitchFamily="34" charset="-120"/>
               </a:rPr>
-              <a:t>© Korea Tourism Organization Photo Korea – photographer name (fill in when images are inserted).</a:t>
+              <a:t>© Korea Tourism Organization (Photo Korea) – 조한섭, 한국관광공사 카멜프레스, 안형록, 임귀빈, 임태원, 이재국, IR 스튜디오. KOGL Type 1.</a:t>
             </a:r>
             <a:endParaRPr lang="en-US" sz="610" dirty="0"/>
           </a:p>
@@ -3813,129 +3360,9 @@
                 <a:ea typeface="Arial" pitchFamily="34" charset="-122"/>
                 <a:cs typeface="Arial" pitchFamily="34" charset="-120"/>
               </a:rPr>
-              <a:t>Skyline illustration: ILCEC 2027 organizing committee.</a:t>
+              <a:t>Typefaces: Arial. Replace the low-resolution preview photos with the original downloads before printing.</a:t>
             </a:r>
             <a:endParaRPr lang="en-US" sz="610" dirty="0"/>
-          </a:p>
-        </p:txBody>
-      </p:sp>
-      <p:sp>
-        <p:nvSpPr>
-          <p:cNvPr id="52" name="Text 0"/>
-          <p:cNvSpPr/>
-          <p:nvPr>
-            <p:ph type="pic" idx="101" hasCustomPrompt="1"/>
-          </p:nvPr>
-        </p:nvSpPr>
-        <p:spPr>
-          <a:xfrm>
-            <a:off x="429768" y="6967728"/>
-            <a:ext cx="3218688" cy="1170432"/>
-          </a:xfrm>
-          <a:prstGeom prst="rect">
-            <a:avLst/>
-          </a:prstGeom>
-          <a:noFill/>
-          <a:ln/>
-        </p:spPr>
-        <p:txBody>
-          <a:bodyPr wrap="square" rtlCol="0"/>
-          <a:lstStyle/>
-          <a:p>
-            <a:pPr indent="0" marL="0">
-              <a:buNone/>
-            </a:pPr>
-            <a:endParaRPr lang="en-US" dirty="0"/>
-          </a:p>
-        </p:txBody>
-      </p:sp>
-      <p:sp>
-        <p:nvSpPr>
-          <p:cNvPr id="53" name="Text 0"/>
-          <p:cNvSpPr/>
-          <p:nvPr>
-            <p:ph type="pic" idx="102" hasCustomPrompt="1"/>
-          </p:nvPr>
-        </p:nvSpPr>
-        <p:spPr>
-          <a:xfrm>
-            <a:off x="429768" y="8211312"/>
-            <a:ext cx="3218688" cy="877824"/>
-          </a:xfrm>
-          <a:prstGeom prst="rect">
-            <a:avLst/>
-          </a:prstGeom>
-          <a:noFill/>
-          <a:ln/>
-        </p:spPr>
-        <p:txBody>
-          <a:bodyPr wrap="square" rtlCol="0"/>
-          <a:lstStyle/>
-          <a:p>
-            <a:pPr indent="0" marL="0">
-              <a:buNone/>
-            </a:pPr>
-            <a:endParaRPr lang="en-US" dirty="0"/>
-          </a:p>
-        </p:txBody>
-      </p:sp>
-      <p:sp>
-        <p:nvSpPr>
-          <p:cNvPr id="54" name="Text 0"/>
-          <p:cNvSpPr/>
-          <p:nvPr>
-            <p:ph type="pic" idx="103" hasCustomPrompt="1"/>
-          </p:nvPr>
-        </p:nvSpPr>
-        <p:spPr>
-          <a:xfrm>
-            <a:off x="3913632" y="8394192"/>
-            <a:ext cx="1563624" cy="694944"/>
-          </a:xfrm>
-          <a:prstGeom prst="rect">
-            <a:avLst/>
-          </a:prstGeom>
-          <a:noFill/>
-          <a:ln/>
-        </p:spPr>
-        <p:txBody>
-          <a:bodyPr wrap="square" rtlCol="0"/>
-          <a:lstStyle/>
-          <a:p>
-            <a:pPr indent="0" marL="0">
-              <a:buNone/>
-            </a:pPr>
-            <a:endParaRPr lang="en-US" dirty="0"/>
-          </a:p>
-        </p:txBody>
-      </p:sp>
-      <p:sp>
-        <p:nvSpPr>
-          <p:cNvPr id="55" name="Text 0"/>
-          <p:cNvSpPr/>
-          <p:nvPr>
-            <p:ph idx="104" hasCustomPrompt="1"/>
-          </p:nvPr>
-        </p:nvSpPr>
-        <p:spPr>
-          <a:xfrm>
-            <a:off x="5568696" y="8394192"/>
-            <a:ext cx="1563624" cy="694944"/>
-          </a:xfrm>
-          <a:prstGeom prst="rect">
-            <a:avLst/>
-          </a:prstGeom>
-          <a:noFill/>
-          <a:ln/>
-        </p:spPr>
-        <p:txBody>
-          <a:bodyPr wrap="square" rtlCol="0"/>
-          <a:lstStyle/>
-          <a:p>
-            <a:pPr indent="0" marL="0">
-              <a:buNone/>
-            </a:pPr>
-            <a:endParaRPr lang="en-US" dirty="0"/>
           </a:p>
         </p:txBody>
       </p:sp>
@@ -3966,7 +3393,7 @@
       </p:grpSpPr>
       <p:pic>
         <p:nvPicPr>
-          <p:cNvPr id="2" name="Image 0" descr="/home/user/spel-website/ilcec2027/flyer/pptx/hero.png">    </p:cNvPr>
+          <p:cNvPr id="2" name="Image 0" descr="/home/user/spel-website/ilcec2027/flyer/pptx/photos/hero-back.jpg">    </p:cNvPr>
           <p:cNvPicPr>
             <a:picLocks noChangeAspect="1"/>
           </p:cNvPicPr>
@@ -5395,157 +4822,61 @@
           </a:p>
         </p:txBody>
       </p:sp>
-      <p:sp>
-        <p:nvSpPr>
-          <p:cNvPr id="20" name="Shape 15"/>
-          <p:cNvSpPr/>
-          <p:nvPr/>
-        </p:nvSpPr>
+      <p:pic>
+        <p:nvPicPr>
+          <p:cNvPr id="20" name="Image 3" descr="/home/user/spel-website/ilcec2027/flyer/pptx/photos/p-bukchon.jpg">    </p:cNvPr>
+          <p:cNvPicPr>
+            <a:picLocks noChangeAspect="1"/>
+          </p:cNvPicPr>
+          <p:nvPr>
+            <p:ph type="pic" idx="101" hasCustomPrompt="1"/>
+          </p:nvPr>
+        </p:nvPicPr>
+        <p:blipFill>
+          <a:blip r:embed="rId4"/>
+          <a:stretch>
+            <a:fillRect/>
+          </a:stretch>
+        </p:blipFill>
         <p:spPr>
           <a:xfrm>
             <a:off x="429768" y="7818120"/>
-            <a:ext cx="3218688" cy="1280160"/>
-          </a:xfrm>
-          <a:prstGeom prst="roundRect">
-            <a:avLst>
-              <a:gd name="adj" fmla="val 4286"/>
-            </a:avLst>
-          </a:prstGeom>
-          <a:solidFill>
-            <a:srgbClr val="E3E6F4"/>
-          </a:solidFill>
-          <a:ln w="6350">
-            <a:solidFill>
-              <a:srgbClr val="CFD4EA"/>
-            </a:solidFill>
-            <a:prstDash val="dash"/>
-          </a:ln>
-        </p:spPr>
-      </p:sp>
-      <p:sp>
-        <p:nvSpPr>
-          <p:cNvPr id="21" name="Text 16"/>
-          <p:cNvSpPr txBox="1"/>
-          <p:nvPr/>
-        </p:nvSpPr>
-        <p:spPr>
-          <a:xfrm>
-            <a:off x="502920" y="7818120"/>
-            <a:ext cx="3072384" cy="1280160"/>
-          </a:xfrm>
-          <a:prstGeom prst="rect">
-            <a:avLst/>
-          </a:prstGeom>
-          <a:noFill/>
-          <a:ln/>
-        </p:spPr>
-        <p:txBody>
-          <a:bodyPr wrap="square" lIns="0" tIns="0" rIns="0" bIns="0" rtlCol="0" anchor="b"/>
-          <a:lstStyle/>
-          <a:p>
-            <a:pPr indent="0" marL="0">
-              <a:spcAft>
-                <a:spcPts val="100"/>
-              </a:spcAft>
-              <a:buNone/>
-            </a:pPr>
-            <a:r>
-              <a:rPr lang="en-US" sz="760" b="1" dirty="0">
-                <a:solidFill>
-                  <a:srgbClr val="1B2450"/>
-                </a:solidFill>
-                <a:latin typeface="Arial" pitchFamily="34" charset="0"/>
-                <a:ea typeface="Arial" pitchFamily="34" charset="-122"/>
-                <a:cs typeface="Arial" pitchFamily="34" charset="-120"/>
-              </a:rPr>
-              <a:t>Bukchon Hanok Village</a:t>
-            </a:r>
-            <a:endParaRPr lang="en-US" sz="760" dirty="0"/>
-          </a:p>
-          <a:p>
-            <a:pPr indent="0" marL="0">
-              <a:spcAft>
-                <a:spcPts val="100"/>
-              </a:spcAft>
-              <a:buNone/>
-            </a:pPr>
-            <a:r>
-              <a:rPr lang="en-US" sz="640" dirty="0">
-                <a:solidFill>
-                  <a:srgbClr val="5B6079"/>
-                </a:solidFill>
-                <a:latin typeface="Arial" pitchFamily="34" charset="0"/>
-                <a:ea typeface="Arial" pitchFamily="34" charset="-122"/>
-                <a:cs typeface="Arial" pitchFamily="34" charset="-120"/>
-              </a:rPr>
-              <a:t>Traditional hanok quarter between Gyeongbokgung and Changdeokgung palaces.</a:t>
-            </a:r>
-            <a:endParaRPr lang="en-US" sz="760" dirty="0"/>
-          </a:p>
-          <a:p>
-            <a:pPr indent="0" marL="0">
-              <a:spcAft>
-                <a:spcPts val="100"/>
-              </a:spcAft>
-              <a:buNone/>
-            </a:pPr>
-            <a:r>
-              <a:rPr lang="en-US" sz="620" b="1" dirty="0">
-                <a:solidFill>
-                  <a:srgbClr val="D8432F"/>
-                </a:solidFill>
-                <a:latin typeface="Arial" pitchFamily="34" charset="0"/>
-                <a:ea typeface="Arial" pitchFamily="34" charset="-122"/>
-                <a:cs typeface="Arial" pitchFamily="34" charset="-120"/>
-              </a:rPr>
-              <a:t>Search: 북촌한옥마을</a:t>
-            </a:r>
-            <a:endParaRPr lang="en-US" sz="760" dirty="0"/>
-          </a:p>
-        </p:txBody>
-      </p:sp>
-      <p:sp>
-        <p:nvSpPr>
-          <p:cNvPr id="22" name="Text 17"/>
-          <p:cNvSpPr txBox="1"/>
-          <p:nvPr/>
-        </p:nvSpPr>
-        <p:spPr>
-          <a:xfrm>
-            <a:off x="502920" y="7863840"/>
-            <a:ext cx="3072384" cy="164592"/>
-          </a:xfrm>
-          <a:prstGeom prst="rect">
-            <a:avLst/>
-          </a:prstGeom>
-          <a:noFill/>
-          <a:ln/>
-        </p:spPr>
-        <p:txBody>
-          <a:bodyPr wrap="square" lIns="0" tIns="0" rIns="0" bIns="0" rtlCol="0" anchor="t"/>
-          <a:lstStyle/>
-          <a:p>
-            <a:pPr indent="0" marL="0">
-              <a:buNone/>
-            </a:pPr>
-            <a:r>
-              <a:rPr lang="en-US" sz="600" i="1" dirty="0">
-                <a:solidFill>
-                  <a:srgbClr val="5B6079"/>
-                </a:solidFill>
-                <a:latin typeface="Arial" pitchFamily="34" charset="0"/>
-                <a:ea typeface="Arial" pitchFamily="34" charset="-122"/>
-                <a:cs typeface="Arial" pitchFamily="34" charset="-120"/>
-              </a:rPr>
-              <a:t>Click the picture icon to insert a photo</a:t>
-            </a:r>
-            <a:endParaRPr lang="en-US" sz="600" dirty="0"/>
-          </a:p>
-        </p:txBody>
-      </p:sp>
-      <p:sp>
-        <p:nvSpPr>
-          <p:cNvPr id="23" name="Text 18"/>
+            <a:ext cx="1563624" cy="1280160"/>
+          </a:xfrm>
+          <a:prstGeom prst="rect">
+            <a:avLst/>
+          </a:prstGeom>
+        </p:spPr>
+      </p:pic>
+      <p:pic>
+        <p:nvPicPr>
+          <p:cNvPr id="21" name="Image 4" descr="/home/user/spel-website/ilcec2027/flyer/pptx/photos/p-gyeonghoeru.jpg">    </p:cNvPr>
+          <p:cNvPicPr>
+            <a:picLocks noChangeAspect="1"/>
+          </p:cNvPicPr>
+          <p:nvPr>
+            <p:ph type="pic" idx="102" hasCustomPrompt="1"/>
+          </p:nvPr>
+        </p:nvPicPr>
+        <p:blipFill>
+          <a:blip r:embed="rId5"/>
+          <a:stretch>
+            <a:fillRect/>
+          </a:stretch>
+        </p:blipFill>
+        <p:spPr>
+          <a:xfrm>
+            <a:off x="2084832" y="7818120"/>
+            <a:ext cx="1563624" cy="1280160"/>
+          </a:xfrm>
+          <a:prstGeom prst="rect">
+            <a:avLst/>
+          </a:prstGeom>
+        </p:spPr>
+      </p:pic>
+      <p:sp>
+        <p:nvSpPr>
+          <p:cNvPr id="22" name="Text 15"/>
           <p:cNvSpPr txBox="1"/>
           <p:nvPr/>
         </p:nvSpPr>
@@ -5584,7 +4915,7 @@
       </p:sp>
       <p:sp>
         <p:nvSpPr>
-          <p:cNvPr id="24" name="Text 19"/>
+          <p:cNvPr id="23" name="Text 16"/>
           <p:cNvSpPr txBox="1"/>
           <p:nvPr/>
         </p:nvSpPr>
@@ -5660,7 +4991,7 @@
       </p:sp>
       <p:sp>
         <p:nvSpPr>
-          <p:cNvPr id="25" name="Text 20"/>
+          <p:cNvPr id="24" name="Text 17"/>
           <p:cNvSpPr txBox="1"/>
           <p:nvPr/>
         </p:nvSpPr>
@@ -5699,7 +5030,7 @@
       </p:sp>
       <p:sp>
         <p:nvSpPr>
-          <p:cNvPr id="26" name="Text 21"/>
+          <p:cNvPr id="25" name="Text 18"/>
           <p:cNvSpPr txBox="1"/>
           <p:nvPr/>
         </p:nvSpPr>
@@ -5741,7 +5072,7 @@
       </p:sp>
       <p:sp>
         <p:nvSpPr>
-          <p:cNvPr id="27" name="Text 22"/>
+          <p:cNvPr id="26" name="Text 19"/>
           <p:cNvSpPr txBox="1"/>
           <p:nvPr/>
         </p:nvSpPr>
@@ -5780,7 +5111,7 @@
       </p:sp>
       <p:sp>
         <p:nvSpPr>
-          <p:cNvPr id="28" name="Text 23"/>
+          <p:cNvPr id="27" name="Text 20"/>
           <p:cNvSpPr txBox="1"/>
           <p:nvPr/>
         </p:nvSpPr>
@@ -5822,7 +5153,7 @@
       </p:sp>
       <p:sp>
         <p:nvSpPr>
-          <p:cNvPr id="29" name="Text 24"/>
+          <p:cNvPr id="28" name="Text 21"/>
           <p:cNvSpPr txBox="1"/>
           <p:nvPr/>
         </p:nvSpPr>
@@ -5875,7 +5206,7 @@
       </p:sp>
       <p:sp>
         <p:nvSpPr>
-          <p:cNvPr id="30" name="Text 25"/>
+          <p:cNvPr id="29" name="Text 22"/>
           <p:cNvSpPr txBox="1"/>
           <p:nvPr/>
         </p:nvSpPr>
@@ -6137,7 +5468,7 @@
       </p:sp>
       <p:sp>
         <p:nvSpPr>
-          <p:cNvPr id="31" name="Text 26"/>
+          <p:cNvPr id="30" name="Text 23"/>
           <p:cNvSpPr txBox="1"/>
           <p:nvPr/>
         </p:nvSpPr>
@@ -6176,14 +5507,14 @@
       </p:sp>
       <p:sp>
         <p:nvSpPr>
-          <p:cNvPr id="32" name="Text 27"/>
+          <p:cNvPr id="31" name="Text 24"/>
           <p:cNvSpPr txBox="1"/>
           <p:nvPr/>
         </p:nvSpPr>
         <p:spPr>
           <a:xfrm>
             <a:off x="3913632" y="8257032"/>
-            <a:ext cx="3218688" cy="877824"/>
+            <a:ext cx="3218688" cy="914400"/>
           </a:xfrm>
           <a:prstGeom prst="rect">
             <a:avLst/>
@@ -6210,7 +5541,7 @@
                 <a:ea typeface="Arial" pitchFamily="34" charset="-122"/>
                 <a:cs typeface="Arial" pitchFamily="34" charset="-120"/>
               </a:rPr>
-              <a:t>· Synthesis, alignment and processing of LCEs and LC networks</a:t>
+              <a:t>· Synthesis, alignment and processing of LCEs</a:t>
             </a:r>
             <a:endParaRPr lang="en-US" sz="760" dirty="0"/>
           </a:p>
@@ -6230,7 +5561,7 @@
                 <a:ea typeface="Arial" pitchFamily="34" charset="-122"/>
                 <a:cs typeface="Arial" pitchFamily="34" charset="-120"/>
               </a:rPr>
-              <a:t>· Photo-, thermo-, electro- and magneto-actuation; soft robotics</a:t>
+              <a:t>· Photo-, thermo-, electro- and magneto-actuation</a:t>
             </a:r>
             <a:endParaRPr lang="en-US" sz="760" dirty="0"/>
           </a:p>
@@ -6290,7 +5621,7 @@
                 <a:ea typeface="Arial" pitchFamily="34" charset="-122"/>
                 <a:cs typeface="Arial" pitchFamily="34" charset="-120"/>
               </a:rPr>
-              <a:t>· Feedback-driven, autonomous and self-oscillating motion</a:t>
+              <a:t>· Feedback-driven and autonomous motion; soft robotics</a:t>
             </a:r>
             <a:endParaRPr lang="en-US" sz="760" dirty="0"/>
           </a:p>
@@ -6338,7 +5669,7 @@
       </p:sp>
       <p:sp>
         <p:nvSpPr>
-          <p:cNvPr id="33" name="Shape 28"/>
+          <p:cNvPr id="32" name="Shape 25"/>
           <p:cNvSpPr/>
           <p:nvPr/>
         </p:nvSpPr>
@@ -6361,7 +5692,7 @@
       </p:sp>
       <p:sp>
         <p:nvSpPr>
-          <p:cNvPr id="34" name="Shape 29"/>
+          <p:cNvPr id="33" name="Shape 26"/>
           <p:cNvSpPr/>
           <p:nvPr/>
         </p:nvSpPr>
@@ -6388,7 +5719,7 @@
       </p:sp>
       <p:sp>
         <p:nvSpPr>
-          <p:cNvPr id="35" name="Text 30"/>
+          <p:cNvPr id="34" name="Text 27"/>
           <p:cNvSpPr txBox="1"/>
           <p:nvPr/>
         </p:nvSpPr>
@@ -6427,7 +5758,7 @@
       </p:sp>
       <p:sp>
         <p:nvSpPr>
-          <p:cNvPr id="36" name="Shape 31"/>
+          <p:cNvPr id="35" name="Shape 28"/>
           <p:cNvSpPr/>
           <p:nvPr/>
         </p:nvSpPr>
@@ -6454,7 +5785,7 @@
       </p:sp>
       <p:sp>
         <p:nvSpPr>
-          <p:cNvPr id="37" name="Text 32"/>
+          <p:cNvPr id="36" name="Text 29"/>
           <p:cNvSpPr txBox="1"/>
           <p:nvPr/>
         </p:nvSpPr>
@@ -6493,7 +5824,7 @@
       </p:sp>
       <p:sp>
         <p:nvSpPr>
-          <p:cNvPr id="38" name="Shape 33"/>
+          <p:cNvPr id="37" name="Shape 30"/>
           <p:cNvSpPr/>
           <p:nvPr/>
         </p:nvSpPr>
@@ -6520,7 +5851,7 @@
       </p:sp>
       <p:sp>
         <p:nvSpPr>
-          <p:cNvPr id="39" name="Text 34"/>
+          <p:cNvPr id="38" name="Text 31"/>
           <p:cNvSpPr txBox="1"/>
           <p:nvPr/>
         </p:nvSpPr>
@@ -6559,7 +5890,7 @@
       </p:sp>
       <p:sp>
         <p:nvSpPr>
-          <p:cNvPr id="40" name="Text 35"/>
+          <p:cNvPr id="39" name="Text 32"/>
           <p:cNvSpPr txBox="1"/>
           <p:nvPr/>
         </p:nvSpPr>
@@ -6590,7 +5921,7 @@
                 <a:ea typeface="Arial" pitchFamily="34" charset="-122"/>
                 <a:cs typeface="Arial" pitchFamily="34" charset="-120"/>
               </a:rPr>
-              <a:t>Photo credits: </a:t>
+              <a:t>Photos: </a:t>
             </a:r>
             <a:pPr algn="r" indent="0" marL="0">
               <a:buNone/>
@@ -6604,7 +5935,7 @@
                 <a:ea typeface="Arial" pitchFamily="34" charset="-122"/>
                 <a:cs typeface="Arial" pitchFamily="34" charset="-120"/>
               </a:rPr>
-              <a:t>© Korea Tourism Organization Photo Korea – photographer name (fill in when images are inserted).</a:t>
+              <a:t>© Korea Tourism Organization (Photo Korea) – 조한섭, 한국관광공사 카멜프레스, 안형록, 임귀빈, 임태원, 이재국, IR 스튜디오. KOGL Type 1.</a:t>
             </a:r>
             <a:endParaRPr lang="en-US" sz="610" dirty="0"/>
           </a:p>
@@ -6621,39 +5952,9 @@
                 <a:ea typeface="Arial" pitchFamily="34" charset="-122"/>
                 <a:cs typeface="Arial" pitchFamily="34" charset="-120"/>
               </a:rPr>
-              <a:t>Skyline illustration: ILCEC 2027 organizing committee.</a:t>
+              <a:t>Typefaces: Arial. Replace the low-resolution preview photos with the original downloads before printing.</a:t>
             </a:r>
             <a:endParaRPr lang="en-US" sz="610" dirty="0"/>
-          </a:p>
-        </p:txBody>
-      </p:sp>
-      <p:sp>
-        <p:nvSpPr>
-          <p:cNvPr id="42" name="Text 0"/>
-          <p:cNvSpPr/>
-          <p:nvPr>
-            <p:ph type="pic" idx="101" hasCustomPrompt="1"/>
-          </p:nvPr>
-        </p:nvSpPr>
-        <p:spPr>
-          <a:xfrm>
-            <a:off x="429768" y="7818120"/>
-            <a:ext cx="3218688" cy="1280160"/>
-          </a:xfrm>
-          <a:prstGeom prst="rect">
-            <a:avLst/>
-          </a:prstGeom>
-          <a:noFill/>
-          <a:ln/>
-        </p:spPr>
-        <p:txBody>
-          <a:bodyPr wrap="square" rtlCol="0"/>
-          <a:lstStyle/>
-          <a:p>
-            <a:pPr indent="0" marL="0">
-              <a:buNone/>
-            </a:pPr>
-            <a:endParaRPr lang="en-US" dirty="0"/>
           </a:p>
         </p:txBody>
       </p:sp>

</xml_diff>

<commit_message>
Align the ILCEC 2027 flyer PDF and PPTX designs
Both outputs now share one look: Arial throughout, TBD items as red
text on a pale rose highlight, rounded photo corners, corner colour
wash and the diagonal DRAFT ribbon. The PPTX post-processor now also
rounds picture corners; the unused web fonts are removed.

Co-Authored-By: Claude Fable 5.1 <noreply@anthropic.com>
Claude-Session: https://claude.ai/code/session_0176bT1uqbE7ABLdKoQNCaUr
</commit_message>
<xml_diff>
--- a/ilcec2027/ILCEC_2027_First_Announcement_DRAFT.pptx
+++ b/ilcec2027/ILCEC_2027_First_Announcement_DRAFT.pptx
@@ -669,9 +669,16 @@
   <p:cSld name="FRONT">
     <p:bg>
       <p:bgPr>
-        <a:solidFill>
-          <a:srgbClr val="FFFFFF"/>
-        </a:solidFill>
+        <a:blipFill dpi="0" rotWithShape="1">
+          <a:blip r:embed="rId1">
+            <a:lum/>
+          </a:blip>
+          <a:srcRect/>
+          <a:stretch>
+            <a:fillRect/>
+          </a:stretch>
+        </a:blipFill>
+        <a:effectLst/>
       </p:bgPr>
     </p:bg>
     <p:spTree>
@@ -833,7 +840,7 @@
           <p:cNvPr id="6" name="Text 0"/>
           <p:cNvSpPr/>
           <p:nvPr>
-            <p:ph idx="104" hasCustomPrompt="1"/>
+            <p:ph type="pic" idx="104" hasCustomPrompt="1"/>
           </p:nvPr>
         </p:nvSpPr>
         <p:spPr>
@@ -876,9 +883,16 @@
   <p:cSld name="BACK">
     <p:bg>
       <p:bgPr>
-        <a:solidFill>
-          <a:srgbClr val="FFFFFF"/>
-        </a:solidFill>
+        <a:blipFill dpi="0" rotWithShape="1">
+          <a:blip r:embed="rId1">
+            <a:lum/>
+          </a:blip>
+          <a:srcRect/>
+          <a:stretch>
+            <a:fillRect/>
+          </a:stretch>
+        </a:blipFill>
+        <a:effectLst/>
       </p:bgPr>
     </p:bg>
     <p:spTree>
@@ -1325,8 +1339,10 @@
             <a:off x="429768" y="393192"/>
             <a:ext cx="6702552" cy="1737360"/>
           </a:xfrm>
-          <a:prstGeom prst="rect">
-            <a:avLst/>
+          <a:prstGeom prst="roundRect">
+            <a:avLst>
+              <a:gd name="adj" fmla="val 4210"/>
+            </a:avLst>
           </a:prstGeom>
         </p:spPr>
       </p:pic>
@@ -1455,7 +1471,7 @@
               <a:buNone/>
             </a:pPr>
             <a:r>
-              <a:rPr lang="en-US" sz="2500" b="1" dirty="0">
+              <a:rPr lang="en-US" sz="2600" b="1" dirty="0">
                 <a:solidFill>
                   <a:srgbClr val="1B2450"/>
                 </a:solidFill>
@@ -1465,7 +1481,7 @@
               </a:rPr>
               <a:t>International Liquid Crystal</a:t>
             </a:r>
-            <a:endParaRPr lang="en-US" sz="2500" dirty="0"/>
+            <a:endParaRPr lang="en-US" sz="2600" dirty="0"/>
           </a:p>
           <a:p>
             <a:pPr indent="0" marL="0">
@@ -1475,7 +1491,7 @@
               <a:buNone/>
             </a:pPr>
             <a:r>
-              <a:rPr lang="en-US" sz="2500" b="1" dirty="0">
+              <a:rPr lang="en-US" sz="2600" b="1" dirty="0">
                 <a:solidFill>
                   <a:srgbClr val="1B2450"/>
                 </a:solidFill>
@@ -1485,7 +1501,7 @@
               </a:rPr>
               <a:t>Elastomer Conference</a:t>
             </a:r>
-            <a:endParaRPr lang="en-US" sz="2500" dirty="0"/>
+            <a:endParaRPr lang="en-US" sz="2600" dirty="0"/>
           </a:p>
         </p:txBody>
       </p:sp>
@@ -1556,13 +1572,16 @@
             <a:r>
               <a:rPr lang="en-US" sz="1050" b="1" dirty="0">
                 <a:solidFill>
-                  <a:srgbClr val="D8432F"/>
-                </a:solidFill>
-                <a:latin typeface="Arial" pitchFamily="34" charset="0"/>
-                <a:ea typeface="Arial" pitchFamily="34" charset="-122"/>
-                <a:cs typeface="Arial" pitchFamily="34" charset="-120"/>
-              </a:rPr>
-              <a:t>[DD–DD Month 2027]</a:t>
+                  <a:srgbClr val="B8402F"/>
+                </a:solidFill>
+                <a:highlight>
+                  <a:srgbClr val="FFF1EE"/>
+                </a:highlight>
+                <a:latin typeface="Arial" pitchFamily="34" charset="0"/>
+                <a:ea typeface="Arial" pitchFamily="34" charset="-122"/>
+                <a:cs typeface="Arial" pitchFamily="34" charset="-120"/>
+              </a:rPr>
+              <a:t> DD–DD Month 2027 </a:t>
             </a:r>
             <a:endParaRPr lang="en-US" sz="1500" dirty="0"/>
           </a:p>
@@ -1595,9 +1614,9 @@
           <p:nvPr/>
         </p:nvSpPr>
         <p:spPr>
-          <a:xfrm>
-            <a:off x="6172200" y="45720"/>
-            <a:ext cx="1051560" cy="219456"/>
+          <a:xfrm rot="2700000">
+            <a:off x="6053328" y="420624"/>
+            <a:ext cx="2011680" cy="237744"/>
           </a:xfrm>
           <a:prstGeom prst="rect">
             <a:avLst/>
@@ -1606,6 +1625,13 @@
             <a:srgbClr val="D8432F"/>
           </a:solidFill>
           <a:ln/>
+          <a:effectLst>
+            <a:outerShdw sx="100000" sy="100000" kx="0" ky="0" algn="bl" rotWithShape="0" blurRad="38100" dist="12700" dir="5400000">
+              <a:srgbClr val="000000">
+                <a:alpha val="25000"/>
+              </a:srgbClr>
+            </a:outerShdw>
+          </a:effectLst>
         </p:spPr>
         <p:txBody>
           <a:bodyPr wrap="square" lIns="0" tIns="0" rIns="0" bIns="0" rtlCol="0" anchor="ctr"/>
@@ -1615,7 +1641,7 @@
               <a:buNone/>
             </a:pPr>
             <a:r>
-              <a:rPr lang="en-US" sz="750" b="1" spc="200" kern="0" dirty="0">
+              <a:rPr lang="en-US" sz="750" b="1" spc="300" kern="0" dirty="0">
                 <a:solidFill>
                   <a:srgbClr val="FFFFFF"/>
                 </a:solidFill>
@@ -1774,13 +1800,16 @@
             <a:r>
               <a:rPr lang="en-US" sz="760" b="1" dirty="0">
                 <a:solidFill>
-                  <a:srgbClr val="D8432F"/>
-                </a:solidFill>
-                <a:latin typeface="Arial" pitchFamily="34" charset="0"/>
-                <a:ea typeface="Arial" pitchFamily="34" charset="-122"/>
-                <a:cs typeface="Arial" pitchFamily="34" charset="-120"/>
-              </a:rPr>
-              <a:t>[Chair name]</a:t>
+                  <a:srgbClr val="B8402F"/>
+                </a:solidFill>
+                <a:highlight>
+                  <a:srgbClr val="FFF1EE"/>
+                </a:highlight>
+                <a:latin typeface="Arial" pitchFamily="34" charset="0"/>
+                <a:ea typeface="Arial" pitchFamily="34" charset="-122"/>
+                <a:cs typeface="Arial" pitchFamily="34" charset="-120"/>
+              </a:rPr>
+              <a:t> Chair name </a:t>
             </a:r>
             <a:pPr indent="0" marL="0">
               <a:spcAft>
@@ -1808,13 +1837,16 @@
             <a:r>
               <a:rPr lang="en-US" sz="760" b="1" dirty="0">
                 <a:solidFill>
-                  <a:srgbClr val="D8432F"/>
-                </a:solidFill>
-                <a:latin typeface="Arial" pitchFamily="34" charset="0"/>
-                <a:ea typeface="Arial" pitchFamily="34" charset="-122"/>
-                <a:cs typeface="Arial" pitchFamily="34" charset="-120"/>
-              </a:rPr>
-              <a:t>[Affiliation]</a:t>
+                  <a:srgbClr val="B8402F"/>
+                </a:solidFill>
+                <a:highlight>
+                  <a:srgbClr val="FFF1EE"/>
+                </a:highlight>
+                <a:latin typeface="Arial" pitchFamily="34" charset="0"/>
+                <a:ea typeface="Arial" pitchFamily="34" charset="-122"/>
+                <a:cs typeface="Arial" pitchFamily="34" charset="-120"/>
+              </a:rPr>
+              <a:t> Affiliation </a:t>
             </a:r>
             <a:pPr indent="0" marL="0">
               <a:spcAft>
@@ -1834,13 +1866,16 @@
             <a:r>
               <a:rPr lang="en-US" sz="760" b="1" dirty="0">
                 <a:solidFill>
-                  <a:srgbClr val="D8432F"/>
-                </a:solidFill>
-                <a:latin typeface="Arial" pitchFamily="34" charset="0"/>
-                <a:ea typeface="Arial" pitchFamily="34" charset="-122"/>
-                <a:cs typeface="Arial" pitchFamily="34" charset="-120"/>
-              </a:rPr>
-              <a:t>[Co-chair name]</a:t>
+                  <a:srgbClr val="B8402F"/>
+                </a:solidFill>
+                <a:highlight>
+                  <a:srgbClr val="FFF1EE"/>
+                </a:highlight>
+                <a:latin typeface="Arial" pitchFamily="34" charset="0"/>
+                <a:ea typeface="Arial" pitchFamily="34" charset="-122"/>
+                <a:cs typeface="Arial" pitchFamily="34" charset="-120"/>
+              </a:rPr>
+              <a:t> Co-chair name </a:t>
             </a:r>
             <a:pPr indent="0" marL="0">
               <a:spcAft>
@@ -1868,13 +1903,16 @@
             <a:r>
               <a:rPr lang="en-US" sz="760" b="1" dirty="0">
                 <a:solidFill>
-                  <a:srgbClr val="D8432F"/>
-                </a:solidFill>
-                <a:latin typeface="Arial" pitchFamily="34" charset="0"/>
-                <a:ea typeface="Arial" pitchFamily="34" charset="-122"/>
-                <a:cs typeface="Arial" pitchFamily="34" charset="-120"/>
-              </a:rPr>
-              <a:t>[Affiliation]</a:t>
+                  <a:srgbClr val="B8402F"/>
+                </a:solidFill>
+                <a:highlight>
+                  <a:srgbClr val="FFF1EE"/>
+                </a:highlight>
+                <a:latin typeface="Arial" pitchFamily="34" charset="0"/>
+                <a:ea typeface="Arial" pitchFamily="34" charset="-122"/>
+                <a:cs typeface="Arial" pitchFamily="34" charset="-120"/>
+              </a:rPr>
+              <a:t> Affiliation </a:t>
             </a:r>
             <a:endParaRPr lang="en-US" sz="760" dirty="0"/>
           </a:p>
@@ -1949,13 +1987,16 @@
             <a:r>
               <a:rPr lang="en-US" sz="760" b="1" dirty="0">
                 <a:solidFill>
-                  <a:srgbClr val="D8432F"/>
-                </a:solidFill>
-                <a:latin typeface="Arial" pitchFamily="34" charset="0"/>
-                <a:ea typeface="Arial" pitchFamily="34" charset="-122"/>
-                <a:cs typeface="Arial" pitchFamily="34" charset="-120"/>
-              </a:rPr>
-              <a:t>[Coordinator name]</a:t>
+                  <a:srgbClr val="B8402F"/>
+                </a:solidFill>
+                <a:highlight>
+                  <a:srgbClr val="FFF1EE"/>
+                </a:highlight>
+                <a:latin typeface="Arial" pitchFamily="34" charset="0"/>
+                <a:ea typeface="Arial" pitchFamily="34" charset="-122"/>
+                <a:cs typeface="Arial" pitchFamily="34" charset="-120"/>
+              </a:rPr>
+              <a:t> Coordinator name </a:t>
             </a:r>
             <a:pPr indent="0" marL="0">
               <a:spcAft>
@@ -1992,13 +2033,16 @@
             <a:r>
               <a:rPr lang="en-US" sz="760" b="1" dirty="0">
                 <a:solidFill>
-                  <a:srgbClr val="D8432F"/>
-                </a:solidFill>
-                <a:latin typeface="Arial" pitchFamily="34" charset="0"/>
-                <a:ea typeface="Arial" pitchFamily="34" charset="-122"/>
-                <a:cs typeface="Arial" pitchFamily="34" charset="-120"/>
-              </a:rPr>
-              <a:t>[ilcec2027@___.ac.kr]</a:t>
+                  <a:srgbClr val="B8402F"/>
+                </a:solidFill>
+                <a:highlight>
+                  <a:srgbClr val="FFF1EE"/>
+                </a:highlight>
+                <a:latin typeface="Arial" pitchFamily="34" charset="0"/>
+                <a:ea typeface="Arial" pitchFamily="34" charset="-122"/>
+                <a:cs typeface="Arial" pitchFamily="34" charset="-120"/>
+              </a:rPr>
+              <a:t> ilcec2027@___.ac.kr </a:t>
             </a:r>
             <a:endParaRPr lang="en-US" sz="760" dirty="0"/>
           </a:p>
@@ -2073,13 +2117,16 @@
             <a:r>
               <a:rPr lang="en-US" sz="760" b="1" dirty="0">
                 <a:solidFill>
-                  <a:srgbClr val="D8432F"/>
-                </a:solidFill>
-                <a:latin typeface="Arial" pitchFamily="34" charset="0"/>
-                <a:ea typeface="Arial" pitchFamily="34" charset="-122"/>
-                <a:cs typeface="Arial" pitchFamily="34" charset="-120"/>
-              </a:rPr>
-              <a:t>[TBD]</a:t>
+                  <a:srgbClr val="B8402F"/>
+                </a:solidFill>
+                <a:highlight>
+                  <a:srgbClr val="FFF1EE"/>
+                </a:highlight>
+                <a:latin typeface="Arial" pitchFamily="34" charset="0"/>
+                <a:ea typeface="Arial" pitchFamily="34" charset="-122"/>
+                <a:cs typeface="Arial" pitchFamily="34" charset="-120"/>
+              </a:rPr>
+              <a:t> TBD </a:t>
             </a:r>
             <a:endParaRPr lang="en-US" sz="760" dirty="0"/>
           </a:p>
@@ -2157,13 +2204,16 @@
             <a:r>
               <a:rPr lang="en-US" sz="760" b="1" dirty="0">
                 <a:solidFill>
-                  <a:srgbClr val="D8432F"/>
-                </a:solidFill>
-                <a:latin typeface="Arial" pitchFamily="34" charset="0"/>
-                <a:ea typeface="Arial" pitchFamily="34" charset="-122"/>
-                <a:cs typeface="Arial" pitchFamily="34" charset="-120"/>
-              </a:rPr>
-              <a:t>[TBD]</a:t>
+                  <a:srgbClr val="B8402F"/>
+                </a:solidFill>
+                <a:highlight>
+                  <a:srgbClr val="FFF1EE"/>
+                </a:highlight>
+                <a:latin typeface="Arial" pitchFamily="34" charset="0"/>
+                <a:ea typeface="Arial" pitchFamily="34" charset="-122"/>
+                <a:cs typeface="Arial" pitchFamily="34" charset="-120"/>
+              </a:rPr>
+              <a:t> TBD </a:t>
             </a:r>
             <a:endParaRPr lang="en-US" sz="760" dirty="0"/>
           </a:p>
@@ -2241,13 +2291,16 @@
             <a:r>
               <a:rPr lang="en-US" sz="760" b="1" dirty="0">
                 <a:solidFill>
-                  <a:srgbClr val="D8432F"/>
-                </a:solidFill>
-                <a:latin typeface="Arial" pitchFamily="34" charset="0"/>
-                <a:ea typeface="Arial" pitchFamily="34" charset="-122"/>
-                <a:cs typeface="Arial" pitchFamily="34" charset="-120"/>
-              </a:rPr>
-              <a:t>[TBD]</a:t>
+                  <a:srgbClr val="B8402F"/>
+                </a:solidFill>
+                <a:highlight>
+                  <a:srgbClr val="FFF1EE"/>
+                </a:highlight>
+                <a:latin typeface="Arial" pitchFamily="34" charset="0"/>
+                <a:ea typeface="Arial" pitchFamily="34" charset="-122"/>
+                <a:cs typeface="Arial" pitchFamily="34" charset="-120"/>
+              </a:rPr>
+              <a:t> TBD </a:t>
             </a:r>
             <a:endParaRPr lang="en-US" sz="760" dirty="0"/>
           </a:p>
@@ -2325,13 +2378,16 @@
             <a:r>
               <a:rPr lang="en-US" sz="760" b="1" dirty="0">
                 <a:solidFill>
-                  <a:srgbClr val="D8432F"/>
-                </a:solidFill>
-                <a:latin typeface="Arial" pitchFamily="34" charset="0"/>
-                <a:ea typeface="Arial" pitchFamily="34" charset="-122"/>
-                <a:cs typeface="Arial" pitchFamily="34" charset="-120"/>
-              </a:rPr>
-              <a:t>[TBD]</a:t>
+                  <a:srgbClr val="B8402F"/>
+                </a:solidFill>
+                <a:highlight>
+                  <a:srgbClr val="FFF1EE"/>
+                </a:highlight>
+                <a:latin typeface="Arial" pitchFamily="34" charset="0"/>
+                <a:ea typeface="Arial" pitchFamily="34" charset="-122"/>
+                <a:cs typeface="Arial" pitchFamily="34" charset="-120"/>
+              </a:rPr>
+              <a:t> TBD </a:t>
             </a:r>
             <a:endParaRPr lang="en-US" sz="760" dirty="0"/>
           </a:p>
@@ -2400,8 +2456,10 @@
             <a:off x="429768" y="6967728"/>
             <a:ext cx="3218688" cy="1170432"/>
           </a:xfrm>
-          <a:prstGeom prst="rect">
-            <a:avLst/>
+          <a:prstGeom prst="roundRect">
+            <a:avLst>
+              <a:gd name="adj" fmla="val 6250"/>
+            </a:avLst>
           </a:prstGeom>
         </p:spPr>
       </p:pic>
@@ -2426,8 +2484,10 @@
             <a:off x="429768" y="8211312"/>
             <a:ext cx="3218688" cy="877824"/>
           </a:xfrm>
-          <a:prstGeom prst="rect">
-            <a:avLst/>
+          <a:prstGeom prst="roundRect">
+            <a:avLst>
+              <a:gd name="adj" fmla="val 8333"/>
+            </a:avLst>
           </a:prstGeom>
         </p:spPr>
       </p:pic>
@@ -2825,13 +2885,16 @@
             <a:r>
               <a:rPr lang="en-US" sz="760" b="1" dirty="0">
                 <a:solidFill>
-                  <a:srgbClr val="D8432F"/>
-                </a:solidFill>
-                <a:latin typeface="Arial" pitchFamily="34" charset="0"/>
-                <a:ea typeface="Arial" pitchFamily="34" charset="-122"/>
-                <a:cs typeface="Arial" pitchFamily="34" charset="-120"/>
-              </a:rPr>
-              <a:t>[Day 1]</a:t>
+                  <a:srgbClr val="B8402F"/>
+                </a:solidFill>
+                <a:highlight>
+                  <a:srgbClr val="FFF1EE"/>
+                </a:highlight>
+                <a:latin typeface="Arial" pitchFamily="34" charset="0"/>
+                <a:ea typeface="Arial" pitchFamily="34" charset="-122"/>
+                <a:cs typeface="Arial" pitchFamily="34" charset="-120"/>
+              </a:rPr>
+              <a:t> Day 1 </a:t>
             </a:r>
             <a:pPr indent="0" marL="0">
               <a:spcAft>
@@ -2905,13 +2968,16 @@
             <a:r>
               <a:rPr lang="en-US" sz="760" b="1" dirty="0">
                 <a:solidFill>
-                  <a:srgbClr val="D8432F"/>
-                </a:solidFill>
-                <a:latin typeface="Arial" pitchFamily="34" charset="0"/>
-                <a:ea typeface="Arial" pitchFamily="34" charset="-122"/>
-                <a:cs typeface="Arial" pitchFamily="34" charset="-120"/>
-              </a:rPr>
-              <a:t>[Day 3]</a:t>
+                  <a:srgbClr val="B8402F"/>
+                </a:solidFill>
+                <a:highlight>
+                  <a:srgbClr val="FFF1EE"/>
+                </a:highlight>
+                <a:latin typeface="Arial" pitchFamily="34" charset="0"/>
+                <a:ea typeface="Arial" pitchFamily="34" charset="-122"/>
+                <a:cs typeface="Arial" pitchFamily="34" charset="-120"/>
+              </a:rPr>
+              <a:t> Day 3 </a:t>
             </a:r>
             <a:pPr indent="0" marL="0">
               <a:spcAft>
@@ -2985,13 +3051,16 @@
             <a:r>
               <a:rPr lang="en-US" sz="760" b="1" dirty="0">
                 <a:solidFill>
-                  <a:srgbClr val="D8432F"/>
-                </a:solidFill>
-                <a:latin typeface="Arial" pitchFamily="34" charset="0"/>
-                <a:ea typeface="Arial" pitchFamily="34" charset="-122"/>
-                <a:cs typeface="Arial" pitchFamily="34" charset="-120"/>
-              </a:rPr>
-              <a:t>[Day 4]</a:t>
+                  <a:srgbClr val="B8402F"/>
+                </a:solidFill>
+                <a:highlight>
+                  <a:srgbClr val="FFF1EE"/>
+                </a:highlight>
+                <a:latin typeface="Arial" pitchFamily="34" charset="0"/>
+                <a:ea typeface="Arial" pitchFamily="34" charset="-122"/>
+                <a:cs typeface="Arial" pitchFamily="34" charset="-120"/>
+              </a:rPr>
+              <a:t> Day 4 </a:t>
             </a:r>
             <a:pPr indent="0" marL="0">
               <a:spcAft>
@@ -3044,8 +3113,10 @@
             <a:off x="3913632" y="8394192"/>
             <a:ext cx="1563624" cy="694944"/>
           </a:xfrm>
-          <a:prstGeom prst="rect">
-            <a:avLst/>
+          <a:prstGeom prst="roundRect">
+            <a:avLst>
+              <a:gd name="adj" fmla="val 10526"/>
+            </a:avLst>
           </a:prstGeom>
         </p:spPr>
       </p:pic>
@@ -3056,7 +3127,7 @@
             <a:picLocks noChangeAspect="1"/>
           </p:cNvPicPr>
           <p:nvPr>
-            <p:ph idx="104" hasCustomPrompt="1"/>
+            <p:ph type="pic" idx="104" hasCustomPrompt="1"/>
           </p:nvPr>
         </p:nvPicPr>
         <p:blipFill>
@@ -3070,8 +3141,10 @@
             <a:off x="5568696" y="8394192"/>
             <a:ext cx="1563624" cy="694944"/>
           </a:xfrm>
-          <a:prstGeom prst="rect">
-            <a:avLst/>
+          <a:prstGeom prst="roundRect">
+            <a:avLst>
+              <a:gd name="adj" fmla="val 10526"/>
+            </a:avLst>
           </a:prstGeom>
         </p:spPr>
       </p:pic>
@@ -3412,8 +3485,10 @@
             <a:off x="429768" y="393192"/>
             <a:ext cx="6702552" cy="1444752"/>
           </a:xfrm>
-          <a:prstGeom prst="rect">
-            <a:avLst/>
+          <a:prstGeom prst="roundRect">
+            <a:avLst>
+              <a:gd name="adj" fmla="val 5063"/>
+            </a:avLst>
           </a:prstGeom>
         </p:spPr>
       </p:pic>
@@ -3542,7 +3617,7 @@
               <a:buNone/>
             </a:pPr>
             <a:r>
-              <a:rPr lang="en-US" sz="2500" b="1" dirty="0">
+              <a:rPr lang="en-US" sz="2600" b="1" dirty="0">
                 <a:solidFill>
                   <a:srgbClr val="1B2450"/>
                 </a:solidFill>
@@ -3552,7 +3627,7 @@
               </a:rPr>
               <a:t>International Liquid Crystal</a:t>
             </a:r>
-            <a:endParaRPr lang="en-US" sz="2500" dirty="0"/>
+            <a:endParaRPr lang="en-US" sz="2600" dirty="0"/>
           </a:p>
           <a:p>
             <a:pPr indent="0" marL="0">
@@ -3562,7 +3637,7 @@
               <a:buNone/>
             </a:pPr>
             <a:r>
-              <a:rPr lang="en-US" sz="2500" b="1" dirty="0">
+              <a:rPr lang="en-US" sz="2600" b="1" dirty="0">
                 <a:solidFill>
                   <a:srgbClr val="1B2450"/>
                 </a:solidFill>
@@ -3572,7 +3647,7 @@
               </a:rPr>
               <a:t>Elastomer Conference</a:t>
             </a:r>
-            <a:endParaRPr lang="en-US" sz="2500" dirty="0"/>
+            <a:endParaRPr lang="en-US" sz="2600" dirty="0"/>
           </a:p>
         </p:txBody>
       </p:sp>
@@ -3643,13 +3718,16 @@
             <a:r>
               <a:rPr lang="en-US" sz="1050" b="1" dirty="0">
                 <a:solidFill>
-                  <a:srgbClr val="D8432F"/>
-                </a:solidFill>
-                <a:latin typeface="Arial" pitchFamily="34" charset="0"/>
-                <a:ea typeface="Arial" pitchFamily="34" charset="-122"/>
-                <a:cs typeface="Arial" pitchFamily="34" charset="-120"/>
-              </a:rPr>
-              <a:t>[DD–DD Month 2027]</a:t>
+                  <a:srgbClr val="B8402F"/>
+                </a:solidFill>
+                <a:highlight>
+                  <a:srgbClr val="FFF1EE"/>
+                </a:highlight>
+                <a:latin typeface="Arial" pitchFamily="34" charset="0"/>
+                <a:ea typeface="Arial" pitchFamily="34" charset="-122"/>
+                <a:cs typeface="Arial" pitchFamily="34" charset="-120"/>
+              </a:rPr>
+              <a:t> DD–DD Month 2027 </a:t>
             </a:r>
             <a:endParaRPr lang="en-US" sz="1500" dirty="0"/>
           </a:p>
@@ -3682,9 +3760,9 @@
           <p:nvPr/>
         </p:nvSpPr>
         <p:spPr>
-          <a:xfrm>
-            <a:off x="6172200" y="45720"/>
-            <a:ext cx="1051560" cy="219456"/>
+          <a:xfrm rot="2700000">
+            <a:off x="6053328" y="420624"/>
+            <a:ext cx="2011680" cy="237744"/>
           </a:xfrm>
           <a:prstGeom prst="rect">
             <a:avLst/>
@@ -3693,6 +3771,13 @@
             <a:srgbClr val="D8432F"/>
           </a:solidFill>
           <a:ln/>
+          <a:effectLst>
+            <a:outerShdw sx="100000" sy="100000" kx="0" ky="0" algn="bl" rotWithShape="0" blurRad="38100" dist="12700" dir="5400000">
+              <a:srgbClr val="000000">
+                <a:alpha val="25000"/>
+              </a:srgbClr>
+            </a:outerShdw>
+          </a:effectLst>
         </p:spPr>
         <p:txBody>
           <a:bodyPr wrap="square" lIns="0" tIns="0" rIns="0" bIns="0" rtlCol="0" anchor="ctr"/>
@@ -3702,7 +3787,7 @@
               <a:buNone/>
             </a:pPr>
             <a:r>
-              <a:rPr lang="en-US" sz="750" b="1" spc="200" kern="0" dirty="0">
+              <a:rPr lang="en-US" sz="750" b="1" spc="300" kern="0" dirty="0">
                 <a:solidFill>
                   <a:srgbClr val="FFFFFF"/>
                 </a:solidFill>
@@ -3861,13 +3946,16 @@
             <a:r>
               <a:rPr lang="en-US" sz="760" b="1" dirty="0">
                 <a:solidFill>
-                  <a:srgbClr val="D8432F"/>
-                </a:solidFill>
-                <a:latin typeface="Arial" pitchFamily="34" charset="0"/>
-                <a:ea typeface="Arial" pitchFamily="34" charset="-122"/>
-                <a:cs typeface="Arial" pitchFamily="34" charset="-120"/>
-              </a:rPr>
-              <a:t>[Chair name]</a:t>
+                  <a:srgbClr val="B8402F"/>
+                </a:solidFill>
+                <a:highlight>
+                  <a:srgbClr val="FFF1EE"/>
+                </a:highlight>
+                <a:latin typeface="Arial" pitchFamily="34" charset="0"/>
+                <a:ea typeface="Arial" pitchFamily="34" charset="-122"/>
+                <a:cs typeface="Arial" pitchFamily="34" charset="-120"/>
+              </a:rPr>
+              <a:t> Chair name </a:t>
             </a:r>
             <a:pPr indent="0" marL="0">
               <a:spcAft>
@@ -3895,13 +3983,16 @@
             <a:r>
               <a:rPr lang="en-US" sz="760" b="1" dirty="0">
                 <a:solidFill>
-                  <a:srgbClr val="D8432F"/>
-                </a:solidFill>
-                <a:latin typeface="Arial" pitchFamily="34" charset="0"/>
-                <a:ea typeface="Arial" pitchFamily="34" charset="-122"/>
-                <a:cs typeface="Arial" pitchFamily="34" charset="-120"/>
-              </a:rPr>
-              <a:t>[Affiliation]</a:t>
+                  <a:srgbClr val="B8402F"/>
+                </a:solidFill>
+                <a:highlight>
+                  <a:srgbClr val="FFF1EE"/>
+                </a:highlight>
+                <a:latin typeface="Arial" pitchFamily="34" charset="0"/>
+                <a:ea typeface="Arial" pitchFamily="34" charset="-122"/>
+                <a:cs typeface="Arial" pitchFamily="34" charset="-120"/>
+              </a:rPr>
+              <a:t> Affiliation </a:t>
             </a:r>
             <a:pPr indent="0" marL="0">
               <a:spcAft>
@@ -3921,13 +4012,16 @@
             <a:r>
               <a:rPr lang="en-US" sz="760" b="1" dirty="0">
                 <a:solidFill>
-                  <a:srgbClr val="D8432F"/>
-                </a:solidFill>
-                <a:latin typeface="Arial" pitchFamily="34" charset="0"/>
-                <a:ea typeface="Arial" pitchFamily="34" charset="-122"/>
-                <a:cs typeface="Arial" pitchFamily="34" charset="-120"/>
-              </a:rPr>
-              <a:t>[Co-chair name]</a:t>
+                  <a:srgbClr val="B8402F"/>
+                </a:solidFill>
+                <a:highlight>
+                  <a:srgbClr val="FFF1EE"/>
+                </a:highlight>
+                <a:latin typeface="Arial" pitchFamily="34" charset="0"/>
+                <a:ea typeface="Arial" pitchFamily="34" charset="-122"/>
+                <a:cs typeface="Arial" pitchFamily="34" charset="-120"/>
+              </a:rPr>
+              <a:t> Co-chair name </a:t>
             </a:r>
             <a:pPr indent="0" marL="0">
               <a:spcAft>
@@ -3955,13 +4049,16 @@
             <a:r>
               <a:rPr lang="en-US" sz="760" b="1" dirty="0">
                 <a:solidFill>
-                  <a:srgbClr val="D8432F"/>
-                </a:solidFill>
-                <a:latin typeface="Arial" pitchFamily="34" charset="0"/>
-                <a:ea typeface="Arial" pitchFamily="34" charset="-122"/>
-                <a:cs typeface="Arial" pitchFamily="34" charset="-120"/>
-              </a:rPr>
-              <a:t>[Affiliation]</a:t>
+                  <a:srgbClr val="B8402F"/>
+                </a:solidFill>
+                <a:highlight>
+                  <a:srgbClr val="FFF1EE"/>
+                </a:highlight>
+                <a:latin typeface="Arial" pitchFamily="34" charset="0"/>
+                <a:ea typeface="Arial" pitchFamily="34" charset="-122"/>
+                <a:cs typeface="Arial" pitchFamily="34" charset="-120"/>
+              </a:rPr>
+              <a:t> Affiliation </a:t>
             </a:r>
             <a:endParaRPr lang="en-US" sz="760" dirty="0"/>
           </a:p>
@@ -4036,13 +4133,16 @@
             <a:r>
               <a:rPr lang="en-US" sz="760" b="1" dirty="0">
                 <a:solidFill>
-                  <a:srgbClr val="D8432F"/>
-                </a:solidFill>
-                <a:latin typeface="Arial" pitchFamily="34" charset="0"/>
-                <a:ea typeface="Arial" pitchFamily="34" charset="-122"/>
-                <a:cs typeface="Arial" pitchFamily="34" charset="-120"/>
-              </a:rPr>
-              <a:t>[Member]</a:t>
+                  <a:srgbClr val="B8402F"/>
+                </a:solidFill>
+                <a:highlight>
+                  <a:srgbClr val="FFF1EE"/>
+                </a:highlight>
+                <a:latin typeface="Arial" pitchFamily="34" charset="0"/>
+                <a:ea typeface="Arial" pitchFamily="34" charset="-122"/>
+                <a:cs typeface="Arial" pitchFamily="34" charset="-120"/>
+              </a:rPr>
+              <a:t> Member </a:t>
             </a:r>
             <a:pPr indent="0" marL="0">
               <a:spcAft>
@@ -4070,13 +4170,16 @@
             <a:r>
               <a:rPr lang="en-US" sz="760" b="1" dirty="0">
                 <a:solidFill>
-                  <a:srgbClr val="D8432F"/>
-                </a:solidFill>
-                <a:latin typeface="Arial" pitchFamily="34" charset="0"/>
-                <a:ea typeface="Arial" pitchFamily="34" charset="-122"/>
-                <a:cs typeface="Arial" pitchFamily="34" charset="-120"/>
-              </a:rPr>
-              <a:t>[Affiliation]</a:t>
+                  <a:srgbClr val="B8402F"/>
+                </a:solidFill>
+                <a:highlight>
+                  <a:srgbClr val="FFF1EE"/>
+                </a:highlight>
+                <a:latin typeface="Arial" pitchFamily="34" charset="0"/>
+                <a:ea typeface="Arial" pitchFamily="34" charset="-122"/>
+                <a:cs typeface="Arial" pitchFamily="34" charset="-120"/>
+              </a:rPr>
+              <a:t> Affiliation </a:t>
             </a:r>
             <a:pPr indent="0" marL="0">
               <a:spcAft>
@@ -4096,13 +4199,16 @@
             <a:r>
               <a:rPr lang="en-US" sz="760" b="1" dirty="0">
                 <a:solidFill>
-                  <a:srgbClr val="D8432F"/>
-                </a:solidFill>
-                <a:latin typeface="Arial" pitchFamily="34" charset="0"/>
-                <a:ea typeface="Arial" pitchFamily="34" charset="-122"/>
-                <a:cs typeface="Arial" pitchFamily="34" charset="-120"/>
-              </a:rPr>
-              <a:t>[Member]</a:t>
+                  <a:srgbClr val="B8402F"/>
+                </a:solidFill>
+                <a:highlight>
+                  <a:srgbClr val="FFF1EE"/>
+                </a:highlight>
+                <a:latin typeface="Arial" pitchFamily="34" charset="0"/>
+                <a:ea typeface="Arial" pitchFamily="34" charset="-122"/>
+                <a:cs typeface="Arial" pitchFamily="34" charset="-120"/>
+              </a:rPr>
+              <a:t> Member </a:t>
             </a:r>
             <a:pPr indent="0" marL="0">
               <a:spcAft>
@@ -4130,13 +4236,16 @@
             <a:r>
               <a:rPr lang="en-US" sz="760" b="1" dirty="0">
                 <a:solidFill>
-                  <a:srgbClr val="D8432F"/>
-                </a:solidFill>
-                <a:latin typeface="Arial" pitchFamily="34" charset="0"/>
-                <a:ea typeface="Arial" pitchFamily="34" charset="-122"/>
-                <a:cs typeface="Arial" pitchFamily="34" charset="-120"/>
-              </a:rPr>
-              <a:t>[Affiliation]</a:t>
+                  <a:srgbClr val="B8402F"/>
+                </a:solidFill>
+                <a:highlight>
+                  <a:srgbClr val="FFF1EE"/>
+                </a:highlight>
+                <a:latin typeface="Arial" pitchFamily="34" charset="0"/>
+                <a:ea typeface="Arial" pitchFamily="34" charset="-122"/>
+                <a:cs typeface="Arial" pitchFamily="34" charset="-120"/>
+              </a:rPr>
+              <a:t> Affiliation </a:t>
             </a:r>
             <a:pPr indent="0" marL="0">
               <a:spcAft>
@@ -4156,13 +4265,16 @@
             <a:r>
               <a:rPr lang="en-US" sz="760" b="1" dirty="0">
                 <a:solidFill>
-                  <a:srgbClr val="D8432F"/>
-                </a:solidFill>
-                <a:latin typeface="Arial" pitchFamily="34" charset="0"/>
-                <a:ea typeface="Arial" pitchFamily="34" charset="-122"/>
-                <a:cs typeface="Arial" pitchFamily="34" charset="-120"/>
-              </a:rPr>
-              <a:t>[Member]</a:t>
+                  <a:srgbClr val="B8402F"/>
+                </a:solidFill>
+                <a:highlight>
+                  <a:srgbClr val="FFF1EE"/>
+                </a:highlight>
+                <a:latin typeface="Arial" pitchFamily="34" charset="0"/>
+                <a:ea typeface="Arial" pitchFamily="34" charset="-122"/>
+                <a:cs typeface="Arial" pitchFamily="34" charset="-120"/>
+              </a:rPr>
+              <a:t> Member </a:t>
             </a:r>
             <a:pPr indent="0" marL="0">
               <a:spcAft>
@@ -4190,13 +4302,16 @@
             <a:r>
               <a:rPr lang="en-US" sz="760" b="1" dirty="0">
                 <a:solidFill>
-                  <a:srgbClr val="D8432F"/>
-                </a:solidFill>
-                <a:latin typeface="Arial" pitchFamily="34" charset="0"/>
-                <a:ea typeface="Arial" pitchFamily="34" charset="-122"/>
-                <a:cs typeface="Arial" pitchFamily="34" charset="-120"/>
-              </a:rPr>
-              <a:t>[Affiliation]</a:t>
+                  <a:srgbClr val="B8402F"/>
+                </a:solidFill>
+                <a:highlight>
+                  <a:srgbClr val="FFF1EE"/>
+                </a:highlight>
+                <a:latin typeface="Arial" pitchFamily="34" charset="0"/>
+                <a:ea typeface="Arial" pitchFamily="34" charset="-122"/>
+                <a:cs typeface="Arial" pitchFamily="34" charset="-120"/>
+              </a:rPr>
+              <a:t> Affiliation </a:t>
             </a:r>
             <a:endParaRPr lang="en-US" sz="760" dirty="0"/>
           </a:p>
@@ -4271,13 +4386,16 @@
             <a:r>
               <a:rPr lang="en-US" sz="760" b="1" dirty="0">
                 <a:solidFill>
-                  <a:srgbClr val="D8432F"/>
-                </a:solidFill>
-                <a:latin typeface="Arial" pitchFamily="34" charset="0"/>
-                <a:ea typeface="Arial" pitchFamily="34" charset="-122"/>
-                <a:cs typeface="Arial" pitchFamily="34" charset="-120"/>
-              </a:rPr>
-              <a:t>[Member]</a:t>
+                  <a:srgbClr val="B8402F"/>
+                </a:solidFill>
+                <a:highlight>
+                  <a:srgbClr val="FFF1EE"/>
+                </a:highlight>
+                <a:latin typeface="Arial" pitchFamily="34" charset="0"/>
+                <a:ea typeface="Arial" pitchFamily="34" charset="-122"/>
+                <a:cs typeface="Arial" pitchFamily="34" charset="-120"/>
+              </a:rPr>
+              <a:t> Member </a:t>
             </a:r>
             <a:pPr indent="0" marL="0">
               <a:spcAft>
@@ -4305,13 +4423,16 @@
             <a:r>
               <a:rPr lang="en-US" sz="760" b="1" dirty="0">
                 <a:solidFill>
-                  <a:srgbClr val="D8432F"/>
-                </a:solidFill>
-                <a:latin typeface="Arial" pitchFamily="34" charset="0"/>
-                <a:ea typeface="Arial" pitchFamily="34" charset="-122"/>
-                <a:cs typeface="Arial" pitchFamily="34" charset="-120"/>
-              </a:rPr>
-              <a:t>[Affiliation, Country]</a:t>
+                  <a:srgbClr val="B8402F"/>
+                </a:solidFill>
+                <a:highlight>
+                  <a:srgbClr val="FFF1EE"/>
+                </a:highlight>
+                <a:latin typeface="Arial" pitchFamily="34" charset="0"/>
+                <a:ea typeface="Arial" pitchFamily="34" charset="-122"/>
+                <a:cs typeface="Arial" pitchFamily="34" charset="-120"/>
+              </a:rPr>
+              <a:t> Affiliation, Country </a:t>
             </a:r>
             <a:pPr indent="0" marL="0">
               <a:spcAft>
@@ -4331,13 +4452,16 @@
             <a:r>
               <a:rPr lang="en-US" sz="760" b="1" dirty="0">
                 <a:solidFill>
-                  <a:srgbClr val="D8432F"/>
-                </a:solidFill>
-                <a:latin typeface="Arial" pitchFamily="34" charset="0"/>
-                <a:ea typeface="Arial" pitchFamily="34" charset="-122"/>
-                <a:cs typeface="Arial" pitchFamily="34" charset="-120"/>
-              </a:rPr>
-              <a:t>[Member]</a:t>
+                  <a:srgbClr val="B8402F"/>
+                </a:solidFill>
+                <a:highlight>
+                  <a:srgbClr val="FFF1EE"/>
+                </a:highlight>
+                <a:latin typeface="Arial" pitchFamily="34" charset="0"/>
+                <a:ea typeface="Arial" pitchFamily="34" charset="-122"/>
+                <a:cs typeface="Arial" pitchFamily="34" charset="-120"/>
+              </a:rPr>
+              <a:t> Member </a:t>
             </a:r>
             <a:pPr indent="0" marL="0">
               <a:spcAft>
@@ -4365,13 +4489,16 @@
             <a:r>
               <a:rPr lang="en-US" sz="760" b="1" dirty="0">
                 <a:solidFill>
-                  <a:srgbClr val="D8432F"/>
-                </a:solidFill>
-                <a:latin typeface="Arial" pitchFamily="34" charset="0"/>
-                <a:ea typeface="Arial" pitchFamily="34" charset="-122"/>
-                <a:cs typeface="Arial" pitchFamily="34" charset="-120"/>
-              </a:rPr>
-              <a:t>[Affiliation, Country]</a:t>
+                  <a:srgbClr val="B8402F"/>
+                </a:solidFill>
+                <a:highlight>
+                  <a:srgbClr val="FFF1EE"/>
+                </a:highlight>
+                <a:latin typeface="Arial" pitchFamily="34" charset="0"/>
+                <a:ea typeface="Arial" pitchFamily="34" charset="-122"/>
+                <a:cs typeface="Arial" pitchFamily="34" charset="-120"/>
+              </a:rPr>
+              <a:t> Affiliation, Country </a:t>
             </a:r>
             <a:pPr indent="0" marL="0">
               <a:spcAft>
@@ -4391,13 +4518,16 @@
             <a:r>
               <a:rPr lang="en-US" sz="760" b="1" dirty="0">
                 <a:solidFill>
-                  <a:srgbClr val="D8432F"/>
-                </a:solidFill>
-                <a:latin typeface="Arial" pitchFamily="34" charset="0"/>
-                <a:ea typeface="Arial" pitchFamily="34" charset="-122"/>
-                <a:cs typeface="Arial" pitchFamily="34" charset="-120"/>
-              </a:rPr>
-              <a:t>[Member]</a:t>
+                  <a:srgbClr val="B8402F"/>
+                </a:solidFill>
+                <a:highlight>
+                  <a:srgbClr val="FFF1EE"/>
+                </a:highlight>
+                <a:latin typeface="Arial" pitchFamily="34" charset="0"/>
+                <a:ea typeface="Arial" pitchFamily="34" charset="-122"/>
+                <a:cs typeface="Arial" pitchFamily="34" charset="-120"/>
+              </a:rPr>
+              <a:t> Member </a:t>
             </a:r>
             <a:pPr indent="0" marL="0">
               <a:spcAft>
@@ -4425,13 +4555,16 @@
             <a:r>
               <a:rPr lang="en-US" sz="760" b="1" dirty="0">
                 <a:solidFill>
-                  <a:srgbClr val="D8432F"/>
-                </a:solidFill>
-                <a:latin typeface="Arial" pitchFamily="34" charset="0"/>
-                <a:ea typeface="Arial" pitchFamily="34" charset="-122"/>
-                <a:cs typeface="Arial" pitchFamily="34" charset="-120"/>
-              </a:rPr>
-              <a:t>[Affiliation, Country]</a:t>
+                  <a:srgbClr val="B8402F"/>
+                </a:solidFill>
+                <a:highlight>
+                  <a:srgbClr val="FFF1EE"/>
+                </a:highlight>
+                <a:latin typeface="Arial" pitchFamily="34" charset="0"/>
+                <a:ea typeface="Arial" pitchFamily="34" charset="-122"/>
+                <a:cs typeface="Arial" pitchFamily="34" charset="-120"/>
+              </a:rPr>
+              <a:t> Affiliation, Country </a:t>
             </a:r>
             <a:pPr indent="0" marL="0">
               <a:spcAft>
@@ -4451,13 +4584,16 @@
             <a:r>
               <a:rPr lang="en-US" sz="760" b="1" dirty="0">
                 <a:solidFill>
-                  <a:srgbClr val="D8432F"/>
-                </a:solidFill>
-                <a:latin typeface="Arial" pitchFamily="34" charset="0"/>
-                <a:ea typeface="Arial" pitchFamily="34" charset="-122"/>
-                <a:cs typeface="Arial" pitchFamily="34" charset="-120"/>
-              </a:rPr>
-              <a:t>[Member]</a:t>
+                  <a:srgbClr val="B8402F"/>
+                </a:solidFill>
+                <a:highlight>
+                  <a:srgbClr val="FFF1EE"/>
+                </a:highlight>
+                <a:latin typeface="Arial" pitchFamily="34" charset="0"/>
+                <a:ea typeface="Arial" pitchFamily="34" charset="-122"/>
+                <a:cs typeface="Arial" pitchFamily="34" charset="-120"/>
+              </a:rPr>
+              <a:t> Member </a:t>
             </a:r>
             <a:pPr indent="0" marL="0">
               <a:spcAft>
@@ -4485,13 +4621,16 @@
             <a:r>
               <a:rPr lang="en-US" sz="760" b="1" dirty="0">
                 <a:solidFill>
-                  <a:srgbClr val="D8432F"/>
-                </a:solidFill>
-                <a:latin typeface="Arial" pitchFamily="34" charset="0"/>
-                <a:ea typeface="Arial" pitchFamily="34" charset="-122"/>
-                <a:cs typeface="Arial" pitchFamily="34" charset="-120"/>
-              </a:rPr>
-              <a:t>[Affiliation, Country]</a:t>
+                  <a:srgbClr val="B8402F"/>
+                </a:solidFill>
+                <a:highlight>
+                  <a:srgbClr val="FFF1EE"/>
+                </a:highlight>
+                <a:latin typeface="Arial" pitchFamily="34" charset="0"/>
+                <a:ea typeface="Arial" pitchFamily="34" charset="-122"/>
+                <a:cs typeface="Arial" pitchFamily="34" charset="-120"/>
+              </a:rPr>
+              <a:t> Affiliation, Country </a:t>
             </a:r>
             <a:pPr indent="0" marL="0">
               <a:spcAft>
@@ -4511,13 +4650,16 @@
             <a:r>
               <a:rPr lang="en-US" sz="760" b="1" dirty="0">
                 <a:solidFill>
-                  <a:srgbClr val="D8432F"/>
-                </a:solidFill>
-                <a:latin typeface="Arial" pitchFamily="34" charset="0"/>
-                <a:ea typeface="Arial" pitchFamily="34" charset="-122"/>
-                <a:cs typeface="Arial" pitchFamily="34" charset="-120"/>
-              </a:rPr>
-              <a:t>[Member]</a:t>
+                  <a:srgbClr val="B8402F"/>
+                </a:solidFill>
+                <a:highlight>
+                  <a:srgbClr val="FFF1EE"/>
+                </a:highlight>
+                <a:latin typeface="Arial" pitchFamily="34" charset="0"/>
+                <a:ea typeface="Arial" pitchFamily="34" charset="-122"/>
+                <a:cs typeface="Arial" pitchFamily="34" charset="-120"/>
+              </a:rPr>
+              <a:t> Member </a:t>
             </a:r>
             <a:pPr indent="0" marL="0">
               <a:spcAft>
@@ -4545,13 +4687,16 @@
             <a:r>
               <a:rPr lang="en-US" sz="760" b="1" dirty="0">
                 <a:solidFill>
-                  <a:srgbClr val="D8432F"/>
-                </a:solidFill>
-                <a:latin typeface="Arial" pitchFamily="34" charset="0"/>
-                <a:ea typeface="Arial" pitchFamily="34" charset="-122"/>
-                <a:cs typeface="Arial" pitchFamily="34" charset="-120"/>
-              </a:rPr>
-              <a:t>[Affiliation, Country]</a:t>
+                  <a:srgbClr val="B8402F"/>
+                </a:solidFill>
+                <a:highlight>
+                  <a:srgbClr val="FFF1EE"/>
+                </a:highlight>
+                <a:latin typeface="Arial" pitchFamily="34" charset="0"/>
+                <a:ea typeface="Arial" pitchFamily="34" charset="-122"/>
+                <a:cs typeface="Arial" pitchFamily="34" charset="-120"/>
+              </a:rPr>
+              <a:t> Affiliation, Country </a:t>
             </a:r>
             <a:pPr indent="0" marL="0">
               <a:spcAft>
@@ -4571,13 +4716,16 @@
             <a:r>
               <a:rPr lang="en-US" sz="760" b="1" dirty="0">
                 <a:solidFill>
-                  <a:srgbClr val="D8432F"/>
-                </a:solidFill>
-                <a:latin typeface="Arial" pitchFamily="34" charset="0"/>
-                <a:ea typeface="Arial" pitchFamily="34" charset="-122"/>
-                <a:cs typeface="Arial" pitchFamily="34" charset="-120"/>
-              </a:rPr>
-              <a:t>[Member]</a:t>
+                  <a:srgbClr val="B8402F"/>
+                </a:solidFill>
+                <a:highlight>
+                  <a:srgbClr val="FFF1EE"/>
+                </a:highlight>
+                <a:latin typeface="Arial" pitchFamily="34" charset="0"/>
+                <a:ea typeface="Arial" pitchFamily="34" charset="-122"/>
+                <a:cs typeface="Arial" pitchFamily="34" charset="-120"/>
+              </a:rPr>
+              <a:t> Member </a:t>
             </a:r>
             <a:pPr indent="0" marL="0">
               <a:spcAft>
@@ -4605,13 +4753,16 @@
             <a:r>
               <a:rPr lang="en-US" sz="760" b="1" dirty="0">
                 <a:solidFill>
-                  <a:srgbClr val="D8432F"/>
-                </a:solidFill>
-                <a:latin typeface="Arial" pitchFamily="34" charset="0"/>
-                <a:ea typeface="Arial" pitchFamily="34" charset="-122"/>
-                <a:cs typeface="Arial" pitchFamily="34" charset="-120"/>
-              </a:rPr>
-              <a:t>[Affiliation, Country]</a:t>
+                  <a:srgbClr val="B8402F"/>
+                </a:solidFill>
+                <a:highlight>
+                  <a:srgbClr val="FFF1EE"/>
+                </a:highlight>
+                <a:latin typeface="Arial" pitchFamily="34" charset="0"/>
+                <a:ea typeface="Arial" pitchFamily="34" charset="-122"/>
+                <a:cs typeface="Arial" pitchFamily="34" charset="-120"/>
+              </a:rPr>
+              <a:t> Affiliation, Country </a:t>
             </a:r>
             <a:endParaRPr lang="en-US" sz="760" dirty="0"/>
           </a:p>
@@ -4686,13 +4837,16 @@
             <a:r>
               <a:rPr lang="en-US" sz="760" b="1" dirty="0">
                 <a:solidFill>
-                  <a:srgbClr val="D8432F"/>
-                </a:solidFill>
-                <a:latin typeface="Arial" pitchFamily="34" charset="0"/>
-                <a:ea typeface="Arial" pitchFamily="34" charset="-122"/>
-                <a:cs typeface="Arial" pitchFamily="34" charset="-120"/>
-              </a:rPr>
-              <a:t>[Coordinator name]</a:t>
+                  <a:srgbClr val="B8402F"/>
+                </a:solidFill>
+                <a:highlight>
+                  <a:srgbClr val="FFF1EE"/>
+                </a:highlight>
+                <a:latin typeface="Arial" pitchFamily="34" charset="0"/>
+                <a:ea typeface="Arial" pitchFamily="34" charset="-122"/>
+                <a:cs typeface="Arial" pitchFamily="34" charset="-120"/>
+              </a:rPr>
+              <a:t> Coordinator name </a:t>
             </a:r>
             <a:pPr indent="0" marL="0">
               <a:spcAft>
@@ -4729,13 +4883,16 @@
             <a:r>
               <a:rPr lang="en-US" sz="760" b="1" dirty="0">
                 <a:solidFill>
-                  <a:srgbClr val="D8432F"/>
-                </a:solidFill>
-                <a:latin typeface="Arial" pitchFamily="34" charset="0"/>
-                <a:ea typeface="Arial" pitchFamily="34" charset="-122"/>
-                <a:cs typeface="Arial" pitchFamily="34" charset="-120"/>
-              </a:rPr>
-              <a:t>[ilcec2027@___.ac.kr]</a:t>
+                  <a:srgbClr val="B8402F"/>
+                </a:solidFill>
+                <a:highlight>
+                  <a:srgbClr val="FFF1EE"/>
+                </a:highlight>
+                <a:latin typeface="Arial" pitchFamily="34" charset="0"/>
+                <a:ea typeface="Arial" pitchFamily="34" charset="-122"/>
+                <a:cs typeface="Arial" pitchFamily="34" charset="-120"/>
+              </a:rPr>
+              <a:t> ilcec2027@___.ac.kr </a:t>
             </a:r>
             <a:endParaRPr lang="en-US" sz="760" dirty="0"/>
           </a:p>
@@ -4808,15 +4965,18 @@
               <a:buNone/>
             </a:pPr>
             <a:r>
-              <a:rPr lang="en-US" sz="760" b="1" u="sng" dirty="0">
-                <a:solidFill>
-                  <a:srgbClr val="D8432F"/>
-                </a:solidFill>
-                <a:latin typeface="Arial" pitchFamily="34" charset="0"/>
-                <a:ea typeface="Arial" pitchFamily="34" charset="-122"/>
-                <a:cs typeface="Arial" pitchFamily="34" charset="-120"/>
-              </a:rPr>
-              <a:t>[https://ilcec2027.___]</a:t>
+              <a:rPr lang="en-US" sz="760" b="1" dirty="0">
+                <a:solidFill>
+                  <a:srgbClr val="B8402F"/>
+                </a:solidFill>
+                <a:highlight>
+                  <a:srgbClr val="FFF1EE"/>
+                </a:highlight>
+                <a:latin typeface="Arial" pitchFamily="34" charset="0"/>
+                <a:ea typeface="Arial" pitchFamily="34" charset="-122"/>
+                <a:cs typeface="Arial" pitchFamily="34" charset="-120"/>
+              </a:rPr>
+              <a:t> https://ilcec2027.___ </a:t>
             </a:r>
             <a:endParaRPr lang="en-US" sz="760" dirty="0"/>
           </a:p>
@@ -4843,8 +5003,10 @@
             <a:off x="429768" y="7818120"/>
             <a:ext cx="1563624" cy="1280160"/>
           </a:xfrm>
-          <a:prstGeom prst="rect">
-            <a:avLst/>
+          <a:prstGeom prst="roundRect">
+            <a:avLst>
+              <a:gd name="adj" fmla="val 5714"/>
+            </a:avLst>
           </a:prstGeom>
         </p:spPr>
       </p:pic>
@@ -4869,8 +5031,10 @@
             <a:off x="2084832" y="7818120"/>
             <a:ext cx="1563624" cy="1280160"/>
           </a:xfrm>
-          <a:prstGeom prst="rect">
-            <a:avLst/>
+          <a:prstGeom prst="roundRect">
+            <a:avLst>
+              <a:gd name="adj" fmla="val 5714"/>
+            </a:avLst>
           </a:prstGeom>
         </p:spPr>
       </p:pic>
@@ -5268,13 +5432,16 @@
             <a:r>
               <a:rPr lang="en-US" sz="760" b="1" dirty="0">
                 <a:solidFill>
-                  <a:srgbClr val="D8432F"/>
-                </a:solidFill>
-                <a:latin typeface="Arial" pitchFamily="34" charset="0"/>
-                <a:ea typeface="Arial" pitchFamily="34" charset="-122"/>
-                <a:cs typeface="Arial" pitchFamily="34" charset="-120"/>
-              </a:rPr>
-              <a:t>[Day 1]</a:t>
+                  <a:srgbClr val="B8402F"/>
+                </a:solidFill>
+                <a:highlight>
+                  <a:srgbClr val="FFF1EE"/>
+                </a:highlight>
+                <a:latin typeface="Arial" pitchFamily="34" charset="0"/>
+                <a:ea typeface="Arial" pitchFamily="34" charset="-122"/>
+                <a:cs typeface="Arial" pitchFamily="34" charset="-120"/>
+              </a:rPr>
+              <a:t> Day 1 </a:t>
             </a:r>
             <a:pPr indent="0" marL="0">
               <a:spcAft>
@@ -5348,13 +5515,16 @@
             <a:r>
               <a:rPr lang="en-US" sz="760" b="1" dirty="0">
                 <a:solidFill>
-                  <a:srgbClr val="D8432F"/>
-                </a:solidFill>
-                <a:latin typeface="Arial" pitchFamily="34" charset="0"/>
-                <a:ea typeface="Arial" pitchFamily="34" charset="-122"/>
-                <a:cs typeface="Arial" pitchFamily="34" charset="-120"/>
-              </a:rPr>
-              <a:t>[Day 3]</a:t>
+                  <a:srgbClr val="B8402F"/>
+                </a:solidFill>
+                <a:highlight>
+                  <a:srgbClr val="FFF1EE"/>
+                </a:highlight>
+                <a:latin typeface="Arial" pitchFamily="34" charset="0"/>
+                <a:ea typeface="Arial" pitchFamily="34" charset="-122"/>
+                <a:cs typeface="Arial" pitchFamily="34" charset="-120"/>
+              </a:rPr>
+              <a:t> Day 3 </a:t>
             </a:r>
             <a:pPr indent="0" marL="0">
               <a:spcAft>
@@ -5428,13 +5598,16 @@
             <a:r>
               <a:rPr lang="en-US" sz="760" b="1" dirty="0">
                 <a:solidFill>
-                  <a:srgbClr val="D8432F"/>
-                </a:solidFill>
-                <a:latin typeface="Arial" pitchFamily="34" charset="0"/>
-                <a:ea typeface="Arial" pitchFamily="34" charset="-122"/>
-                <a:cs typeface="Arial" pitchFamily="34" charset="-120"/>
-              </a:rPr>
-              <a:t>[Day 4]</a:t>
+                  <a:srgbClr val="B8402F"/>
+                </a:solidFill>
+                <a:highlight>
+                  <a:srgbClr val="FFF1EE"/>
+                </a:highlight>
+                <a:latin typeface="Arial" pitchFamily="34" charset="0"/>
+                <a:ea typeface="Arial" pitchFamily="34" charset="-122"/>
+                <a:cs typeface="Arial" pitchFamily="34" charset="-120"/>
+              </a:rPr>
+              <a:t> Day 4 </a:t>
             </a:r>
             <a:pPr indent="0" marL="0">
               <a:spcAft>

</xml_diff>

<commit_message>
Restore the flyer PDF design and match the PPTX to it
The HTML/PDF flyer goes back to its Manrope/Inter design with dashed
TBD badges. The PPTX now uses the same typefaces (TTF copies with OFL
licences are included for installation), the same title, badge and
credit styling, and keeps the rounded photos, wash and DRAFT ribbon.

Co-Authored-By: Claude Fable 5.1 <noreply@anthropic.com>
Claude-Session: https://claude.ai/code/session_0176bT1uqbE7ABLdKoQNCaUr
</commit_message>
<xml_diff>
--- a/ilcec2027/ILCEC_2027_First_Announcement_DRAFT.pptx
+++ b/ilcec2027/ILCEC_2027_First_Announcement_DRAFT.pptx
@@ -1385,9 +1385,9 @@
                 <a:solidFill>
                   <a:srgbClr val="FFFFFF"/>
                 </a:solidFill>
-                <a:latin typeface="Arial" pitchFamily="34" charset="0"/>
-                <a:ea typeface="Arial" pitchFamily="34" charset="-122"/>
-                <a:cs typeface="Arial" pitchFamily="34" charset="-120"/>
+                <a:latin typeface="Manrope" pitchFamily="34" charset="0"/>
+                <a:ea typeface="Manrope" pitchFamily="34" charset="-122"/>
+                <a:cs typeface="Manrope" pitchFamily="34" charset="-120"/>
               </a:rPr>
               <a:t>SEOUL  ·  KOREA  ·  2027</a:t>
             </a:r>
@@ -1452,7 +1452,7 @@
         <p:spPr>
           <a:xfrm>
             <a:off x="429768" y="2286000"/>
-            <a:ext cx="4343400" cy="868680"/>
+            <a:ext cx="4663440" cy="868680"/>
           </a:xfrm>
           <a:prstGeom prst="rect">
             <a:avLst/>
@@ -1471,17 +1471,17 @@
               <a:buNone/>
             </a:pPr>
             <a:r>
-              <a:rPr lang="en-US" sz="2600" b="1" dirty="0">
+              <a:rPr lang="en-US" sz="2500" b="1" spc="-40" kern="0" dirty="0">
                 <a:solidFill>
                   <a:srgbClr val="1B2450"/>
                 </a:solidFill>
-                <a:latin typeface="Arial" pitchFamily="34" charset="0"/>
-                <a:ea typeface="Arial" pitchFamily="34" charset="-122"/>
-                <a:cs typeface="Arial" pitchFamily="34" charset="-120"/>
+                <a:latin typeface="Manrope" pitchFamily="34" charset="0"/>
+                <a:ea typeface="Manrope" pitchFamily="34" charset="-122"/>
+                <a:cs typeface="Manrope" pitchFamily="34" charset="-120"/>
               </a:rPr>
               <a:t>International Liquid Crystal</a:t>
             </a:r>
-            <a:endParaRPr lang="en-US" sz="2600" dirty="0"/>
+            <a:endParaRPr lang="en-US" sz="2500" dirty="0"/>
           </a:p>
           <a:p>
             <a:pPr indent="0" marL="0">
@@ -1491,17 +1491,17 @@
               <a:buNone/>
             </a:pPr>
             <a:r>
-              <a:rPr lang="en-US" sz="2600" b="1" dirty="0">
+              <a:rPr lang="en-US" sz="2500" b="1" spc="-40" kern="0" dirty="0">
                 <a:solidFill>
                   <a:srgbClr val="1B2450"/>
                 </a:solidFill>
-                <a:latin typeface="Arial" pitchFamily="34" charset="0"/>
-                <a:ea typeface="Arial" pitchFamily="34" charset="-122"/>
-                <a:cs typeface="Arial" pitchFamily="34" charset="-120"/>
+                <a:latin typeface="Manrope" pitchFamily="34" charset="0"/>
+                <a:ea typeface="Manrope" pitchFamily="34" charset="-122"/>
+                <a:cs typeface="Manrope" pitchFamily="34" charset="-120"/>
               </a:rPr>
               <a:t>Elastomer Conference</a:t>
             </a:r>
-            <a:endParaRPr lang="en-US" sz="2600" dirty="0"/>
+            <a:endParaRPr lang="en-US" sz="2500" dirty="0"/>
           </a:p>
         </p:txBody>
       </p:sp>
@@ -1537,9 +1537,9 @@
                 <a:solidFill>
                   <a:srgbClr val="D8432F"/>
                 </a:solidFill>
-                <a:latin typeface="Arial" pitchFamily="34" charset="0"/>
-                <a:ea typeface="Arial" pitchFamily="34" charset="-122"/>
-                <a:cs typeface="Arial" pitchFamily="34" charset="-120"/>
+                <a:latin typeface="Manrope" pitchFamily="34" charset="0"/>
+                <a:ea typeface="Manrope" pitchFamily="34" charset="-122"/>
+                <a:cs typeface="Manrope" pitchFamily="34" charset="-120"/>
               </a:rPr>
               <a:t>ILCEC 2027</a:t>
             </a:r>
@@ -1557,9 +1557,9 @@
                 <a:solidFill>
                   <a:srgbClr val="2C3A7A"/>
                 </a:solidFill>
-                <a:latin typeface="Arial" pitchFamily="34" charset="0"/>
-                <a:ea typeface="Arial" pitchFamily="34" charset="-122"/>
-                <a:cs typeface="Arial" pitchFamily="34" charset="-120"/>
+                <a:latin typeface="Manrope" pitchFamily="34" charset="0"/>
+                <a:ea typeface="Manrope" pitchFamily="34" charset="-122"/>
+                <a:cs typeface="Manrope" pitchFamily="34" charset="-120"/>
               </a:rPr>
               <a:t>on </a:t>
             </a:r>
@@ -1577,9 +1577,9 @@
                 <a:highlight>
                   <a:srgbClr val="FFF1EE"/>
                 </a:highlight>
-                <a:latin typeface="Arial" pitchFamily="34" charset="0"/>
-                <a:ea typeface="Arial" pitchFamily="34" charset="-122"/>
-                <a:cs typeface="Arial" pitchFamily="34" charset="-120"/>
+                <a:latin typeface="Manrope" pitchFamily="34" charset="0"/>
+                <a:ea typeface="Manrope" pitchFamily="34" charset="-122"/>
+                <a:cs typeface="Manrope" pitchFamily="34" charset="-120"/>
               </a:rPr>
               <a:t> DD–DD Month 2027 </a:t>
             </a:r>
@@ -1597,9 +1597,9 @@
                 <a:solidFill>
                   <a:srgbClr val="2C3A7A"/>
                 </a:solidFill>
-                <a:latin typeface="Arial" pitchFamily="34" charset="0"/>
-                <a:ea typeface="Arial" pitchFamily="34" charset="-122"/>
-                <a:cs typeface="Arial" pitchFamily="34" charset="-120"/>
+                <a:latin typeface="Manrope" pitchFamily="34" charset="0"/>
+                <a:ea typeface="Manrope" pitchFamily="34" charset="-122"/>
+                <a:cs typeface="Manrope" pitchFamily="34" charset="-120"/>
               </a:rPr>
               <a:t>in Seoul, Republic of Korea</a:t>
             </a:r>
@@ -1645,9 +1645,9 @@
                 <a:solidFill>
                   <a:srgbClr val="FFFFFF"/>
                 </a:solidFill>
-                <a:latin typeface="Arial" pitchFamily="34" charset="0"/>
-                <a:ea typeface="Arial" pitchFamily="34" charset="-122"/>
-                <a:cs typeface="Arial" pitchFamily="34" charset="-120"/>
+                <a:latin typeface="Manrope" pitchFamily="34" charset="0"/>
+                <a:ea typeface="Manrope" pitchFamily="34" charset="-122"/>
+                <a:cs typeface="Manrope" pitchFamily="34" charset="-120"/>
               </a:rPr>
               <a:t>DRAFT · TBD</a:t>
             </a:r>
@@ -1687,9 +1687,9 @@
                 <a:solidFill>
                   <a:srgbClr val="2C3A7A"/>
                 </a:solidFill>
-                <a:latin typeface="Arial" pitchFamily="34" charset="0"/>
-                <a:ea typeface="Arial" pitchFamily="34" charset="-122"/>
-                <a:cs typeface="Arial" pitchFamily="34" charset="-120"/>
+                <a:latin typeface="Inter" pitchFamily="34" charset="0"/>
+                <a:ea typeface="Inter" pitchFamily="34" charset="-122"/>
+                <a:cs typeface="Inter" pitchFamily="34" charset="-120"/>
               </a:rPr>
               <a:t>The International Liquid Crystal Elastomer Conference (ILCEC) will be held in </a:t>
             </a:r>
@@ -1704,9 +1704,9 @@
                 <a:solidFill>
                   <a:srgbClr val="1B2450"/>
                 </a:solidFill>
-                <a:latin typeface="Arial" pitchFamily="34" charset="0"/>
-                <a:ea typeface="Arial" pitchFamily="34" charset="-122"/>
-                <a:cs typeface="Arial" pitchFamily="34" charset="-120"/>
+                <a:latin typeface="Inter" pitchFamily="34" charset="0"/>
+                <a:ea typeface="Inter" pitchFamily="34" charset="-122"/>
+                <a:cs typeface="Inter" pitchFamily="34" charset="-120"/>
               </a:rPr>
               <a:t>2027 at the Royal Hotel Seoul, Myeongdong</a:t>
             </a:r>
@@ -1721,9 +1721,9 @@
                 <a:solidFill>
                   <a:srgbClr val="2C3A7A"/>
                 </a:solidFill>
-                <a:latin typeface="Arial" pitchFamily="34" charset="0"/>
-                <a:ea typeface="Arial" pitchFamily="34" charset="-122"/>
-                <a:cs typeface="Arial" pitchFamily="34" charset="-120"/>
+                <a:latin typeface="Inter" pitchFamily="34" charset="0"/>
+                <a:ea typeface="Inter" pitchFamily="34" charset="-122"/>
+                <a:cs typeface="Inter" pitchFamily="34" charset="-120"/>
               </a:rPr>
               <a:t>, in the heart of Seoul, Republic of Korea. Following ILCEC 2025 in Tampere, ILCEC 2027 will bring together chemists, physicists and engineers to share fundamental advances and application opportunities for this exciting class of materials. The conference will cover, but is not limited to, dynamic and multiresponsive LCEs, soft mechanics and actuation, 4D printing, feedback-driven and autonomous motion, tunable photonics, and novel behaviour and functions of LCEs. Contributions on related stimuli-responsive soft materials are also welcome. We hope you will consider joining us in Seoul!</a:t>
             </a:r>
@@ -1760,9 +1760,9 @@
                 <a:solidFill>
                   <a:srgbClr val="D8432F"/>
                 </a:solidFill>
-                <a:latin typeface="Arial" pitchFamily="34" charset="0"/>
-                <a:ea typeface="Arial" pitchFamily="34" charset="-122"/>
-                <a:cs typeface="Arial" pitchFamily="34" charset="-120"/>
+                <a:latin typeface="Manrope" pitchFamily="34" charset="0"/>
+                <a:ea typeface="Manrope" pitchFamily="34" charset="-122"/>
+                <a:cs typeface="Manrope" pitchFamily="34" charset="-120"/>
               </a:rPr>
               <a:t>Chairs</a:t>
             </a:r>
@@ -1798,16 +1798,16 @@
               <a:buNone/>
             </a:pPr>
             <a:r>
-              <a:rPr lang="en-US" sz="760" b="1" dirty="0">
+              <a:rPr lang="en-US" sz="700" b="1" dirty="0">
                 <a:solidFill>
                   <a:srgbClr val="B8402F"/>
                 </a:solidFill>
                 <a:highlight>
                   <a:srgbClr val="FFF1EE"/>
                 </a:highlight>
-                <a:latin typeface="Arial" pitchFamily="34" charset="0"/>
-                <a:ea typeface="Arial" pitchFamily="34" charset="-122"/>
-                <a:cs typeface="Arial" pitchFamily="34" charset="-120"/>
+                <a:latin typeface="Manrope" pitchFamily="34" charset="0"/>
+                <a:ea typeface="Manrope" pitchFamily="34" charset="-122"/>
+                <a:cs typeface="Manrope" pitchFamily="34" charset="-120"/>
               </a:rPr>
               <a:t> Chair name </a:t>
             </a:r>
@@ -1822,9 +1822,9 @@
                 <a:solidFill>
                   <a:srgbClr val="262B3D"/>
                 </a:solidFill>
-                <a:latin typeface="Arial" pitchFamily="34" charset="0"/>
-                <a:ea typeface="Arial" pitchFamily="34" charset="-122"/>
-                <a:cs typeface="Arial" pitchFamily="34" charset="-120"/>
+                <a:latin typeface="Inter" pitchFamily="34" charset="0"/>
+                <a:ea typeface="Inter" pitchFamily="34" charset="-122"/>
+                <a:cs typeface="Inter" pitchFamily="34" charset="-120"/>
               </a:rPr>
               <a:t>, </a:t>
             </a:r>
@@ -1835,16 +1835,16 @@
               <a:buNone/>
             </a:pPr>
             <a:r>
-              <a:rPr lang="en-US" sz="760" b="1" dirty="0">
+              <a:rPr lang="en-US" sz="700" b="1" dirty="0">
                 <a:solidFill>
                   <a:srgbClr val="B8402F"/>
                 </a:solidFill>
                 <a:highlight>
                   <a:srgbClr val="FFF1EE"/>
                 </a:highlight>
-                <a:latin typeface="Arial" pitchFamily="34" charset="0"/>
-                <a:ea typeface="Arial" pitchFamily="34" charset="-122"/>
-                <a:cs typeface="Arial" pitchFamily="34" charset="-120"/>
+                <a:latin typeface="Manrope" pitchFamily="34" charset="0"/>
+                <a:ea typeface="Manrope" pitchFamily="34" charset="-122"/>
+                <a:cs typeface="Manrope" pitchFamily="34" charset="-120"/>
               </a:rPr>
               <a:t> Affiliation </a:t>
             </a:r>
@@ -1864,16 +1864,16 @@
               <a:buNone/>
             </a:pPr>
             <a:r>
-              <a:rPr lang="en-US" sz="760" b="1" dirty="0">
+              <a:rPr lang="en-US" sz="700" b="1" dirty="0">
                 <a:solidFill>
                   <a:srgbClr val="B8402F"/>
                 </a:solidFill>
                 <a:highlight>
                   <a:srgbClr val="FFF1EE"/>
                 </a:highlight>
-                <a:latin typeface="Arial" pitchFamily="34" charset="0"/>
-                <a:ea typeface="Arial" pitchFamily="34" charset="-122"/>
-                <a:cs typeface="Arial" pitchFamily="34" charset="-120"/>
+                <a:latin typeface="Manrope" pitchFamily="34" charset="0"/>
+                <a:ea typeface="Manrope" pitchFamily="34" charset="-122"/>
+                <a:cs typeface="Manrope" pitchFamily="34" charset="-120"/>
               </a:rPr>
               <a:t> Co-chair name </a:t>
             </a:r>
@@ -1888,9 +1888,9 @@
                 <a:solidFill>
                   <a:srgbClr val="262B3D"/>
                 </a:solidFill>
-                <a:latin typeface="Arial" pitchFamily="34" charset="0"/>
-                <a:ea typeface="Arial" pitchFamily="34" charset="-122"/>
-                <a:cs typeface="Arial" pitchFamily="34" charset="-120"/>
+                <a:latin typeface="Inter" pitchFamily="34" charset="0"/>
+                <a:ea typeface="Inter" pitchFamily="34" charset="-122"/>
+                <a:cs typeface="Inter" pitchFamily="34" charset="-120"/>
               </a:rPr>
               <a:t>, </a:t>
             </a:r>
@@ -1901,16 +1901,16 @@
               <a:buNone/>
             </a:pPr>
             <a:r>
-              <a:rPr lang="en-US" sz="760" b="1" dirty="0">
+              <a:rPr lang="en-US" sz="700" b="1" dirty="0">
                 <a:solidFill>
                   <a:srgbClr val="B8402F"/>
                 </a:solidFill>
                 <a:highlight>
                   <a:srgbClr val="FFF1EE"/>
                 </a:highlight>
-                <a:latin typeface="Arial" pitchFamily="34" charset="0"/>
-                <a:ea typeface="Arial" pitchFamily="34" charset="-122"/>
-                <a:cs typeface="Arial" pitchFamily="34" charset="-120"/>
+                <a:latin typeface="Manrope" pitchFamily="34" charset="0"/>
+                <a:ea typeface="Manrope" pitchFamily="34" charset="-122"/>
+                <a:cs typeface="Manrope" pitchFamily="34" charset="-120"/>
               </a:rPr>
               <a:t> Affiliation </a:t>
             </a:r>
@@ -1947,9 +1947,9 @@
                 <a:solidFill>
                   <a:srgbClr val="D8432F"/>
                 </a:solidFill>
-                <a:latin typeface="Arial" pitchFamily="34" charset="0"/>
-                <a:ea typeface="Arial" pitchFamily="34" charset="-122"/>
-                <a:cs typeface="Arial" pitchFamily="34" charset="-120"/>
+                <a:latin typeface="Manrope" pitchFamily="34" charset="0"/>
+                <a:ea typeface="Manrope" pitchFamily="34" charset="-122"/>
+                <a:cs typeface="Manrope" pitchFamily="34" charset="-120"/>
               </a:rPr>
               <a:t>Contact</a:t>
             </a:r>
@@ -1985,16 +1985,16 @@
               <a:buNone/>
             </a:pPr>
             <a:r>
-              <a:rPr lang="en-US" sz="760" b="1" dirty="0">
+              <a:rPr lang="en-US" sz="700" b="1" dirty="0">
                 <a:solidFill>
                   <a:srgbClr val="B8402F"/>
                 </a:solidFill>
                 <a:highlight>
                   <a:srgbClr val="FFF1EE"/>
                 </a:highlight>
-                <a:latin typeface="Arial" pitchFamily="34" charset="0"/>
-                <a:ea typeface="Arial" pitchFamily="34" charset="-122"/>
-                <a:cs typeface="Arial" pitchFamily="34" charset="-120"/>
+                <a:latin typeface="Manrope" pitchFamily="34" charset="0"/>
+                <a:ea typeface="Manrope" pitchFamily="34" charset="-122"/>
+                <a:cs typeface="Manrope" pitchFamily="34" charset="-120"/>
               </a:rPr>
               <a:t> Coordinator name </a:t>
             </a:r>
@@ -2009,9 +2009,9 @@
                 <a:solidFill>
                   <a:srgbClr val="262B3D"/>
                 </a:solidFill>
-                <a:latin typeface="Arial" pitchFamily="34" charset="0"/>
-                <a:ea typeface="Arial" pitchFamily="34" charset="-122"/>
-                <a:cs typeface="Arial" pitchFamily="34" charset="-120"/>
+                <a:latin typeface="Inter" pitchFamily="34" charset="0"/>
+                <a:ea typeface="Inter" pitchFamily="34" charset="-122"/>
+                <a:cs typeface="Inter" pitchFamily="34" charset="-120"/>
               </a:rPr>
               <a:t>, conference coordinator</a:t>
             </a:r>
@@ -2031,16 +2031,16 @@
               <a:buNone/>
             </a:pPr>
             <a:r>
-              <a:rPr lang="en-US" sz="760" b="1" dirty="0">
+              <a:rPr lang="en-US" sz="700" b="1" dirty="0">
                 <a:solidFill>
                   <a:srgbClr val="B8402F"/>
                 </a:solidFill>
                 <a:highlight>
                   <a:srgbClr val="FFF1EE"/>
                 </a:highlight>
-                <a:latin typeface="Arial" pitchFamily="34" charset="0"/>
-                <a:ea typeface="Arial" pitchFamily="34" charset="-122"/>
-                <a:cs typeface="Arial" pitchFamily="34" charset="-120"/>
+                <a:latin typeface="Manrope" pitchFamily="34" charset="0"/>
+                <a:ea typeface="Manrope" pitchFamily="34" charset="-122"/>
+                <a:cs typeface="Manrope" pitchFamily="34" charset="-120"/>
               </a:rPr>
               <a:t> ilcec2027@___.ac.kr </a:t>
             </a:r>
@@ -2077,9 +2077,9 @@
                 <a:solidFill>
                   <a:srgbClr val="D8432F"/>
                 </a:solidFill>
-                <a:latin typeface="Arial" pitchFamily="34" charset="0"/>
-                <a:ea typeface="Arial" pitchFamily="34" charset="-122"/>
-                <a:cs typeface="Arial" pitchFamily="34" charset="-120"/>
+                <a:latin typeface="Manrope" pitchFamily="34" charset="0"/>
+                <a:ea typeface="Manrope" pitchFamily="34" charset="-122"/>
+                <a:cs typeface="Manrope" pitchFamily="34" charset="-120"/>
               </a:rPr>
               <a:t>Important dates</a:t>
             </a:r>
@@ -2115,16 +2115,16 @@
               <a:buNone/>
             </a:pPr>
             <a:r>
-              <a:rPr lang="en-US" sz="760" b="1" dirty="0">
+              <a:rPr lang="en-US" sz="700" b="1" dirty="0">
                 <a:solidFill>
                   <a:srgbClr val="B8402F"/>
                 </a:solidFill>
                 <a:highlight>
                   <a:srgbClr val="FFF1EE"/>
                 </a:highlight>
-                <a:latin typeface="Arial" pitchFamily="34" charset="0"/>
-                <a:ea typeface="Arial" pitchFamily="34" charset="-122"/>
-                <a:cs typeface="Arial" pitchFamily="34" charset="-120"/>
+                <a:latin typeface="Manrope" pitchFamily="34" charset="0"/>
+                <a:ea typeface="Manrope" pitchFamily="34" charset="-122"/>
+                <a:cs typeface="Manrope" pitchFamily="34" charset="-120"/>
               </a:rPr>
               <a:t> TBD </a:t>
             </a:r>
@@ -2164,11 +2164,11 @@
                 <a:solidFill>
                   <a:srgbClr val="262B3D"/>
                 </a:solidFill>
-                <a:latin typeface="Arial" pitchFamily="34" charset="0"/>
-                <a:ea typeface="Arial" pitchFamily="34" charset="-122"/>
-                <a:cs typeface="Arial" pitchFamily="34" charset="-120"/>
-              </a:rPr>
-              <a:t>2nd announcement with keynote speakers and key dates</a:t>
+                <a:latin typeface="Inter" pitchFamily="34" charset="0"/>
+                <a:ea typeface="Inter" pitchFamily="34" charset="-122"/>
+                <a:cs typeface="Inter" pitchFamily="34" charset="-120"/>
+              </a:rPr>
+              <a:t>2nd announcement: speakers and key dates</a:t>
             </a:r>
             <a:endParaRPr lang="en-US" sz="760" dirty="0"/>
           </a:p>
@@ -2202,16 +2202,16 @@
               <a:buNone/>
             </a:pPr>
             <a:r>
-              <a:rPr lang="en-US" sz="760" b="1" dirty="0">
+              <a:rPr lang="en-US" sz="700" b="1" dirty="0">
                 <a:solidFill>
                   <a:srgbClr val="B8402F"/>
                 </a:solidFill>
                 <a:highlight>
                   <a:srgbClr val="FFF1EE"/>
                 </a:highlight>
-                <a:latin typeface="Arial" pitchFamily="34" charset="0"/>
-                <a:ea typeface="Arial" pitchFamily="34" charset="-122"/>
-                <a:cs typeface="Arial" pitchFamily="34" charset="-120"/>
+                <a:latin typeface="Manrope" pitchFamily="34" charset="0"/>
+                <a:ea typeface="Manrope" pitchFamily="34" charset="-122"/>
+                <a:cs typeface="Manrope" pitchFamily="34" charset="-120"/>
               </a:rPr>
               <a:t> TBD </a:t>
             </a:r>
@@ -2251,9 +2251,9 @@
                 <a:solidFill>
                   <a:srgbClr val="262B3D"/>
                 </a:solidFill>
-                <a:latin typeface="Arial" pitchFamily="34" charset="0"/>
-                <a:ea typeface="Arial" pitchFamily="34" charset="-122"/>
-                <a:cs typeface="Arial" pitchFamily="34" charset="-120"/>
+                <a:latin typeface="Inter" pitchFamily="34" charset="0"/>
+                <a:ea typeface="Inter" pitchFamily="34" charset="-122"/>
+                <a:cs typeface="Inter" pitchFamily="34" charset="-120"/>
               </a:rPr>
               <a:t>Abstract submission opens</a:t>
             </a:r>
@@ -2289,16 +2289,16 @@
               <a:buNone/>
             </a:pPr>
             <a:r>
-              <a:rPr lang="en-US" sz="760" b="1" dirty="0">
+              <a:rPr lang="en-US" sz="700" b="1" dirty="0">
                 <a:solidFill>
                   <a:srgbClr val="B8402F"/>
                 </a:solidFill>
                 <a:highlight>
                   <a:srgbClr val="FFF1EE"/>
                 </a:highlight>
-                <a:latin typeface="Arial" pitchFamily="34" charset="0"/>
-                <a:ea typeface="Arial" pitchFamily="34" charset="-122"/>
-                <a:cs typeface="Arial" pitchFamily="34" charset="-120"/>
+                <a:latin typeface="Manrope" pitchFamily="34" charset="0"/>
+                <a:ea typeface="Manrope" pitchFamily="34" charset="-122"/>
+                <a:cs typeface="Manrope" pitchFamily="34" charset="-120"/>
               </a:rPr>
               <a:t> TBD </a:t>
             </a:r>
@@ -2338,9 +2338,9 @@
                 <a:solidFill>
                   <a:srgbClr val="262B3D"/>
                 </a:solidFill>
-                <a:latin typeface="Arial" pitchFamily="34" charset="0"/>
-                <a:ea typeface="Arial" pitchFamily="34" charset="-122"/>
-                <a:cs typeface="Arial" pitchFamily="34" charset="-120"/>
+                <a:latin typeface="Inter" pitchFamily="34" charset="0"/>
+                <a:ea typeface="Inter" pitchFamily="34" charset="-122"/>
+                <a:cs typeface="Inter" pitchFamily="34" charset="-120"/>
               </a:rPr>
               <a:t>Abstract submission deadline</a:t>
             </a:r>
@@ -2376,16 +2376,16 @@
               <a:buNone/>
             </a:pPr>
             <a:r>
-              <a:rPr lang="en-US" sz="760" b="1" dirty="0">
+              <a:rPr lang="en-US" sz="700" b="1" dirty="0">
                 <a:solidFill>
                   <a:srgbClr val="B8402F"/>
                 </a:solidFill>
                 <a:highlight>
                   <a:srgbClr val="FFF1EE"/>
                 </a:highlight>
-                <a:latin typeface="Arial" pitchFamily="34" charset="0"/>
-                <a:ea typeface="Arial" pitchFamily="34" charset="-122"/>
-                <a:cs typeface="Arial" pitchFamily="34" charset="-120"/>
+                <a:latin typeface="Manrope" pitchFamily="34" charset="0"/>
+                <a:ea typeface="Manrope" pitchFamily="34" charset="-122"/>
+                <a:cs typeface="Manrope" pitchFamily="34" charset="-120"/>
               </a:rPr>
               <a:t> TBD </a:t>
             </a:r>
@@ -2425,9 +2425,9 @@
                 <a:solidFill>
                   <a:srgbClr val="262B3D"/>
                 </a:solidFill>
-                <a:latin typeface="Arial" pitchFamily="34" charset="0"/>
-                <a:ea typeface="Arial" pitchFamily="34" charset="-122"/>
-                <a:cs typeface="Arial" pitchFamily="34" charset="-120"/>
+                <a:latin typeface="Inter" pitchFamily="34" charset="0"/>
+                <a:ea typeface="Inter" pitchFamily="34" charset="-122"/>
+                <a:cs typeface="Inter" pitchFamily="34" charset="-120"/>
               </a:rPr>
               <a:t>Early-bird registration deadline</a:t>
             </a:r>
@@ -2520,9 +2520,9 @@
                 <a:solidFill>
                   <a:srgbClr val="D8432F"/>
                 </a:solidFill>
-                <a:latin typeface="Arial" pitchFamily="34" charset="0"/>
-                <a:ea typeface="Arial" pitchFamily="34" charset="-122"/>
-                <a:cs typeface="Arial" pitchFamily="34" charset="-120"/>
+                <a:latin typeface="Manrope" pitchFamily="34" charset="0"/>
+                <a:ea typeface="Manrope" pitchFamily="34" charset="-122"/>
+                <a:cs typeface="Manrope" pitchFamily="34" charset="-120"/>
               </a:rPr>
               <a:t>Venue</a:t>
             </a:r>
@@ -2562,9 +2562,9 @@
                 <a:solidFill>
                   <a:srgbClr val="262B3D"/>
                 </a:solidFill>
-                <a:latin typeface="Arial" pitchFamily="34" charset="0"/>
-                <a:ea typeface="Arial" pitchFamily="34" charset="-122"/>
-                <a:cs typeface="Arial" pitchFamily="34" charset="-120"/>
+                <a:latin typeface="Inter" pitchFamily="34" charset="0"/>
+                <a:ea typeface="Inter" pitchFamily="34" charset="-122"/>
+                <a:cs typeface="Inter" pitchFamily="34" charset="-120"/>
               </a:rPr>
               <a:t>The conference takes place at the </a:t>
             </a:r>
@@ -2579,9 +2579,9 @@
                 <a:solidFill>
                   <a:srgbClr val="1B2450"/>
                 </a:solidFill>
-                <a:latin typeface="Arial" pitchFamily="34" charset="0"/>
-                <a:ea typeface="Arial" pitchFamily="34" charset="-122"/>
-                <a:cs typeface="Arial" pitchFamily="34" charset="-120"/>
+                <a:latin typeface="Inter" pitchFamily="34" charset="0"/>
+                <a:ea typeface="Inter" pitchFamily="34" charset="-122"/>
+                <a:cs typeface="Inter" pitchFamily="34" charset="-120"/>
               </a:rPr>
               <a:t>Royal Hotel Seoul</a:t>
             </a:r>
@@ -2596,9 +2596,9 @@
                 <a:solidFill>
                   <a:srgbClr val="262B3D"/>
                 </a:solidFill>
-                <a:latin typeface="Arial" pitchFamily="34" charset="0"/>
-                <a:ea typeface="Arial" pitchFamily="34" charset="-122"/>
-                <a:cs typeface="Arial" pitchFamily="34" charset="-120"/>
+                <a:latin typeface="Inter" pitchFamily="34" charset="0"/>
+                <a:ea typeface="Inter" pitchFamily="34" charset="-122"/>
+                <a:cs typeface="Inter" pitchFamily="34" charset="-120"/>
               </a:rPr>
               <a:t> (61 Myeongdong-gil, Jung-gu) in the heart of Myeongdong, Seoul's most vibrant shopping and dining district, next to Myeongdong Cathedral and a few minutes' walk from Myeongdong and Euljiro 1-ga subway stations. Seoul is a city of 10 million where 600-year-old royal palaces and hanok villages sit beside a global hub of semiconductor, display and soft-materials research. Gyeongbokgung Palace, Bukchon Hanok Village, Namsan and the Cheonggyecheon stream are all within easy reach of the venue.</a:t>
             </a:r>
@@ -2635,9 +2635,9 @@
                 <a:solidFill>
                   <a:srgbClr val="D8432F"/>
                 </a:solidFill>
-                <a:latin typeface="Arial" pitchFamily="34" charset="0"/>
-                <a:ea typeface="Arial" pitchFamily="34" charset="-122"/>
-                <a:cs typeface="Arial" pitchFamily="34" charset="-120"/>
+                <a:latin typeface="Manrope" pitchFamily="34" charset="0"/>
+                <a:ea typeface="Manrope" pitchFamily="34" charset="-122"/>
+                <a:cs typeface="Manrope" pitchFamily="34" charset="-120"/>
               </a:rPr>
               <a:t>Getting there</a:t>
             </a:r>
@@ -2677,9 +2677,9 @@
                 <a:solidFill>
                   <a:srgbClr val="262B3D"/>
                 </a:solidFill>
-                <a:latin typeface="Arial" pitchFamily="34" charset="0"/>
-                <a:ea typeface="Arial" pitchFamily="34" charset="-122"/>
-                <a:cs typeface="Arial" pitchFamily="34" charset="-120"/>
+                <a:latin typeface="Inter" pitchFamily="34" charset="0"/>
+                <a:ea typeface="Inter" pitchFamily="34" charset="-122"/>
+                <a:cs typeface="Inter" pitchFamily="34" charset="-120"/>
               </a:rPr>
               <a:t>Incheon International Airport (ICN) is linked to Seoul Station by the AREX express train (about 45 min); the venue is then one subway stop or a 10-minute taxi ride away.</a:t>
             </a:r>
@@ -2716,9 +2716,9 @@
                 <a:solidFill>
                   <a:srgbClr val="D8432F"/>
                 </a:solidFill>
-                <a:latin typeface="Arial" pitchFamily="34" charset="0"/>
-                <a:ea typeface="Arial" pitchFamily="34" charset="-122"/>
-                <a:cs typeface="Arial" pitchFamily="34" charset="-120"/>
+                <a:latin typeface="Manrope" pitchFamily="34" charset="0"/>
+                <a:ea typeface="Manrope" pitchFamily="34" charset="-122"/>
+                <a:cs typeface="Manrope" pitchFamily="34" charset="-120"/>
               </a:rPr>
               <a:t>Accommodation</a:t>
             </a:r>
@@ -2758,9 +2758,9 @@
                 <a:solidFill>
                   <a:srgbClr val="262B3D"/>
                 </a:solidFill>
-                <a:latin typeface="Arial" pitchFamily="34" charset="0"/>
-                <a:ea typeface="Arial" pitchFamily="34" charset="-122"/>
-                <a:cs typeface="Arial" pitchFamily="34" charset="-120"/>
+                <a:latin typeface="Inter" pitchFamily="34" charset="0"/>
+                <a:ea typeface="Inter" pitchFamily="34" charset="-122"/>
+                <a:cs typeface="Inter" pitchFamily="34" charset="-120"/>
               </a:rPr>
               <a:t>A block of rooms at a conference rate will be pre-reserved at the Royal Hotel Seoul. Myeongdong offers a very wide range of hotels and guesthouses at every price level within walking distance of the venue; details will follow in the 2nd announcement.</a:t>
             </a:r>
@@ -2797,9 +2797,9 @@
                 <a:solidFill>
                   <a:srgbClr val="D8432F"/>
                 </a:solidFill>
-                <a:latin typeface="Arial" pitchFamily="34" charset="0"/>
-                <a:ea typeface="Arial" pitchFamily="34" charset="-122"/>
-                <a:cs typeface="Arial" pitchFamily="34" charset="-120"/>
+                <a:latin typeface="Manrope" pitchFamily="34" charset="0"/>
+                <a:ea typeface="Manrope" pitchFamily="34" charset="-122"/>
+                <a:cs typeface="Manrope" pitchFamily="34" charset="-120"/>
               </a:rPr>
               <a:t>Social program </a:t>
             </a:r>
@@ -2811,9 +2811,9 @@
                 <a:solidFill>
                   <a:srgbClr val="5B6079"/>
                 </a:solidFill>
-                <a:latin typeface="Arial" pitchFamily="34" charset="0"/>
-                <a:ea typeface="Arial" pitchFamily="34" charset="-122"/>
-                <a:cs typeface="Arial" pitchFamily="34" charset="-120"/>
+                <a:latin typeface="Inter" pitchFamily="34" charset="0"/>
+                <a:ea typeface="Inter" pitchFamily="34" charset="-122"/>
+                <a:cs typeface="Inter" pitchFamily="34" charset="-120"/>
               </a:rPr>
               <a:t>(tentative)</a:t>
             </a:r>
@@ -2853,9 +2853,9 @@
                 <a:solidFill>
                   <a:srgbClr val="1B2450"/>
                 </a:solidFill>
-                <a:latin typeface="Arial" pitchFamily="34" charset="0"/>
-                <a:ea typeface="Arial" pitchFamily="34" charset="-122"/>
-                <a:cs typeface="Arial" pitchFamily="34" charset="-120"/>
+                <a:latin typeface="Inter" pitchFamily="34" charset="0"/>
+                <a:ea typeface="Inter" pitchFamily="34" charset="-122"/>
+                <a:cs typeface="Inter" pitchFamily="34" charset="-120"/>
               </a:rPr>
               <a:t>Welcome reception</a:t>
             </a:r>
@@ -2870,9 +2870,9 @@
                 <a:solidFill>
                   <a:srgbClr val="262B3D"/>
                 </a:solidFill>
-                <a:latin typeface="Arial" pitchFamily="34" charset="0"/>
-                <a:ea typeface="Arial" pitchFamily="34" charset="-122"/>
-                <a:cs typeface="Arial" pitchFamily="34" charset="-120"/>
+                <a:latin typeface="Inter" pitchFamily="34" charset="0"/>
+                <a:ea typeface="Inter" pitchFamily="34" charset="-122"/>
+                <a:cs typeface="Inter" pitchFamily="34" charset="-120"/>
               </a:rPr>
               <a:t> on </a:t>
             </a:r>
@@ -2883,16 +2883,16 @@
               <a:buNone/>
             </a:pPr>
             <a:r>
-              <a:rPr lang="en-US" sz="760" b="1" dirty="0">
+              <a:rPr lang="en-US" sz="700" b="1" dirty="0">
                 <a:solidFill>
                   <a:srgbClr val="B8402F"/>
                 </a:solidFill>
                 <a:highlight>
                   <a:srgbClr val="FFF1EE"/>
                 </a:highlight>
-                <a:latin typeface="Arial" pitchFamily="34" charset="0"/>
-                <a:ea typeface="Arial" pitchFamily="34" charset="-122"/>
-                <a:cs typeface="Arial" pitchFamily="34" charset="-120"/>
+                <a:latin typeface="Manrope" pitchFamily="34" charset="0"/>
+                <a:ea typeface="Manrope" pitchFamily="34" charset="-122"/>
+                <a:cs typeface="Manrope" pitchFamily="34" charset="-120"/>
               </a:rPr>
               <a:t> Day 1 </a:t>
             </a:r>
@@ -2916,9 +2916,9 @@
                 <a:solidFill>
                   <a:srgbClr val="262B3D"/>
                 </a:solidFill>
-                <a:latin typeface="Arial" pitchFamily="34" charset="0"/>
-                <a:ea typeface="Arial" pitchFamily="34" charset="-122"/>
-                <a:cs typeface="Arial" pitchFamily="34" charset="-120"/>
+                <a:latin typeface="Inter" pitchFamily="34" charset="0"/>
+                <a:ea typeface="Inter" pitchFamily="34" charset="-122"/>
+                <a:cs typeface="Inter" pitchFamily="34" charset="-120"/>
               </a:rPr>
               <a:t>Welcome reception at the conference hotel on the first evening.</a:t>
             </a:r>
@@ -2936,9 +2936,9 @@
                 <a:solidFill>
                   <a:srgbClr val="1B2450"/>
                 </a:solidFill>
-                <a:latin typeface="Arial" pitchFamily="34" charset="0"/>
-                <a:ea typeface="Arial" pitchFamily="34" charset="-122"/>
-                <a:cs typeface="Arial" pitchFamily="34" charset="-120"/>
+                <a:latin typeface="Inter" pitchFamily="34" charset="0"/>
+                <a:ea typeface="Inter" pitchFamily="34" charset="-122"/>
+                <a:cs typeface="Inter" pitchFamily="34" charset="-120"/>
               </a:rPr>
               <a:t>Conference dinner</a:t>
             </a:r>
@@ -2953,9 +2953,9 @@
                 <a:solidFill>
                   <a:srgbClr val="262B3D"/>
                 </a:solidFill>
-                <a:latin typeface="Arial" pitchFamily="34" charset="0"/>
-                <a:ea typeface="Arial" pitchFamily="34" charset="-122"/>
-                <a:cs typeface="Arial" pitchFamily="34" charset="-120"/>
+                <a:latin typeface="Inter" pitchFamily="34" charset="0"/>
+                <a:ea typeface="Inter" pitchFamily="34" charset="-122"/>
+                <a:cs typeface="Inter" pitchFamily="34" charset="-120"/>
               </a:rPr>
               <a:t> on </a:t>
             </a:r>
@@ -2966,16 +2966,16 @@
               <a:buNone/>
             </a:pPr>
             <a:r>
-              <a:rPr lang="en-US" sz="760" b="1" dirty="0">
+              <a:rPr lang="en-US" sz="700" b="1" dirty="0">
                 <a:solidFill>
                   <a:srgbClr val="B8402F"/>
                 </a:solidFill>
                 <a:highlight>
                   <a:srgbClr val="FFF1EE"/>
                 </a:highlight>
-                <a:latin typeface="Arial" pitchFamily="34" charset="0"/>
-                <a:ea typeface="Arial" pitchFamily="34" charset="-122"/>
-                <a:cs typeface="Arial" pitchFamily="34" charset="-120"/>
+                <a:latin typeface="Manrope" pitchFamily="34" charset="0"/>
+                <a:ea typeface="Manrope" pitchFamily="34" charset="-122"/>
+                <a:cs typeface="Manrope" pitchFamily="34" charset="-120"/>
               </a:rPr>
               <a:t> Day 3 </a:t>
             </a:r>
@@ -2999,9 +2999,9 @@
                 <a:solidFill>
                   <a:srgbClr val="262B3D"/>
                 </a:solidFill>
-                <a:latin typeface="Arial" pitchFamily="34" charset="0"/>
-                <a:ea typeface="Arial" pitchFamily="34" charset="-122"/>
-                <a:cs typeface="Arial" pitchFamily="34" charset="-120"/>
+                <a:latin typeface="Inter" pitchFamily="34" charset="0"/>
+                <a:ea typeface="Inter" pitchFamily="34" charset="-122"/>
+                <a:cs typeface="Inter" pitchFamily="34" charset="-120"/>
               </a:rPr>
               <a:t>Korean banquet in the city centre with a traditional performance.</a:t>
             </a:r>
@@ -3019,9 +3019,9 @@
                 <a:solidFill>
                   <a:srgbClr val="1B2450"/>
                 </a:solidFill>
-                <a:latin typeface="Arial" pitchFamily="34" charset="0"/>
-                <a:ea typeface="Arial" pitchFamily="34" charset="-122"/>
-                <a:cs typeface="Arial" pitchFamily="34" charset="-120"/>
+                <a:latin typeface="Inter" pitchFamily="34" charset="0"/>
+                <a:ea typeface="Inter" pitchFamily="34" charset="-122"/>
+                <a:cs typeface="Inter" pitchFamily="34" charset="-120"/>
               </a:rPr>
               <a:t>Cultural afternoon</a:t>
             </a:r>
@@ -3036,9 +3036,9 @@
                 <a:solidFill>
                   <a:srgbClr val="262B3D"/>
                 </a:solidFill>
-                <a:latin typeface="Arial" pitchFamily="34" charset="0"/>
-                <a:ea typeface="Arial" pitchFamily="34" charset="-122"/>
-                <a:cs typeface="Arial" pitchFamily="34" charset="-120"/>
+                <a:latin typeface="Inter" pitchFamily="34" charset="0"/>
+                <a:ea typeface="Inter" pitchFamily="34" charset="-122"/>
+                <a:cs typeface="Inter" pitchFamily="34" charset="-120"/>
               </a:rPr>
               <a:t> on </a:t>
             </a:r>
@@ -3049,16 +3049,16 @@
               <a:buNone/>
             </a:pPr>
             <a:r>
-              <a:rPr lang="en-US" sz="760" b="1" dirty="0">
+              <a:rPr lang="en-US" sz="700" b="1" dirty="0">
                 <a:solidFill>
                   <a:srgbClr val="B8402F"/>
                 </a:solidFill>
                 <a:highlight>
                   <a:srgbClr val="FFF1EE"/>
                 </a:highlight>
-                <a:latin typeface="Arial" pitchFamily="34" charset="0"/>
-                <a:ea typeface="Arial" pitchFamily="34" charset="-122"/>
-                <a:cs typeface="Arial" pitchFamily="34" charset="-120"/>
+                <a:latin typeface="Manrope" pitchFamily="34" charset="0"/>
+                <a:ea typeface="Manrope" pitchFamily="34" charset="-122"/>
+                <a:cs typeface="Manrope" pitchFamily="34" charset="-120"/>
               </a:rPr>
               <a:t> Day 4 </a:t>
             </a:r>
@@ -3082,9 +3082,9 @@
                 <a:solidFill>
                   <a:srgbClr val="262B3D"/>
                 </a:solidFill>
-                <a:latin typeface="Arial" pitchFamily="34" charset="0"/>
-                <a:ea typeface="Arial" pitchFamily="34" charset="-122"/>
-                <a:cs typeface="Arial" pitchFamily="34" charset="-120"/>
+                <a:latin typeface="Inter" pitchFamily="34" charset="0"/>
+                <a:ea typeface="Inter" pitchFamily="34" charset="-122"/>
+                <a:cs typeface="Inter" pitchFamily="34" charset="-120"/>
               </a:rPr>
               <a:t>Gyeongbokgung Palace and Bukchon Hanok Village, or a Han River evening cruise.</a:t>
             </a:r>
@@ -3227,9 +3227,9 @@
                 <a:solidFill>
                   <a:srgbClr val="5B6079"/>
                 </a:solidFill>
-                <a:latin typeface="Arial" pitchFamily="34" charset="0"/>
-                <a:ea typeface="Arial" pitchFamily="34" charset="-122"/>
-                <a:cs typeface="Arial" pitchFamily="34" charset="-120"/>
+                <a:latin typeface="Inter" pitchFamily="34" charset="0"/>
+                <a:ea typeface="Inter" pitchFamily="34" charset="-122"/>
+                <a:cs typeface="Inter" pitchFamily="34" charset="-120"/>
               </a:rPr>
               <a:t>Host institution logo</a:t>
             </a:r>
@@ -3293,9 +3293,9 @@
                 <a:solidFill>
                   <a:srgbClr val="5B6079"/>
                 </a:solidFill>
-                <a:latin typeface="Arial" pitchFamily="34" charset="0"/>
-                <a:ea typeface="Arial" pitchFamily="34" charset="-122"/>
-                <a:cs typeface="Arial" pitchFamily="34" charset="-120"/>
+                <a:latin typeface="Inter" pitchFamily="34" charset="0"/>
+                <a:ea typeface="Inter" pitchFamily="34" charset="-122"/>
+                <a:cs typeface="Inter" pitchFamily="34" charset="-120"/>
               </a:rPr>
               <a:t>Society / sponsor logo</a:t>
             </a:r>
@@ -3359,9 +3359,9 @@
                 <a:solidFill>
                   <a:srgbClr val="5B6079"/>
                 </a:solidFill>
-                <a:latin typeface="Arial" pitchFamily="34" charset="0"/>
-                <a:ea typeface="Arial" pitchFamily="34" charset="-122"/>
-                <a:cs typeface="Arial" pitchFamily="34" charset="-120"/>
+                <a:latin typeface="Inter" pitchFamily="34" charset="0"/>
+                <a:ea typeface="Inter" pitchFamily="34" charset="-122"/>
+                <a:cs typeface="Inter" pitchFamily="34" charset="-120"/>
               </a:rPr>
               <a:t>Seoul CVB / KTO logo</a:t>
             </a:r>
@@ -3398,9 +3398,9 @@
                 <a:solidFill>
                   <a:srgbClr val="2C3A7A"/>
                 </a:solidFill>
-                <a:latin typeface="Arial" pitchFamily="34" charset="0"/>
-                <a:ea typeface="Arial" pitchFamily="34" charset="-122"/>
-                <a:cs typeface="Arial" pitchFamily="34" charset="-120"/>
+                <a:latin typeface="Inter" pitchFamily="34" charset="0"/>
+                <a:ea typeface="Inter" pitchFamily="34" charset="-122"/>
+                <a:cs typeface="Inter" pitchFamily="34" charset="-120"/>
               </a:rPr>
               <a:t>Photos: </a:t>
             </a:r>
@@ -3412,9 +3412,9 @@
                 <a:solidFill>
                   <a:srgbClr val="5B6079"/>
                 </a:solidFill>
-                <a:latin typeface="Arial" pitchFamily="34" charset="0"/>
-                <a:ea typeface="Arial" pitchFamily="34" charset="-122"/>
-                <a:cs typeface="Arial" pitchFamily="34" charset="-120"/>
+                <a:latin typeface="Inter" pitchFamily="34" charset="0"/>
+                <a:ea typeface="Inter" pitchFamily="34" charset="-122"/>
+                <a:cs typeface="Inter" pitchFamily="34" charset="-120"/>
               </a:rPr>
               <a:t>© Korea Tourism Organization (Photo Korea) – 조한섭, 한국관광공사 카멜프레스, 안형록, 임귀빈, 임태원, 이재국, IR 스튜디오. KOGL Type 1.</a:t>
             </a:r>
@@ -3429,11 +3429,11 @@
                 <a:solidFill>
                   <a:srgbClr val="5B6079"/>
                 </a:solidFill>
-                <a:latin typeface="Arial" pitchFamily="34" charset="0"/>
-                <a:ea typeface="Arial" pitchFamily="34" charset="-122"/>
-                <a:cs typeface="Arial" pitchFamily="34" charset="-120"/>
-              </a:rPr>
-              <a:t>Typefaces: Arial. Replace the low-resolution preview photos with the original downloads before printing.</a:t>
+                <a:latin typeface="Inter" pitchFamily="34" charset="0"/>
+                <a:ea typeface="Inter" pitchFamily="34" charset="-122"/>
+                <a:cs typeface="Inter" pitchFamily="34" charset="-120"/>
+              </a:rPr>
+              <a:t>Typefaces: Manrope and Inter (SIL Open Font License).</a:t>
             </a:r>
             <a:endParaRPr lang="en-US" sz="610" dirty="0"/>
           </a:p>
@@ -3531,9 +3531,9 @@
                 <a:solidFill>
                   <a:srgbClr val="FFFFFF"/>
                 </a:solidFill>
-                <a:latin typeface="Arial" pitchFamily="34" charset="0"/>
-                <a:ea typeface="Arial" pitchFamily="34" charset="-122"/>
-                <a:cs typeface="Arial" pitchFamily="34" charset="-120"/>
+                <a:latin typeface="Manrope" pitchFamily="34" charset="0"/>
+                <a:ea typeface="Manrope" pitchFamily="34" charset="-122"/>
+                <a:cs typeface="Manrope" pitchFamily="34" charset="-120"/>
               </a:rPr>
               <a:t>SEOUL  ·  KOREA  ·  2027</a:t>
             </a:r>
@@ -3598,7 +3598,7 @@
         <p:spPr>
           <a:xfrm>
             <a:off x="429768" y="1993392"/>
-            <a:ext cx="4343400" cy="868680"/>
+            <a:ext cx="4663440" cy="868680"/>
           </a:xfrm>
           <a:prstGeom prst="rect">
             <a:avLst/>
@@ -3617,17 +3617,17 @@
               <a:buNone/>
             </a:pPr>
             <a:r>
-              <a:rPr lang="en-US" sz="2600" b="1" dirty="0">
+              <a:rPr lang="en-US" sz="2500" b="1" spc="-40" kern="0" dirty="0">
                 <a:solidFill>
                   <a:srgbClr val="1B2450"/>
                 </a:solidFill>
-                <a:latin typeface="Arial" pitchFamily="34" charset="0"/>
-                <a:ea typeface="Arial" pitchFamily="34" charset="-122"/>
-                <a:cs typeface="Arial" pitchFamily="34" charset="-120"/>
+                <a:latin typeface="Manrope" pitchFamily="34" charset="0"/>
+                <a:ea typeface="Manrope" pitchFamily="34" charset="-122"/>
+                <a:cs typeface="Manrope" pitchFamily="34" charset="-120"/>
               </a:rPr>
               <a:t>International Liquid Crystal</a:t>
             </a:r>
-            <a:endParaRPr lang="en-US" sz="2600" dirty="0"/>
+            <a:endParaRPr lang="en-US" sz="2500" dirty="0"/>
           </a:p>
           <a:p>
             <a:pPr indent="0" marL="0">
@@ -3637,17 +3637,17 @@
               <a:buNone/>
             </a:pPr>
             <a:r>
-              <a:rPr lang="en-US" sz="2600" b="1" dirty="0">
+              <a:rPr lang="en-US" sz="2500" b="1" spc="-40" kern="0" dirty="0">
                 <a:solidFill>
                   <a:srgbClr val="1B2450"/>
                 </a:solidFill>
-                <a:latin typeface="Arial" pitchFamily="34" charset="0"/>
-                <a:ea typeface="Arial" pitchFamily="34" charset="-122"/>
-                <a:cs typeface="Arial" pitchFamily="34" charset="-120"/>
+                <a:latin typeface="Manrope" pitchFamily="34" charset="0"/>
+                <a:ea typeface="Manrope" pitchFamily="34" charset="-122"/>
+                <a:cs typeface="Manrope" pitchFamily="34" charset="-120"/>
               </a:rPr>
               <a:t>Elastomer Conference</a:t>
             </a:r>
-            <a:endParaRPr lang="en-US" sz="2600" dirty="0"/>
+            <a:endParaRPr lang="en-US" sz="2500" dirty="0"/>
           </a:p>
         </p:txBody>
       </p:sp>
@@ -3683,9 +3683,9 @@
                 <a:solidFill>
                   <a:srgbClr val="D8432F"/>
                 </a:solidFill>
-                <a:latin typeface="Arial" pitchFamily="34" charset="0"/>
-                <a:ea typeface="Arial" pitchFamily="34" charset="-122"/>
-                <a:cs typeface="Arial" pitchFamily="34" charset="-120"/>
+                <a:latin typeface="Manrope" pitchFamily="34" charset="0"/>
+                <a:ea typeface="Manrope" pitchFamily="34" charset="-122"/>
+                <a:cs typeface="Manrope" pitchFamily="34" charset="-120"/>
               </a:rPr>
               <a:t>ILCEC 2027</a:t>
             </a:r>
@@ -3703,9 +3703,9 @@
                 <a:solidFill>
                   <a:srgbClr val="2C3A7A"/>
                 </a:solidFill>
-                <a:latin typeface="Arial" pitchFamily="34" charset="0"/>
-                <a:ea typeface="Arial" pitchFamily="34" charset="-122"/>
-                <a:cs typeface="Arial" pitchFamily="34" charset="-120"/>
+                <a:latin typeface="Manrope" pitchFamily="34" charset="0"/>
+                <a:ea typeface="Manrope" pitchFamily="34" charset="-122"/>
+                <a:cs typeface="Manrope" pitchFamily="34" charset="-120"/>
               </a:rPr>
               <a:t>on </a:t>
             </a:r>
@@ -3723,9 +3723,9 @@
                 <a:highlight>
                   <a:srgbClr val="FFF1EE"/>
                 </a:highlight>
-                <a:latin typeface="Arial" pitchFamily="34" charset="0"/>
-                <a:ea typeface="Arial" pitchFamily="34" charset="-122"/>
-                <a:cs typeface="Arial" pitchFamily="34" charset="-120"/>
+                <a:latin typeface="Manrope" pitchFamily="34" charset="0"/>
+                <a:ea typeface="Manrope" pitchFamily="34" charset="-122"/>
+                <a:cs typeface="Manrope" pitchFamily="34" charset="-120"/>
               </a:rPr>
               <a:t> DD–DD Month 2027 </a:t>
             </a:r>
@@ -3743,9 +3743,9 @@
                 <a:solidFill>
                   <a:srgbClr val="2C3A7A"/>
                 </a:solidFill>
-                <a:latin typeface="Arial" pitchFamily="34" charset="0"/>
-                <a:ea typeface="Arial" pitchFamily="34" charset="-122"/>
-                <a:cs typeface="Arial" pitchFamily="34" charset="-120"/>
+                <a:latin typeface="Manrope" pitchFamily="34" charset="0"/>
+                <a:ea typeface="Manrope" pitchFamily="34" charset="-122"/>
+                <a:cs typeface="Manrope" pitchFamily="34" charset="-120"/>
               </a:rPr>
               <a:t>in Seoul, Republic of Korea</a:t>
             </a:r>
@@ -3791,9 +3791,9 @@
                 <a:solidFill>
                   <a:srgbClr val="FFFFFF"/>
                 </a:solidFill>
-                <a:latin typeface="Arial" pitchFamily="34" charset="0"/>
-                <a:ea typeface="Arial" pitchFamily="34" charset="-122"/>
-                <a:cs typeface="Arial" pitchFamily="34" charset="-120"/>
+                <a:latin typeface="Manrope" pitchFamily="34" charset="0"/>
+                <a:ea typeface="Manrope" pitchFamily="34" charset="-122"/>
+                <a:cs typeface="Manrope" pitchFamily="34" charset="-120"/>
               </a:rPr>
               <a:t>DRAFT · TBD</a:t>
             </a:r>
@@ -3833,9 +3833,9 @@
                 <a:solidFill>
                   <a:srgbClr val="2C3A7A"/>
                 </a:solidFill>
-                <a:latin typeface="Arial" pitchFamily="34" charset="0"/>
-                <a:ea typeface="Arial" pitchFamily="34" charset="-122"/>
-                <a:cs typeface="Arial" pitchFamily="34" charset="-120"/>
+                <a:latin typeface="Inter" pitchFamily="34" charset="0"/>
+                <a:ea typeface="Inter" pitchFamily="34" charset="-122"/>
+                <a:cs typeface="Inter" pitchFamily="34" charset="-120"/>
               </a:rPr>
               <a:t>The International Liquid Crystal Elastomer Conference (ILCEC) will be held in </a:t>
             </a:r>
@@ -3850,9 +3850,9 @@
                 <a:solidFill>
                   <a:srgbClr val="1B2450"/>
                 </a:solidFill>
-                <a:latin typeface="Arial" pitchFamily="34" charset="0"/>
-                <a:ea typeface="Arial" pitchFamily="34" charset="-122"/>
-                <a:cs typeface="Arial" pitchFamily="34" charset="-120"/>
+                <a:latin typeface="Inter" pitchFamily="34" charset="0"/>
+                <a:ea typeface="Inter" pitchFamily="34" charset="-122"/>
+                <a:cs typeface="Inter" pitchFamily="34" charset="-120"/>
               </a:rPr>
               <a:t>2027 at the Royal Hotel Seoul, Myeongdong</a:t>
             </a:r>
@@ -3867,9 +3867,9 @@
                 <a:solidFill>
                   <a:srgbClr val="2C3A7A"/>
                 </a:solidFill>
-                <a:latin typeface="Arial" pitchFamily="34" charset="0"/>
-                <a:ea typeface="Arial" pitchFamily="34" charset="-122"/>
-                <a:cs typeface="Arial" pitchFamily="34" charset="-120"/>
+                <a:latin typeface="Inter" pitchFamily="34" charset="0"/>
+                <a:ea typeface="Inter" pitchFamily="34" charset="-122"/>
+                <a:cs typeface="Inter" pitchFamily="34" charset="-120"/>
               </a:rPr>
               <a:t>, in the heart of Seoul, Republic of Korea. Following ILCEC 2025 in Tampere, ILCEC 2027 will bring together chemists, physicists and engineers to share fundamental advances and application opportunities for this exciting class of materials. The conference will cover, but is not limited to, dynamic and multiresponsive LCEs, soft mechanics and actuation, 4D printing, feedback-driven and autonomous motion, tunable photonics, and novel behaviour and functions of LCEs. Contributions on related stimuli-responsive soft materials are also welcome. We hope you will consider joining us in Seoul!</a:t>
             </a:r>
@@ -3906,9 +3906,9 @@
                 <a:solidFill>
                   <a:srgbClr val="D8432F"/>
                 </a:solidFill>
-                <a:latin typeface="Arial" pitchFamily="34" charset="0"/>
-                <a:ea typeface="Arial" pitchFamily="34" charset="-122"/>
-                <a:cs typeface="Arial" pitchFamily="34" charset="-120"/>
+                <a:latin typeface="Manrope" pitchFamily="34" charset="0"/>
+                <a:ea typeface="Manrope" pitchFamily="34" charset="-122"/>
+                <a:cs typeface="Manrope" pitchFamily="34" charset="-120"/>
               </a:rPr>
               <a:t>Chairs</a:t>
             </a:r>
@@ -3944,16 +3944,16 @@
               <a:buNone/>
             </a:pPr>
             <a:r>
-              <a:rPr lang="en-US" sz="760" b="1" dirty="0">
+              <a:rPr lang="en-US" sz="700" b="1" dirty="0">
                 <a:solidFill>
                   <a:srgbClr val="B8402F"/>
                 </a:solidFill>
                 <a:highlight>
                   <a:srgbClr val="FFF1EE"/>
                 </a:highlight>
-                <a:latin typeface="Arial" pitchFamily="34" charset="0"/>
-                <a:ea typeface="Arial" pitchFamily="34" charset="-122"/>
-                <a:cs typeface="Arial" pitchFamily="34" charset="-120"/>
+                <a:latin typeface="Manrope" pitchFamily="34" charset="0"/>
+                <a:ea typeface="Manrope" pitchFamily="34" charset="-122"/>
+                <a:cs typeface="Manrope" pitchFamily="34" charset="-120"/>
               </a:rPr>
               <a:t> Chair name </a:t>
             </a:r>
@@ -3968,9 +3968,9 @@
                 <a:solidFill>
                   <a:srgbClr val="262B3D"/>
                 </a:solidFill>
-                <a:latin typeface="Arial" pitchFamily="34" charset="0"/>
-                <a:ea typeface="Arial" pitchFamily="34" charset="-122"/>
-                <a:cs typeface="Arial" pitchFamily="34" charset="-120"/>
+                <a:latin typeface="Inter" pitchFamily="34" charset="0"/>
+                <a:ea typeface="Inter" pitchFamily="34" charset="-122"/>
+                <a:cs typeface="Inter" pitchFamily="34" charset="-120"/>
               </a:rPr>
               <a:t>, </a:t>
             </a:r>
@@ -3981,16 +3981,16 @@
               <a:buNone/>
             </a:pPr>
             <a:r>
-              <a:rPr lang="en-US" sz="760" b="1" dirty="0">
+              <a:rPr lang="en-US" sz="700" b="1" dirty="0">
                 <a:solidFill>
                   <a:srgbClr val="B8402F"/>
                 </a:solidFill>
                 <a:highlight>
                   <a:srgbClr val="FFF1EE"/>
                 </a:highlight>
-                <a:latin typeface="Arial" pitchFamily="34" charset="0"/>
-                <a:ea typeface="Arial" pitchFamily="34" charset="-122"/>
-                <a:cs typeface="Arial" pitchFamily="34" charset="-120"/>
+                <a:latin typeface="Manrope" pitchFamily="34" charset="0"/>
+                <a:ea typeface="Manrope" pitchFamily="34" charset="-122"/>
+                <a:cs typeface="Manrope" pitchFamily="34" charset="-120"/>
               </a:rPr>
               <a:t> Affiliation </a:t>
             </a:r>
@@ -4010,16 +4010,16 @@
               <a:buNone/>
             </a:pPr>
             <a:r>
-              <a:rPr lang="en-US" sz="760" b="1" dirty="0">
+              <a:rPr lang="en-US" sz="700" b="1" dirty="0">
                 <a:solidFill>
                   <a:srgbClr val="B8402F"/>
                 </a:solidFill>
                 <a:highlight>
                   <a:srgbClr val="FFF1EE"/>
                 </a:highlight>
-                <a:latin typeface="Arial" pitchFamily="34" charset="0"/>
-                <a:ea typeface="Arial" pitchFamily="34" charset="-122"/>
-                <a:cs typeface="Arial" pitchFamily="34" charset="-120"/>
+                <a:latin typeface="Manrope" pitchFamily="34" charset="0"/>
+                <a:ea typeface="Manrope" pitchFamily="34" charset="-122"/>
+                <a:cs typeface="Manrope" pitchFamily="34" charset="-120"/>
               </a:rPr>
               <a:t> Co-chair name </a:t>
             </a:r>
@@ -4034,9 +4034,9 @@
                 <a:solidFill>
                   <a:srgbClr val="262B3D"/>
                 </a:solidFill>
-                <a:latin typeface="Arial" pitchFamily="34" charset="0"/>
-                <a:ea typeface="Arial" pitchFamily="34" charset="-122"/>
-                <a:cs typeface="Arial" pitchFamily="34" charset="-120"/>
+                <a:latin typeface="Inter" pitchFamily="34" charset="0"/>
+                <a:ea typeface="Inter" pitchFamily="34" charset="-122"/>
+                <a:cs typeface="Inter" pitchFamily="34" charset="-120"/>
               </a:rPr>
               <a:t>, </a:t>
             </a:r>
@@ -4047,16 +4047,16 @@
               <a:buNone/>
             </a:pPr>
             <a:r>
-              <a:rPr lang="en-US" sz="760" b="1" dirty="0">
+              <a:rPr lang="en-US" sz="700" b="1" dirty="0">
                 <a:solidFill>
                   <a:srgbClr val="B8402F"/>
                 </a:solidFill>
                 <a:highlight>
                   <a:srgbClr val="FFF1EE"/>
                 </a:highlight>
-                <a:latin typeface="Arial" pitchFamily="34" charset="0"/>
-                <a:ea typeface="Arial" pitchFamily="34" charset="-122"/>
-                <a:cs typeface="Arial" pitchFamily="34" charset="-120"/>
+                <a:latin typeface="Manrope" pitchFamily="34" charset="0"/>
+                <a:ea typeface="Manrope" pitchFamily="34" charset="-122"/>
+                <a:cs typeface="Manrope" pitchFamily="34" charset="-120"/>
               </a:rPr>
               <a:t> Affiliation </a:t>
             </a:r>
@@ -4093,9 +4093,9 @@
                 <a:solidFill>
                   <a:srgbClr val="D8432F"/>
                 </a:solidFill>
-                <a:latin typeface="Arial" pitchFamily="34" charset="0"/>
-                <a:ea typeface="Arial" pitchFamily="34" charset="-122"/>
-                <a:cs typeface="Arial" pitchFamily="34" charset="-120"/>
+                <a:latin typeface="Manrope" pitchFamily="34" charset="0"/>
+                <a:ea typeface="Manrope" pitchFamily="34" charset="-122"/>
+                <a:cs typeface="Manrope" pitchFamily="34" charset="-120"/>
               </a:rPr>
               <a:t>Organizing committee</a:t>
             </a:r>
@@ -4131,16 +4131,16 @@
               <a:buNone/>
             </a:pPr>
             <a:r>
-              <a:rPr lang="en-US" sz="760" b="1" dirty="0">
+              <a:rPr lang="en-US" sz="700" b="1" dirty="0">
                 <a:solidFill>
                   <a:srgbClr val="B8402F"/>
                 </a:solidFill>
                 <a:highlight>
                   <a:srgbClr val="FFF1EE"/>
                 </a:highlight>
-                <a:latin typeface="Arial" pitchFamily="34" charset="0"/>
-                <a:ea typeface="Arial" pitchFamily="34" charset="-122"/>
-                <a:cs typeface="Arial" pitchFamily="34" charset="-120"/>
+                <a:latin typeface="Manrope" pitchFamily="34" charset="0"/>
+                <a:ea typeface="Manrope" pitchFamily="34" charset="-122"/>
+                <a:cs typeface="Manrope" pitchFamily="34" charset="-120"/>
               </a:rPr>
               <a:t> Member </a:t>
             </a:r>
@@ -4155,9 +4155,9 @@
                 <a:solidFill>
                   <a:srgbClr val="262B3D"/>
                 </a:solidFill>
-                <a:latin typeface="Arial" pitchFamily="34" charset="0"/>
-                <a:ea typeface="Arial" pitchFamily="34" charset="-122"/>
-                <a:cs typeface="Arial" pitchFamily="34" charset="-120"/>
+                <a:latin typeface="Inter" pitchFamily="34" charset="0"/>
+                <a:ea typeface="Inter" pitchFamily="34" charset="-122"/>
+                <a:cs typeface="Inter" pitchFamily="34" charset="-120"/>
               </a:rPr>
               <a:t>, </a:t>
             </a:r>
@@ -4168,16 +4168,16 @@
               <a:buNone/>
             </a:pPr>
             <a:r>
-              <a:rPr lang="en-US" sz="760" b="1" dirty="0">
+              <a:rPr lang="en-US" sz="700" b="1" dirty="0">
                 <a:solidFill>
                   <a:srgbClr val="B8402F"/>
                 </a:solidFill>
                 <a:highlight>
                   <a:srgbClr val="FFF1EE"/>
                 </a:highlight>
-                <a:latin typeface="Arial" pitchFamily="34" charset="0"/>
-                <a:ea typeface="Arial" pitchFamily="34" charset="-122"/>
-                <a:cs typeface="Arial" pitchFamily="34" charset="-120"/>
+                <a:latin typeface="Manrope" pitchFamily="34" charset="0"/>
+                <a:ea typeface="Manrope" pitchFamily="34" charset="-122"/>
+                <a:cs typeface="Manrope" pitchFamily="34" charset="-120"/>
               </a:rPr>
               <a:t> Affiliation </a:t>
             </a:r>
@@ -4197,16 +4197,16 @@
               <a:buNone/>
             </a:pPr>
             <a:r>
-              <a:rPr lang="en-US" sz="760" b="1" dirty="0">
+              <a:rPr lang="en-US" sz="700" b="1" dirty="0">
                 <a:solidFill>
                   <a:srgbClr val="B8402F"/>
                 </a:solidFill>
                 <a:highlight>
                   <a:srgbClr val="FFF1EE"/>
                 </a:highlight>
-                <a:latin typeface="Arial" pitchFamily="34" charset="0"/>
-                <a:ea typeface="Arial" pitchFamily="34" charset="-122"/>
-                <a:cs typeface="Arial" pitchFamily="34" charset="-120"/>
+                <a:latin typeface="Manrope" pitchFamily="34" charset="0"/>
+                <a:ea typeface="Manrope" pitchFamily="34" charset="-122"/>
+                <a:cs typeface="Manrope" pitchFamily="34" charset="-120"/>
               </a:rPr>
               <a:t> Member </a:t>
             </a:r>
@@ -4221,9 +4221,9 @@
                 <a:solidFill>
                   <a:srgbClr val="262B3D"/>
                 </a:solidFill>
-                <a:latin typeface="Arial" pitchFamily="34" charset="0"/>
-                <a:ea typeface="Arial" pitchFamily="34" charset="-122"/>
-                <a:cs typeface="Arial" pitchFamily="34" charset="-120"/>
+                <a:latin typeface="Inter" pitchFamily="34" charset="0"/>
+                <a:ea typeface="Inter" pitchFamily="34" charset="-122"/>
+                <a:cs typeface="Inter" pitchFamily="34" charset="-120"/>
               </a:rPr>
               <a:t>, </a:t>
             </a:r>
@@ -4234,16 +4234,16 @@
               <a:buNone/>
             </a:pPr>
             <a:r>
-              <a:rPr lang="en-US" sz="760" b="1" dirty="0">
+              <a:rPr lang="en-US" sz="700" b="1" dirty="0">
                 <a:solidFill>
                   <a:srgbClr val="B8402F"/>
                 </a:solidFill>
                 <a:highlight>
                   <a:srgbClr val="FFF1EE"/>
                 </a:highlight>
-                <a:latin typeface="Arial" pitchFamily="34" charset="0"/>
-                <a:ea typeface="Arial" pitchFamily="34" charset="-122"/>
-                <a:cs typeface="Arial" pitchFamily="34" charset="-120"/>
+                <a:latin typeface="Manrope" pitchFamily="34" charset="0"/>
+                <a:ea typeface="Manrope" pitchFamily="34" charset="-122"/>
+                <a:cs typeface="Manrope" pitchFamily="34" charset="-120"/>
               </a:rPr>
               <a:t> Affiliation </a:t>
             </a:r>
@@ -4263,16 +4263,16 @@
               <a:buNone/>
             </a:pPr>
             <a:r>
-              <a:rPr lang="en-US" sz="760" b="1" dirty="0">
+              <a:rPr lang="en-US" sz="700" b="1" dirty="0">
                 <a:solidFill>
                   <a:srgbClr val="B8402F"/>
                 </a:solidFill>
                 <a:highlight>
                   <a:srgbClr val="FFF1EE"/>
                 </a:highlight>
-                <a:latin typeface="Arial" pitchFamily="34" charset="0"/>
-                <a:ea typeface="Arial" pitchFamily="34" charset="-122"/>
-                <a:cs typeface="Arial" pitchFamily="34" charset="-120"/>
+                <a:latin typeface="Manrope" pitchFamily="34" charset="0"/>
+                <a:ea typeface="Manrope" pitchFamily="34" charset="-122"/>
+                <a:cs typeface="Manrope" pitchFamily="34" charset="-120"/>
               </a:rPr>
               <a:t> Member </a:t>
             </a:r>
@@ -4287,9 +4287,9 @@
                 <a:solidFill>
                   <a:srgbClr val="262B3D"/>
                 </a:solidFill>
-                <a:latin typeface="Arial" pitchFamily="34" charset="0"/>
-                <a:ea typeface="Arial" pitchFamily="34" charset="-122"/>
-                <a:cs typeface="Arial" pitchFamily="34" charset="-120"/>
+                <a:latin typeface="Inter" pitchFamily="34" charset="0"/>
+                <a:ea typeface="Inter" pitchFamily="34" charset="-122"/>
+                <a:cs typeface="Inter" pitchFamily="34" charset="-120"/>
               </a:rPr>
               <a:t>, </a:t>
             </a:r>
@@ -4300,16 +4300,16 @@
               <a:buNone/>
             </a:pPr>
             <a:r>
-              <a:rPr lang="en-US" sz="760" b="1" dirty="0">
+              <a:rPr lang="en-US" sz="700" b="1" dirty="0">
                 <a:solidFill>
                   <a:srgbClr val="B8402F"/>
                 </a:solidFill>
                 <a:highlight>
                   <a:srgbClr val="FFF1EE"/>
                 </a:highlight>
-                <a:latin typeface="Arial" pitchFamily="34" charset="0"/>
-                <a:ea typeface="Arial" pitchFamily="34" charset="-122"/>
-                <a:cs typeface="Arial" pitchFamily="34" charset="-120"/>
+                <a:latin typeface="Manrope" pitchFamily="34" charset="0"/>
+                <a:ea typeface="Manrope" pitchFamily="34" charset="-122"/>
+                <a:cs typeface="Manrope" pitchFamily="34" charset="-120"/>
               </a:rPr>
               <a:t> Affiliation </a:t>
             </a:r>
@@ -4346,9 +4346,9 @@
                 <a:solidFill>
                   <a:srgbClr val="D8432F"/>
                 </a:solidFill>
-                <a:latin typeface="Arial" pitchFamily="34" charset="0"/>
-                <a:ea typeface="Arial" pitchFamily="34" charset="-122"/>
-                <a:cs typeface="Arial" pitchFamily="34" charset="-120"/>
+                <a:latin typeface="Manrope" pitchFamily="34" charset="0"/>
+                <a:ea typeface="Manrope" pitchFamily="34" charset="-122"/>
+                <a:cs typeface="Manrope" pitchFamily="34" charset="-120"/>
               </a:rPr>
               <a:t>International program committee</a:t>
             </a:r>
@@ -4384,16 +4384,16 @@
               <a:buNone/>
             </a:pPr>
             <a:r>
-              <a:rPr lang="en-US" sz="760" b="1" dirty="0">
+              <a:rPr lang="en-US" sz="700" b="1" dirty="0">
                 <a:solidFill>
                   <a:srgbClr val="B8402F"/>
                 </a:solidFill>
                 <a:highlight>
                   <a:srgbClr val="FFF1EE"/>
                 </a:highlight>
-                <a:latin typeface="Arial" pitchFamily="34" charset="0"/>
-                <a:ea typeface="Arial" pitchFamily="34" charset="-122"/>
-                <a:cs typeface="Arial" pitchFamily="34" charset="-120"/>
+                <a:latin typeface="Manrope" pitchFamily="34" charset="0"/>
+                <a:ea typeface="Manrope" pitchFamily="34" charset="-122"/>
+                <a:cs typeface="Manrope" pitchFamily="34" charset="-120"/>
               </a:rPr>
               <a:t> Member </a:t>
             </a:r>
@@ -4408,9 +4408,9 @@
                 <a:solidFill>
                   <a:srgbClr val="262B3D"/>
                 </a:solidFill>
-                <a:latin typeface="Arial" pitchFamily="34" charset="0"/>
-                <a:ea typeface="Arial" pitchFamily="34" charset="-122"/>
-                <a:cs typeface="Arial" pitchFamily="34" charset="-120"/>
+                <a:latin typeface="Inter" pitchFamily="34" charset="0"/>
+                <a:ea typeface="Inter" pitchFamily="34" charset="-122"/>
+                <a:cs typeface="Inter" pitchFamily="34" charset="-120"/>
               </a:rPr>
               <a:t>, </a:t>
             </a:r>
@@ -4421,16 +4421,16 @@
               <a:buNone/>
             </a:pPr>
             <a:r>
-              <a:rPr lang="en-US" sz="760" b="1" dirty="0">
+              <a:rPr lang="en-US" sz="700" b="1" dirty="0">
                 <a:solidFill>
                   <a:srgbClr val="B8402F"/>
                 </a:solidFill>
                 <a:highlight>
                   <a:srgbClr val="FFF1EE"/>
                 </a:highlight>
-                <a:latin typeface="Arial" pitchFamily="34" charset="0"/>
-                <a:ea typeface="Arial" pitchFamily="34" charset="-122"/>
-                <a:cs typeface="Arial" pitchFamily="34" charset="-120"/>
+                <a:latin typeface="Manrope" pitchFamily="34" charset="0"/>
+                <a:ea typeface="Manrope" pitchFamily="34" charset="-122"/>
+                <a:cs typeface="Manrope" pitchFamily="34" charset="-120"/>
               </a:rPr>
               <a:t> Affiliation, Country </a:t>
             </a:r>
@@ -4450,16 +4450,16 @@
               <a:buNone/>
             </a:pPr>
             <a:r>
-              <a:rPr lang="en-US" sz="760" b="1" dirty="0">
+              <a:rPr lang="en-US" sz="700" b="1" dirty="0">
                 <a:solidFill>
                   <a:srgbClr val="B8402F"/>
                 </a:solidFill>
                 <a:highlight>
                   <a:srgbClr val="FFF1EE"/>
                 </a:highlight>
-                <a:latin typeface="Arial" pitchFamily="34" charset="0"/>
-                <a:ea typeface="Arial" pitchFamily="34" charset="-122"/>
-                <a:cs typeface="Arial" pitchFamily="34" charset="-120"/>
+                <a:latin typeface="Manrope" pitchFamily="34" charset="0"/>
+                <a:ea typeface="Manrope" pitchFamily="34" charset="-122"/>
+                <a:cs typeface="Manrope" pitchFamily="34" charset="-120"/>
               </a:rPr>
               <a:t> Member </a:t>
             </a:r>
@@ -4474,9 +4474,9 @@
                 <a:solidFill>
                   <a:srgbClr val="262B3D"/>
                 </a:solidFill>
-                <a:latin typeface="Arial" pitchFamily="34" charset="0"/>
-                <a:ea typeface="Arial" pitchFamily="34" charset="-122"/>
-                <a:cs typeface="Arial" pitchFamily="34" charset="-120"/>
+                <a:latin typeface="Inter" pitchFamily="34" charset="0"/>
+                <a:ea typeface="Inter" pitchFamily="34" charset="-122"/>
+                <a:cs typeface="Inter" pitchFamily="34" charset="-120"/>
               </a:rPr>
               <a:t>, </a:t>
             </a:r>
@@ -4487,16 +4487,16 @@
               <a:buNone/>
             </a:pPr>
             <a:r>
-              <a:rPr lang="en-US" sz="760" b="1" dirty="0">
+              <a:rPr lang="en-US" sz="700" b="1" dirty="0">
                 <a:solidFill>
                   <a:srgbClr val="B8402F"/>
                 </a:solidFill>
                 <a:highlight>
                   <a:srgbClr val="FFF1EE"/>
                 </a:highlight>
-                <a:latin typeface="Arial" pitchFamily="34" charset="0"/>
-                <a:ea typeface="Arial" pitchFamily="34" charset="-122"/>
-                <a:cs typeface="Arial" pitchFamily="34" charset="-120"/>
+                <a:latin typeface="Manrope" pitchFamily="34" charset="0"/>
+                <a:ea typeface="Manrope" pitchFamily="34" charset="-122"/>
+                <a:cs typeface="Manrope" pitchFamily="34" charset="-120"/>
               </a:rPr>
               <a:t> Affiliation, Country </a:t>
             </a:r>
@@ -4516,16 +4516,16 @@
               <a:buNone/>
             </a:pPr>
             <a:r>
-              <a:rPr lang="en-US" sz="760" b="1" dirty="0">
+              <a:rPr lang="en-US" sz="700" b="1" dirty="0">
                 <a:solidFill>
                   <a:srgbClr val="B8402F"/>
                 </a:solidFill>
                 <a:highlight>
                   <a:srgbClr val="FFF1EE"/>
                 </a:highlight>
-                <a:latin typeface="Arial" pitchFamily="34" charset="0"/>
-                <a:ea typeface="Arial" pitchFamily="34" charset="-122"/>
-                <a:cs typeface="Arial" pitchFamily="34" charset="-120"/>
+                <a:latin typeface="Manrope" pitchFamily="34" charset="0"/>
+                <a:ea typeface="Manrope" pitchFamily="34" charset="-122"/>
+                <a:cs typeface="Manrope" pitchFamily="34" charset="-120"/>
               </a:rPr>
               <a:t> Member </a:t>
             </a:r>
@@ -4540,9 +4540,9 @@
                 <a:solidFill>
                   <a:srgbClr val="262B3D"/>
                 </a:solidFill>
-                <a:latin typeface="Arial" pitchFamily="34" charset="0"/>
-                <a:ea typeface="Arial" pitchFamily="34" charset="-122"/>
-                <a:cs typeface="Arial" pitchFamily="34" charset="-120"/>
+                <a:latin typeface="Inter" pitchFamily="34" charset="0"/>
+                <a:ea typeface="Inter" pitchFamily="34" charset="-122"/>
+                <a:cs typeface="Inter" pitchFamily="34" charset="-120"/>
               </a:rPr>
               <a:t>, </a:t>
             </a:r>
@@ -4553,16 +4553,16 @@
               <a:buNone/>
             </a:pPr>
             <a:r>
-              <a:rPr lang="en-US" sz="760" b="1" dirty="0">
+              <a:rPr lang="en-US" sz="700" b="1" dirty="0">
                 <a:solidFill>
                   <a:srgbClr val="B8402F"/>
                 </a:solidFill>
                 <a:highlight>
                   <a:srgbClr val="FFF1EE"/>
                 </a:highlight>
-                <a:latin typeface="Arial" pitchFamily="34" charset="0"/>
-                <a:ea typeface="Arial" pitchFamily="34" charset="-122"/>
-                <a:cs typeface="Arial" pitchFamily="34" charset="-120"/>
+                <a:latin typeface="Manrope" pitchFamily="34" charset="0"/>
+                <a:ea typeface="Manrope" pitchFamily="34" charset="-122"/>
+                <a:cs typeface="Manrope" pitchFamily="34" charset="-120"/>
               </a:rPr>
               <a:t> Affiliation, Country </a:t>
             </a:r>
@@ -4582,16 +4582,16 @@
               <a:buNone/>
             </a:pPr>
             <a:r>
-              <a:rPr lang="en-US" sz="760" b="1" dirty="0">
+              <a:rPr lang="en-US" sz="700" b="1" dirty="0">
                 <a:solidFill>
                   <a:srgbClr val="B8402F"/>
                 </a:solidFill>
                 <a:highlight>
                   <a:srgbClr val="FFF1EE"/>
                 </a:highlight>
-                <a:latin typeface="Arial" pitchFamily="34" charset="0"/>
-                <a:ea typeface="Arial" pitchFamily="34" charset="-122"/>
-                <a:cs typeface="Arial" pitchFamily="34" charset="-120"/>
+                <a:latin typeface="Manrope" pitchFamily="34" charset="0"/>
+                <a:ea typeface="Manrope" pitchFamily="34" charset="-122"/>
+                <a:cs typeface="Manrope" pitchFamily="34" charset="-120"/>
               </a:rPr>
               <a:t> Member </a:t>
             </a:r>
@@ -4606,9 +4606,9 @@
                 <a:solidFill>
                   <a:srgbClr val="262B3D"/>
                 </a:solidFill>
-                <a:latin typeface="Arial" pitchFamily="34" charset="0"/>
-                <a:ea typeface="Arial" pitchFamily="34" charset="-122"/>
-                <a:cs typeface="Arial" pitchFamily="34" charset="-120"/>
+                <a:latin typeface="Inter" pitchFamily="34" charset="0"/>
+                <a:ea typeface="Inter" pitchFamily="34" charset="-122"/>
+                <a:cs typeface="Inter" pitchFamily="34" charset="-120"/>
               </a:rPr>
               <a:t>, </a:t>
             </a:r>
@@ -4619,16 +4619,16 @@
               <a:buNone/>
             </a:pPr>
             <a:r>
-              <a:rPr lang="en-US" sz="760" b="1" dirty="0">
+              <a:rPr lang="en-US" sz="700" b="1" dirty="0">
                 <a:solidFill>
                   <a:srgbClr val="B8402F"/>
                 </a:solidFill>
                 <a:highlight>
                   <a:srgbClr val="FFF1EE"/>
                 </a:highlight>
-                <a:latin typeface="Arial" pitchFamily="34" charset="0"/>
-                <a:ea typeface="Arial" pitchFamily="34" charset="-122"/>
-                <a:cs typeface="Arial" pitchFamily="34" charset="-120"/>
+                <a:latin typeface="Manrope" pitchFamily="34" charset="0"/>
+                <a:ea typeface="Manrope" pitchFamily="34" charset="-122"/>
+                <a:cs typeface="Manrope" pitchFamily="34" charset="-120"/>
               </a:rPr>
               <a:t> Affiliation, Country </a:t>
             </a:r>
@@ -4648,16 +4648,16 @@
               <a:buNone/>
             </a:pPr>
             <a:r>
-              <a:rPr lang="en-US" sz="760" b="1" dirty="0">
+              <a:rPr lang="en-US" sz="700" b="1" dirty="0">
                 <a:solidFill>
                   <a:srgbClr val="B8402F"/>
                 </a:solidFill>
                 <a:highlight>
                   <a:srgbClr val="FFF1EE"/>
                 </a:highlight>
-                <a:latin typeface="Arial" pitchFamily="34" charset="0"/>
-                <a:ea typeface="Arial" pitchFamily="34" charset="-122"/>
-                <a:cs typeface="Arial" pitchFamily="34" charset="-120"/>
+                <a:latin typeface="Manrope" pitchFamily="34" charset="0"/>
+                <a:ea typeface="Manrope" pitchFamily="34" charset="-122"/>
+                <a:cs typeface="Manrope" pitchFamily="34" charset="-120"/>
               </a:rPr>
               <a:t> Member </a:t>
             </a:r>
@@ -4672,9 +4672,9 @@
                 <a:solidFill>
                   <a:srgbClr val="262B3D"/>
                 </a:solidFill>
-                <a:latin typeface="Arial" pitchFamily="34" charset="0"/>
-                <a:ea typeface="Arial" pitchFamily="34" charset="-122"/>
-                <a:cs typeface="Arial" pitchFamily="34" charset="-120"/>
+                <a:latin typeface="Inter" pitchFamily="34" charset="0"/>
+                <a:ea typeface="Inter" pitchFamily="34" charset="-122"/>
+                <a:cs typeface="Inter" pitchFamily="34" charset="-120"/>
               </a:rPr>
               <a:t>, </a:t>
             </a:r>
@@ -4685,16 +4685,16 @@
               <a:buNone/>
             </a:pPr>
             <a:r>
-              <a:rPr lang="en-US" sz="760" b="1" dirty="0">
+              <a:rPr lang="en-US" sz="700" b="1" dirty="0">
                 <a:solidFill>
                   <a:srgbClr val="B8402F"/>
                 </a:solidFill>
                 <a:highlight>
                   <a:srgbClr val="FFF1EE"/>
                 </a:highlight>
-                <a:latin typeface="Arial" pitchFamily="34" charset="0"/>
-                <a:ea typeface="Arial" pitchFamily="34" charset="-122"/>
-                <a:cs typeface="Arial" pitchFamily="34" charset="-120"/>
+                <a:latin typeface="Manrope" pitchFamily="34" charset="0"/>
+                <a:ea typeface="Manrope" pitchFamily="34" charset="-122"/>
+                <a:cs typeface="Manrope" pitchFamily="34" charset="-120"/>
               </a:rPr>
               <a:t> Affiliation, Country </a:t>
             </a:r>
@@ -4714,16 +4714,16 @@
               <a:buNone/>
             </a:pPr>
             <a:r>
-              <a:rPr lang="en-US" sz="760" b="1" dirty="0">
+              <a:rPr lang="en-US" sz="700" b="1" dirty="0">
                 <a:solidFill>
                   <a:srgbClr val="B8402F"/>
                 </a:solidFill>
                 <a:highlight>
                   <a:srgbClr val="FFF1EE"/>
                 </a:highlight>
-                <a:latin typeface="Arial" pitchFamily="34" charset="0"/>
-                <a:ea typeface="Arial" pitchFamily="34" charset="-122"/>
-                <a:cs typeface="Arial" pitchFamily="34" charset="-120"/>
+                <a:latin typeface="Manrope" pitchFamily="34" charset="0"/>
+                <a:ea typeface="Manrope" pitchFamily="34" charset="-122"/>
+                <a:cs typeface="Manrope" pitchFamily="34" charset="-120"/>
               </a:rPr>
               <a:t> Member </a:t>
             </a:r>
@@ -4738,9 +4738,9 @@
                 <a:solidFill>
                   <a:srgbClr val="262B3D"/>
                 </a:solidFill>
-                <a:latin typeface="Arial" pitchFamily="34" charset="0"/>
-                <a:ea typeface="Arial" pitchFamily="34" charset="-122"/>
-                <a:cs typeface="Arial" pitchFamily="34" charset="-120"/>
+                <a:latin typeface="Inter" pitchFamily="34" charset="0"/>
+                <a:ea typeface="Inter" pitchFamily="34" charset="-122"/>
+                <a:cs typeface="Inter" pitchFamily="34" charset="-120"/>
               </a:rPr>
               <a:t>, </a:t>
             </a:r>
@@ -4751,16 +4751,16 @@
               <a:buNone/>
             </a:pPr>
             <a:r>
-              <a:rPr lang="en-US" sz="760" b="1" dirty="0">
+              <a:rPr lang="en-US" sz="700" b="1" dirty="0">
                 <a:solidFill>
                   <a:srgbClr val="B8402F"/>
                 </a:solidFill>
                 <a:highlight>
                   <a:srgbClr val="FFF1EE"/>
                 </a:highlight>
-                <a:latin typeface="Arial" pitchFamily="34" charset="0"/>
-                <a:ea typeface="Arial" pitchFamily="34" charset="-122"/>
-                <a:cs typeface="Arial" pitchFamily="34" charset="-120"/>
+                <a:latin typeface="Manrope" pitchFamily="34" charset="0"/>
+                <a:ea typeface="Manrope" pitchFamily="34" charset="-122"/>
+                <a:cs typeface="Manrope" pitchFamily="34" charset="-120"/>
               </a:rPr>
               <a:t> Affiliation, Country </a:t>
             </a:r>
@@ -4797,9 +4797,9 @@
                 <a:solidFill>
                   <a:srgbClr val="D8432F"/>
                 </a:solidFill>
-                <a:latin typeface="Arial" pitchFamily="34" charset="0"/>
-                <a:ea typeface="Arial" pitchFamily="34" charset="-122"/>
-                <a:cs typeface="Arial" pitchFamily="34" charset="-120"/>
+                <a:latin typeface="Manrope" pitchFamily="34" charset="0"/>
+                <a:ea typeface="Manrope" pitchFamily="34" charset="-122"/>
+                <a:cs typeface="Manrope" pitchFamily="34" charset="-120"/>
               </a:rPr>
               <a:t>Contact</a:t>
             </a:r>
@@ -4835,16 +4835,16 @@
               <a:buNone/>
             </a:pPr>
             <a:r>
-              <a:rPr lang="en-US" sz="760" b="1" dirty="0">
+              <a:rPr lang="en-US" sz="700" b="1" dirty="0">
                 <a:solidFill>
                   <a:srgbClr val="B8402F"/>
                 </a:solidFill>
                 <a:highlight>
                   <a:srgbClr val="FFF1EE"/>
                 </a:highlight>
-                <a:latin typeface="Arial" pitchFamily="34" charset="0"/>
-                <a:ea typeface="Arial" pitchFamily="34" charset="-122"/>
-                <a:cs typeface="Arial" pitchFamily="34" charset="-120"/>
+                <a:latin typeface="Manrope" pitchFamily="34" charset="0"/>
+                <a:ea typeface="Manrope" pitchFamily="34" charset="-122"/>
+                <a:cs typeface="Manrope" pitchFamily="34" charset="-120"/>
               </a:rPr>
               <a:t> Coordinator name </a:t>
             </a:r>
@@ -4859,9 +4859,9 @@
                 <a:solidFill>
                   <a:srgbClr val="262B3D"/>
                 </a:solidFill>
-                <a:latin typeface="Arial" pitchFamily="34" charset="0"/>
-                <a:ea typeface="Arial" pitchFamily="34" charset="-122"/>
-                <a:cs typeface="Arial" pitchFamily="34" charset="-120"/>
+                <a:latin typeface="Inter" pitchFamily="34" charset="0"/>
+                <a:ea typeface="Inter" pitchFamily="34" charset="-122"/>
+                <a:cs typeface="Inter" pitchFamily="34" charset="-120"/>
               </a:rPr>
               <a:t>, conference coordinator</a:t>
             </a:r>
@@ -4881,16 +4881,16 @@
               <a:buNone/>
             </a:pPr>
             <a:r>
-              <a:rPr lang="en-US" sz="760" b="1" dirty="0">
+              <a:rPr lang="en-US" sz="700" b="1" dirty="0">
                 <a:solidFill>
                   <a:srgbClr val="B8402F"/>
                 </a:solidFill>
                 <a:highlight>
                   <a:srgbClr val="FFF1EE"/>
                 </a:highlight>
-                <a:latin typeface="Arial" pitchFamily="34" charset="0"/>
-                <a:ea typeface="Arial" pitchFamily="34" charset="-122"/>
-                <a:cs typeface="Arial" pitchFamily="34" charset="-120"/>
+                <a:latin typeface="Manrope" pitchFamily="34" charset="0"/>
+                <a:ea typeface="Manrope" pitchFamily="34" charset="-122"/>
+                <a:cs typeface="Manrope" pitchFamily="34" charset="-120"/>
               </a:rPr>
               <a:t> ilcec2027@___.ac.kr </a:t>
             </a:r>
@@ -4927,9 +4927,9 @@
                 <a:solidFill>
                   <a:srgbClr val="D8432F"/>
                 </a:solidFill>
-                <a:latin typeface="Arial" pitchFamily="34" charset="0"/>
-                <a:ea typeface="Arial" pitchFamily="34" charset="-122"/>
-                <a:cs typeface="Arial" pitchFamily="34" charset="-120"/>
+                <a:latin typeface="Manrope" pitchFamily="34" charset="0"/>
+                <a:ea typeface="Manrope" pitchFamily="34" charset="-122"/>
+                <a:cs typeface="Manrope" pitchFamily="34" charset="-120"/>
               </a:rPr>
               <a:t>Webpage</a:t>
             </a:r>
@@ -4965,16 +4965,16 @@
               <a:buNone/>
             </a:pPr>
             <a:r>
-              <a:rPr lang="en-US" sz="760" b="1" dirty="0">
+              <a:rPr lang="en-US" sz="700" b="1" dirty="0">
                 <a:solidFill>
                   <a:srgbClr val="B8402F"/>
                 </a:solidFill>
                 <a:highlight>
                   <a:srgbClr val="FFF1EE"/>
                 </a:highlight>
-                <a:latin typeface="Arial" pitchFamily="34" charset="0"/>
-                <a:ea typeface="Arial" pitchFamily="34" charset="-122"/>
-                <a:cs typeface="Arial" pitchFamily="34" charset="-120"/>
+                <a:latin typeface="Manrope" pitchFamily="34" charset="0"/>
+                <a:ea typeface="Manrope" pitchFamily="34" charset="-122"/>
+                <a:cs typeface="Manrope" pitchFamily="34" charset="-120"/>
               </a:rPr>
               <a:t> https://ilcec2027.___ </a:t>
             </a:r>
@@ -5067,9 +5067,9 @@
                 <a:solidFill>
                   <a:srgbClr val="D8432F"/>
                 </a:solidFill>
-                <a:latin typeface="Arial" pitchFamily="34" charset="0"/>
-                <a:ea typeface="Arial" pitchFamily="34" charset="-122"/>
-                <a:cs typeface="Arial" pitchFamily="34" charset="-120"/>
+                <a:latin typeface="Manrope" pitchFamily="34" charset="0"/>
+                <a:ea typeface="Manrope" pitchFamily="34" charset="-122"/>
+                <a:cs typeface="Manrope" pitchFamily="34" charset="-120"/>
               </a:rPr>
               <a:t>Venue</a:t>
             </a:r>
@@ -5109,9 +5109,9 @@
                 <a:solidFill>
                   <a:srgbClr val="262B3D"/>
                 </a:solidFill>
-                <a:latin typeface="Arial" pitchFamily="34" charset="0"/>
-                <a:ea typeface="Arial" pitchFamily="34" charset="-122"/>
-                <a:cs typeface="Arial" pitchFamily="34" charset="-120"/>
+                <a:latin typeface="Inter" pitchFamily="34" charset="0"/>
+                <a:ea typeface="Inter" pitchFamily="34" charset="-122"/>
+                <a:cs typeface="Inter" pitchFamily="34" charset="-120"/>
               </a:rPr>
               <a:t>The conference takes place at the </a:t>
             </a:r>
@@ -5126,9 +5126,9 @@
                 <a:solidFill>
                   <a:srgbClr val="1B2450"/>
                 </a:solidFill>
-                <a:latin typeface="Arial" pitchFamily="34" charset="0"/>
-                <a:ea typeface="Arial" pitchFamily="34" charset="-122"/>
-                <a:cs typeface="Arial" pitchFamily="34" charset="-120"/>
+                <a:latin typeface="Inter" pitchFamily="34" charset="0"/>
+                <a:ea typeface="Inter" pitchFamily="34" charset="-122"/>
+                <a:cs typeface="Inter" pitchFamily="34" charset="-120"/>
               </a:rPr>
               <a:t>Royal Hotel Seoul</a:t>
             </a:r>
@@ -5143,9 +5143,9 @@
                 <a:solidFill>
                   <a:srgbClr val="262B3D"/>
                 </a:solidFill>
-                <a:latin typeface="Arial" pitchFamily="34" charset="0"/>
-                <a:ea typeface="Arial" pitchFamily="34" charset="-122"/>
-                <a:cs typeface="Arial" pitchFamily="34" charset="-120"/>
+                <a:latin typeface="Inter" pitchFamily="34" charset="0"/>
+                <a:ea typeface="Inter" pitchFamily="34" charset="-122"/>
+                <a:cs typeface="Inter" pitchFamily="34" charset="-120"/>
               </a:rPr>
               <a:t> (61 Myeongdong-gil, Jung-gu) in the heart of Myeongdong, Seoul's most vibrant shopping and dining district, next to Myeongdong Cathedral and a few minutes' walk from Myeongdong and Euljiro 1-ga subway stations. Seoul is a city of 10 million where 600-year-old royal palaces and hanok villages sit beside a global hub of semiconductor, display and soft-materials research. Gyeongbokgung Palace, Bukchon Hanok Village, Namsan and the Cheonggyecheon stream are all within easy reach of the venue.</a:t>
             </a:r>
@@ -5182,9 +5182,9 @@
                 <a:solidFill>
                   <a:srgbClr val="D8432F"/>
                 </a:solidFill>
-                <a:latin typeface="Arial" pitchFamily="34" charset="0"/>
-                <a:ea typeface="Arial" pitchFamily="34" charset="-122"/>
-                <a:cs typeface="Arial" pitchFamily="34" charset="-120"/>
+                <a:latin typeface="Manrope" pitchFamily="34" charset="0"/>
+                <a:ea typeface="Manrope" pitchFamily="34" charset="-122"/>
+                <a:cs typeface="Manrope" pitchFamily="34" charset="-120"/>
               </a:rPr>
               <a:t>Getting there</a:t>
             </a:r>
@@ -5224,9 +5224,9 @@
                 <a:solidFill>
                   <a:srgbClr val="262B3D"/>
                 </a:solidFill>
-                <a:latin typeface="Arial" pitchFamily="34" charset="0"/>
-                <a:ea typeface="Arial" pitchFamily="34" charset="-122"/>
-                <a:cs typeface="Arial" pitchFamily="34" charset="-120"/>
+                <a:latin typeface="Inter" pitchFamily="34" charset="0"/>
+                <a:ea typeface="Inter" pitchFamily="34" charset="-122"/>
+                <a:cs typeface="Inter" pitchFamily="34" charset="-120"/>
               </a:rPr>
               <a:t>Incheon International Airport (ICN) is linked to Seoul Station by the AREX express train (about 45 min); the venue is then one subway stop or a 10-minute taxi ride away.</a:t>
             </a:r>
@@ -5263,9 +5263,9 @@
                 <a:solidFill>
                   <a:srgbClr val="D8432F"/>
                 </a:solidFill>
-                <a:latin typeface="Arial" pitchFamily="34" charset="0"/>
-                <a:ea typeface="Arial" pitchFamily="34" charset="-122"/>
-                <a:cs typeface="Arial" pitchFamily="34" charset="-120"/>
+                <a:latin typeface="Manrope" pitchFamily="34" charset="0"/>
+                <a:ea typeface="Manrope" pitchFamily="34" charset="-122"/>
+                <a:cs typeface="Manrope" pitchFamily="34" charset="-120"/>
               </a:rPr>
               <a:t>Accommodation</a:t>
             </a:r>
@@ -5305,9 +5305,9 @@
                 <a:solidFill>
                   <a:srgbClr val="262B3D"/>
                 </a:solidFill>
-                <a:latin typeface="Arial" pitchFamily="34" charset="0"/>
-                <a:ea typeface="Arial" pitchFamily="34" charset="-122"/>
-                <a:cs typeface="Arial" pitchFamily="34" charset="-120"/>
+                <a:latin typeface="Inter" pitchFamily="34" charset="0"/>
+                <a:ea typeface="Inter" pitchFamily="34" charset="-122"/>
+                <a:cs typeface="Inter" pitchFamily="34" charset="-120"/>
               </a:rPr>
               <a:t>A block of rooms at a conference rate will be pre-reserved at the Royal Hotel Seoul. Myeongdong offers a very wide range of hotels and guesthouses at every price level within walking distance of the venue; details will follow in the 2nd announcement.</a:t>
             </a:r>
@@ -5344,9 +5344,9 @@
                 <a:solidFill>
                   <a:srgbClr val="D8432F"/>
                 </a:solidFill>
-                <a:latin typeface="Arial" pitchFamily="34" charset="0"/>
-                <a:ea typeface="Arial" pitchFamily="34" charset="-122"/>
-                <a:cs typeface="Arial" pitchFamily="34" charset="-120"/>
+                <a:latin typeface="Manrope" pitchFamily="34" charset="0"/>
+                <a:ea typeface="Manrope" pitchFamily="34" charset="-122"/>
+                <a:cs typeface="Manrope" pitchFamily="34" charset="-120"/>
               </a:rPr>
               <a:t>Social program </a:t>
             </a:r>
@@ -5358,9 +5358,9 @@
                 <a:solidFill>
                   <a:srgbClr val="5B6079"/>
                 </a:solidFill>
-                <a:latin typeface="Arial" pitchFamily="34" charset="0"/>
-                <a:ea typeface="Arial" pitchFamily="34" charset="-122"/>
-                <a:cs typeface="Arial" pitchFamily="34" charset="-120"/>
+                <a:latin typeface="Inter" pitchFamily="34" charset="0"/>
+                <a:ea typeface="Inter" pitchFamily="34" charset="-122"/>
+                <a:cs typeface="Inter" pitchFamily="34" charset="-120"/>
               </a:rPr>
               <a:t>(tentative)</a:t>
             </a:r>
@@ -5400,9 +5400,9 @@
                 <a:solidFill>
                   <a:srgbClr val="1B2450"/>
                 </a:solidFill>
-                <a:latin typeface="Arial" pitchFamily="34" charset="0"/>
-                <a:ea typeface="Arial" pitchFamily="34" charset="-122"/>
-                <a:cs typeface="Arial" pitchFamily="34" charset="-120"/>
+                <a:latin typeface="Inter" pitchFamily="34" charset="0"/>
+                <a:ea typeface="Inter" pitchFamily="34" charset="-122"/>
+                <a:cs typeface="Inter" pitchFamily="34" charset="-120"/>
               </a:rPr>
               <a:t>Welcome reception</a:t>
             </a:r>
@@ -5417,9 +5417,9 @@
                 <a:solidFill>
                   <a:srgbClr val="262B3D"/>
                 </a:solidFill>
-                <a:latin typeface="Arial" pitchFamily="34" charset="0"/>
-                <a:ea typeface="Arial" pitchFamily="34" charset="-122"/>
-                <a:cs typeface="Arial" pitchFamily="34" charset="-120"/>
+                <a:latin typeface="Inter" pitchFamily="34" charset="0"/>
+                <a:ea typeface="Inter" pitchFamily="34" charset="-122"/>
+                <a:cs typeface="Inter" pitchFamily="34" charset="-120"/>
               </a:rPr>
               <a:t> on </a:t>
             </a:r>
@@ -5430,16 +5430,16 @@
               <a:buNone/>
             </a:pPr>
             <a:r>
-              <a:rPr lang="en-US" sz="760" b="1" dirty="0">
+              <a:rPr lang="en-US" sz="700" b="1" dirty="0">
                 <a:solidFill>
                   <a:srgbClr val="B8402F"/>
                 </a:solidFill>
                 <a:highlight>
                   <a:srgbClr val="FFF1EE"/>
                 </a:highlight>
-                <a:latin typeface="Arial" pitchFamily="34" charset="0"/>
-                <a:ea typeface="Arial" pitchFamily="34" charset="-122"/>
-                <a:cs typeface="Arial" pitchFamily="34" charset="-120"/>
+                <a:latin typeface="Manrope" pitchFamily="34" charset="0"/>
+                <a:ea typeface="Manrope" pitchFamily="34" charset="-122"/>
+                <a:cs typeface="Manrope" pitchFamily="34" charset="-120"/>
               </a:rPr>
               <a:t> Day 1 </a:t>
             </a:r>
@@ -5463,9 +5463,9 @@
                 <a:solidFill>
                   <a:srgbClr val="262B3D"/>
                 </a:solidFill>
-                <a:latin typeface="Arial" pitchFamily="34" charset="0"/>
-                <a:ea typeface="Arial" pitchFamily="34" charset="-122"/>
-                <a:cs typeface="Arial" pitchFamily="34" charset="-120"/>
+                <a:latin typeface="Inter" pitchFamily="34" charset="0"/>
+                <a:ea typeface="Inter" pitchFamily="34" charset="-122"/>
+                <a:cs typeface="Inter" pitchFamily="34" charset="-120"/>
               </a:rPr>
               <a:t>Welcome reception at the conference hotel on the first evening.</a:t>
             </a:r>
@@ -5483,9 +5483,9 @@
                 <a:solidFill>
                   <a:srgbClr val="1B2450"/>
                 </a:solidFill>
-                <a:latin typeface="Arial" pitchFamily="34" charset="0"/>
-                <a:ea typeface="Arial" pitchFamily="34" charset="-122"/>
-                <a:cs typeface="Arial" pitchFamily="34" charset="-120"/>
+                <a:latin typeface="Inter" pitchFamily="34" charset="0"/>
+                <a:ea typeface="Inter" pitchFamily="34" charset="-122"/>
+                <a:cs typeface="Inter" pitchFamily="34" charset="-120"/>
               </a:rPr>
               <a:t>Conference dinner</a:t>
             </a:r>
@@ -5500,9 +5500,9 @@
                 <a:solidFill>
                   <a:srgbClr val="262B3D"/>
                 </a:solidFill>
-                <a:latin typeface="Arial" pitchFamily="34" charset="0"/>
-                <a:ea typeface="Arial" pitchFamily="34" charset="-122"/>
-                <a:cs typeface="Arial" pitchFamily="34" charset="-120"/>
+                <a:latin typeface="Inter" pitchFamily="34" charset="0"/>
+                <a:ea typeface="Inter" pitchFamily="34" charset="-122"/>
+                <a:cs typeface="Inter" pitchFamily="34" charset="-120"/>
               </a:rPr>
               <a:t> on </a:t>
             </a:r>
@@ -5513,16 +5513,16 @@
               <a:buNone/>
             </a:pPr>
             <a:r>
-              <a:rPr lang="en-US" sz="760" b="1" dirty="0">
+              <a:rPr lang="en-US" sz="700" b="1" dirty="0">
                 <a:solidFill>
                   <a:srgbClr val="B8402F"/>
                 </a:solidFill>
                 <a:highlight>
                   <a:srgbClr val="FFF1EE"/>
                 </a:highlight>
-                <a:latin typeface="Arial" pitchFamily="34" charset="0"/>
-                <a:ea typeface="Arial" pitchFamily="34" charset="-122"/>
-                <a:cs typeface="Arial" pitchFamily="34" charset="-120"/>
+                <a:latin typeface="Manrope" pitchFamily="34" charset="0"/>
+                <a:ea typeface="Manrope" pitchFamily="34" charset="-122"/>
+                <a:cs typeface="Manrope" pitchFamily="34" charset="-120"/>
               </a:rPr>
               <a:t> Day 3 </a:t>
             </a:r>
@@ -5546,9 +5546,9 @@
                 <a:solidFill>
                   <a:srgbClr val="262B3D"/>
                 </a:solidFill>
-                <a:latin typeface="Arial" pitchFamily="34" charset="0"/>
-                <a:ea typeface="Arial" pitchFamily="34" charset="-122"/>
-                <a:cs typeface="Arial" pitchFamily="34" charset="-120"/>
+                <a:latin typeface="Inter" pitchFamily="34" charset="0"/>
+                <a:ea typeface="Inter" pitchFamily="34" charset="-122"/>
+                <a:cs typeface="Inter" pitchFamily="34" charset="-120"/>
               </a:rPr>
               <a:t>Korean banquet in the city centre with a traditional performance.</a:t>
             </a:r>
@@ -5566,9 +5566,9 @@
                 <a:solidFill>
                   <a:srgbClr val="1B2450"/>
                 </a:solidFill>
-                <a:latin typeface="Arial" pitchFamily="34" charset="0"/>
-                <a:ea typeface="Arial" pitchFamily="34" charset="-122"/>
-                <a:cs typeface="Arial" pitchFamily="34" charset="-120"/>
+                <a:latin typeface="Inter" pitchFamily="34" charset="0"/>
+                <a:ea typeface="Inter" pitchFamily="34" charset="-122"/>
+                <a:cs typeface="Inter" pitchFamily="34" charset="-120"/>
               </a:rPr>
               <a:t>Cultural afternoon</a:t>
             </a:r>
@@ -5583,9 +5583,9 @@
                 <a:solidFill>
                   <a:srgbClr val="262B3D"/>
                 </a:solidFill>
-                <a:latin typeface="Arial" pitchFamily="34" charset="0"/>
-                <a:ea typeface="Arial" pitchFamily="34" charset="-122"/>
-                <a:cs typeface="Arial" pitchFamily="34" charset="-120"/>
+                <a:latin typeface="Inter" pitchFamily="34" charset="0"/>
+                <a:ea typeface="Inter" pitchFamily="34" charset="-122"/>
+                <a:cs typeface="Inter" pitchFamily="34" charset="-120"/>
               </a:rPr>
               <a:t> on </a:t>
             </a:r>
@@ -5596,16 +5596,16 @@
               <a:buNone/>
             </a:pPr>
             <a:r>
-              <a:rPr lang="en-US" sz="760" b="1" dirty="0">
+              <a:rPr lang="en-US" sz="700" b="1" dirty="0">
                 <a:solidFill>
                   <a:srgbClr val="B8402F"/>
                 </a:solidFill>
                 <a:highlight>
                   <a:srgbClr val="FFF1EE"/>
                 </a:highlight>
-                <a:latin typeface="Arial" pitchFamily="34" charset="0"/>
-                <a:ea typeface="Arial" pitchFamily="34" charset="-122"/>
-                <a:cs typeface="Arial" pitchFamily="34" charset="-120"/>
+                <a:latin typeface="Manrope" pitchFamily="34" charset="0"/>
+                <a:ea typeface="Manrope" pitchFamily="34" charset="-122"/>
+                <a:cs typeface="Manrope" pitchFamily="34" charset="-120"/>
               </a:rPr>
               <a:t> Day 4 </a:t>
             </a:r>
@@ -5629,9 +5629,9 @@
                 <a:solidFill>
                   <a:srgbClr val="262B3D"/>
                 </a:solidFill>
-                <a:latin typeface="Arial" pitchFamily="34" charset="0"/>
-                <a:ea typeface="Arial" pitchFamily="34" charset="-122"/>
-                <a:cs typeface="Arial" pitchFamily="34" charset="-120"/>
+                <a:latin typeface="Inter" pitchFamily="34" charset="0"/>
+                <a:ea typeface="Inter" pitchFamily="34" charset="-122"/>
+                <a:cs typeface="Inter" pitchFamily="34" charset="-120"/>
               </a:rPr>
               <a:t>Gyeongbokgung Palace and Bukchon Hanok Village, or a Han River evening cruise.</a:t>
             </a:r>
@@ -5668,9 +5668,9 @@
                 <a:solidFill>
                   <a:srgbClr val="D8432F"/>
                 </a:solidFill>
-                <a:latin typeface="Arial" pitchFamily="34" charset="0"/>
-                <a:ea typeface="Arial" pitchFamily="34" charset="-122"/>
-                <a:cs typeface="Arial" pitchFamily="34" charset="-120"/>
+                <a:latin typeface="Manrope" pitchFamily="34" charset="0"/>
+                <a:ea typeface="Manrope" pitchFamily="34" charset="-122"/>
+                <a:cs typeface="Manrope" pitchFamily="34" charset="-120"/>
               </a:rPr>
               <a:t>Topics</a:t>
             </a:r>
@@ -5687,7 +5687,7 @@
         <p:spPr>
           <a:xfrm>
             <a:off x="3913632" y="8257032"/>
-            <a:ext cx="3218688" cy="914400"/>
+            <a:ext cx="3218688" cy="950976"/>
           </a:xfrm>
           <a:prstGeom prst="rect">
             <a:avLst/>
@@ -5710,9 +5710,9 @@
                 <a:solidFill>
                   <a:srgbClr val="262B3D"/>
                 </a:solidFill>
-                <a:latin typeface="Arial" pitchFamily="34" charset="0"/>
-                <a:ea typeface="Arial" pitchFamily="34" charset="-122"/>
-                <a:cs typeface="Arial" pitchFamily="34" charset="-120"/>
+                <a:latin typeface="Inter" pitchFamily="34" charset="0"/>
+                <a:ea typeface="Inter" pitchFamily="34" charset="-122"/>
+                <a:cs typeface="Inter" pitchFamily="34" charset="-120"/>
               </a:rPr>
               <a:t>· Synthesis, alignment and processing of LCEs</a:t>
             </a:r>
@@ -5730,9 +5730,9 @@
                 <a:solidFill>
                   <a:srgbClr val="262B3D"/>
                 </a:solidFill>
-                <a:latin typeface="Arial" pitchFamily="34" charset="0"/>
-                <a:ea typeface="Arial" pitchFamily="34" charset="-122"/>
-                <a:cs typeface="Arial" pitchFamily="34" charset="-120"/>
+                <a:latin typeface="Inter" pitchFamily="34" charset="0"/>
+                <a:ea typeface="Inter" pitchFamily="34" charset="-122"/>
+                <a:cs typeface="Inter" pitchFamily="34" charset="-120"/>
               </a:rPr>
               <a:t>· Photo-, thermo-, electro- and magneto-actuation</a:t>
             </a:r>
@@ -5750,9 +5750,9 @@
                 <a:solidFill>
                   <a:srgbClr val="262B3D"/>
                 </a:solidFill>
-                <a:latin typeface="Arial" pitchFamily="34" charset="0"/>
-                <a:ea typeface="Arial" pitchFamily="34" charset="-122"/>
-                <a:cs typeface="Arial" pitchFamily="34" charset="-120"/>
+                <a:latin typeface="Inter" pitchFamily="34" charset="0"/>
+                <a:ea typeface="Inter" pitchFamily="34" charset="-122"/>
+                <a:cs typeface="Inter" pitchFamily="34" charset="-120"/>
               </a:rPr>
               <a:t>· Soft mechanics, instabilities, defects and topology</a:t>
             </a:r>
@@ -5770,9 +5770,9 @@
                 <a:solidFill>
                   <a:srgbClr val="262B3D"/>
                 </a:solidFill>
-                <a:latin typeface="Arial" pitchFamily="34" charset="0"/>
-                <a:ea typeface="Arial" pitchFamily="34" charset="-122"/>
-                <a:cs typeface="Arial" pitchFamily="34" charset="-120"/>
+                <a:latin typeface="Inter" pitchFamily="34" charset="0"/>
+                <a:ea typeface="Inter" pitchFamily="34" charset="-122"/>
+                <a:cs typeface="Inter" pitchFamily="34" charset="-120"/>
               </a:rPr>
               <a:t>· 4D printing and microfabrication</a:t>
             </a:r>
@@ -5790,9 +5790,9 @@
                 <a:solidFill>
                   <a:srgbClr val="262B3D"/>
                 </a:solidFill>
-                <a:latin typeface="Arial" pitchFamily="34" charset="0"/>
-                <a:ea typeface="Arial" pitchFamily="34" charset="-122"/>
-                <a:cs typeface="Arial" pitchFamily="34" charset="-120"/>
+                <a:latin typeface="Inter" pitchFamily="34" charset="0"/>
+                <a:ea typeface="Inter" pitchFamily="34" charset="-122"/>
+                <a:cs typeface="Inter" pitchFamily="34" charset="-120"/>
               </a:rPr>
               <a:t>· Feedback-driven and autonomous motion; soft robotics</a:t>
             </a:r>
@@ -5810,9 +5810,9 @@
                 <a:solidFill>
                   <a:srgbClr val="262B3D"/>
                 </a:solidFill>
-                <a:latin typeface="Arial" pitchFamily="34" charset="0"/>
-                <a:ea typeface="Arial" pitchFamily="34" charset="-122"/>
-                <a:cs typeface="Arial" pitchFamily="34" charset="-120"/>
+                <a:latin typeface="Inter" pitchFamily="34" charset="0"/>
+                <a:ea typeface="Inter" pitchFamily="34" charset="-122"/>
+                <a:cs typeface="Inter" pitchFamily="34" charset="-120"/>
               </a:rPr>
               <a:t>· Tunable photonics, stretchable and wearable devices</a:t>
             </a:r>
@@ -5830,9 +5830,9 @@
                 <a:solidFill>
                   <a:srgbClr val="262B3D"/>
                 </a:solidFill>
-                <a:latin typeface="Arial" pitchFamily="34" charset="0"/>
-                <a:ea typeface="Arial" pitchFamily="34" charset="-122"/>
-                <a:cs typeface="Arial" pitchFamily="34" charset="-120"/>
+                <a:latin typeface="Inter" pitchFamily="34" charset="0"/>
+                <a:ea typeface="Inter" pitchFamily="34" charset="-122"/>
+                <a:cs typeface="Inter" pitchFamily="34" charset="-120"/>
               </a:rPr>
               <a:t>· Theory, modelling and data-driven design</a:t>
             </a:r>
@@ -5919,9 +5919,9 @@
                 <a:solidFill>
                   <a:srgbClr val="5B6079"/>
                 </a:solidFill>
-                <a:latin typeface="Arial" pitchFamily="34" charset="0"/>
-                <a:ea typeface="Arial" pitchFamily="34" charset="-122"/>
-                <a:cs typeface="Arial" pitchFamily="34" charset="-120"/>
+                <a:latin typeface="Inter" pitchFamily="34" charset="0"/>
+                <a:ea typeface="Inter" pitchFamily="34" charset="-122"/>
+                <a:cs typeface="Inter" pitchFamily="34" charset="-120"/>
               </a:rPr>
               <a:t>Host institution logo</a:t>
             </a:r>
@@ -5985,9 +5985,9 @@
                 <a:solidFill>
                   <a:srgbClr val="5B6079"/>
                 </a:solidFill>
-                <a:latin typeface="Arial" pitchFamily="34" charset="0"/>
-                <a:ea typeface="Arial" pitchFamily="34" charset="-122"/>
-                <a:cs typeface="Arial" pitchFamily="34" charset="-120"/>
+                <a:latin typeface="Inter" pitchFamily="34" charset="0"/>
+                <a:ea typeface="Inter" pitchFamily="34" charset="-122"/>
+                <a:cs typeface="Inter" pitchFamily="34" charset="-120"/>
               </a:rPr>
               <a:t>Society / sponsor logo</a:t>
             </a:r>
@@ -6051,9 +6051,9 @@
                 <a:solidFill>
                   <a:srgbClr val="5B6079"/>
                 </a:solidFill>
-                <a:latin typeface="Arial" pitchFamily="34" charset="0"/>
-                <a:ea typeface="Arial" pitchFamily="34" charset="-122"/>
-                <a:cs typeface="Arial" pitchFamily="34" charset="-120"/>
+                <a:latin typeface="Inter" pitchFamily="34" charset="0"/>
+                <a:ea typeface="Inter" pitchFamily="34" charset="-122"/>
+                <a:cs typeface="Inter" pitchFamily="34" charset="-120"/>
               </a:rPr>
               <a:t>Seoul CVB / KTO logo</a:t>
             </a:r>
@@ -6090,9 +6090,9 @@
                 <a:solidFill>
                   <a:srgbClr val="2C3A7A"/>
                 </a:solidFill>
-                <a:latin typeface="Arial" pitchFamily="34" charset="0"/>
-                <a:ea typeface="Arial" pitchFamily="34" charset="-122"/>
-                <a:cs typeface="Arial" pitchFamily="34" charset="-120"/>
+                <a:latin typeface="Inter" pitchFamily="34" charset="0"/>
+                <a:ea typeface="Inter" pitchFamily="34" charset="-122"/>
+                <a:cs typeface="Inter" pitchFamily="34" charset="-120"/>
               </a:rPr>
               <a:t>Photos: </a:t>
             </a:r>
@@ -6104,9 +6104,9 @@
                 <a:solidFill>
                   <a:srgbClr val="5B6079"/>
                 </a:solidFill>
-                <a:latin typeface="Arial" pitchFamily="34" charset="0"/>
-                <a:ea typeface="Arial" pitchFamily="34" charset="-122"/>
-                <a:cs typeface="Arial" pitchFamily="34" charset="-120"/>
+                <a:latin typeface="Inter" pitchFamily="34" charset="0"/>
+                <a:ea typeface="Inter" pitchFamily="34" charset="-122"/>
+                <a:cs typeface="Inter" pitchFamily="34" charset="-120"/>
               </a:rPr>
               <a:t>© Korea Tourism Organization (Photo Korea) – 조한섭, 한국관광공사 카멜프레스, 안형록, 임귀빈, 임태원, 이재국, IR 스튜디오. KOGL Type 1.</a:t>
             </a:r>
@@ -6121,11 +6121,11 @@
                 <a:solidFill>
                   <a:srgbClr val="5B6079"/>
                 </a:solidFill>
-                <a:latin typeface="Arial" pitchFamily="34" charset="0"/>
-                <a:ea typeface="Arial" pitchFamily="34" charset="-122"/>
-                <a:cs typeface="Arial" pitchFamily="34" charset="-120"/>
-              </a:rPr>
-              <a:t>Typefaces: Arial. Replace the low-resolution preview photos with the original downloads before printing.</a:t>
+                <a:latin typeface="Inter" pitchFamily="34" charset="0"/>
+                <a:ea typeface="Inter" pitchFamily="34" charset="-122"/>
+                <a:cs typeface="Inter" pitchFamily="34" charset="-120"/>
+              </a:rPr>
+              <a:t>Typefaces: Manrope and Inter (SIL Open Font License).</a:t>
             </a:r>
             <a:endParaRPr lang="en-US" sz="610" dirty="0"/>
           </a:p>

</xml_diff>